<commit_message>
Remove TA2 mentions, proofread text, cite verified web sources
Co-Authored-By: Claude Opus 5.5 <noreply@anthropic.com>
Claude-Session: https://claude.ai/code/session_01A3dr5uNJtqowxFZtjwACBv
</commit_message>
<xml_diff>
--- a/domkratas-ta1/domkratas-ta1.pptx
+++ b/domkratas-ta1/domkratas-ta1.pptx
@@ -14,6 +14,7 @@
     <p:sldId id="262" r:id="rId14"/>
     <p:sldId id="263" r:id="rId15"/>
     <p:sldId id="264" r:id="rId16"/>
+    <p:sldId id="265" r:id="rId17"/>
   </p:sldIdLst>
   <p:sldSz cx="12191695" cy="6858000" type="screen4x3"/>
   <p:notesSz cx="6858000" cy="9144000"/>
@@ -510,7 +511,7 @@
           <a:lstStyle/>
           <a:p>
             <a:r>
-              <a:t>Laba diena. Mūsų tema – domkratas. Parodysime, kaip domkratai vystėsi, kokias problemas jie turi šiandien ir kaip siūlome patobulinti automobilio žirklinį domkratą.</a:t>
+              <a:t>Laba diena. Mūsų tema – domkratas. Parodysime, kaip domkratai vystėsi, kokių problemų jie turi šiandien ir kaip siūlome patobulinti automobilio žirklinį domkratą.</a:t>
             </a:r>
           </a:p>
         </p:txBody>
@@ -580,7 +581,7 @@
           <a:lstStyle/>
           <a:p>
             <a:r>
-              <a:t>Domkratą turi beveik kiekvienas automobilis, o jame susitinka pavaros, medžiagos, sauga ir ergonomika.</a:t>
+              <a:t>Žirklinį domkratą gamintojai deda į naujus automobilius, todėl su juo susiduria beveik kiekvienas vairuotojas. Domkratas veikia pagal sverto arba Paskalio dėsnį: nedidele jėga pakeliamas didelis krovinys.</a:t>
             </a:r>
           </a:p>
         </p:txBody>
@@ -650,7 +651,7 @@
           <a:lstStyle/>
           <a:p>
             <a:r>
-              <a:t>Raida: nuo sverto ir sraigto per hidrauliką iki elektrinių domkratų. Pagrindinė tendencija – nuo jėgos laimėjimo link greičio, saugos ir patogumo.</a:t>
+              <a:t>Raida: nuo Archimedo sverto ir antikinių sraigtinių presų per Bramah ir Dudgeon hidrauliką iki žirklinių ir elektrinių domkratų. Tendencija – nuo jėgos laimėjimo link greičio, saugos ir patogumo.</a:t>
             </a:r>
           </a:p>
         </p:txBody>
@@ -720,7 +721,7 @@
           <a:lstStyle/>
           <a:p>
             <a:r>
-              <a:t>Palyginome penkis pagrindinius tipus. Pasiteisino savistabdis sriegis ir hidraulika, o silpnybės – lėtumas, nestabilumas ir sauga. Gilinsimės į žirklinį, nes jis yra kiekvieno automobilio komplekte.</a:t>
+              <a:t>Palyginome penkis pagrindinius tipus. Pasiteisino savistabdis sraigtas ir hidraulika, o silpnybės – lėtumas, nestabilumas ir sauga. Gilinsimės į žirklinį, nes jis yra automobilio komplekte.</a:t>
             </a:r>
           </a:p>
         </p:txBody>
@@ -790,7 +791,7 @@
           <a:lstStyle/>
           <a:p>
             <a:r>
-              <a:t>Žirklinis domkratas lėtas ir sunkiai sukamas, ypač pradžioje, nes jėga sraigte F = Q / tg θ. Todėl formuluojame uždavinį – greitesnis, lengviau valdomas ir stabilesnis domkratas.</a:t>
+              <a:t>Žirklinis domkratas lėtas ir sunkiai sukamas, ypač pradžioje. Jėga sraigte F = Q / tg θ, todėl žemoje padėtyje ji kelis kartus didesnė už krovinį. Todėl formuluojame uždavinį.</a:t>
             </a:r>
           </a:p>
         </p:txBody>
@@ -930,7 +931,7 @@
           <a:lstStyle/>
           <a:p>
             <a:r>
-              <a:t>Laimime greitį, jėgą ir stabilumą. Kompromisai – didesnė masė ir kaina. Preliminariai variklio galia apie 100 W, todėl užtenka automobilio 12 V lizdo.</a:t>
+              <a:t>Laimime greitį, jėgą ir stabilumą. Kompromisai – didesnė masė ir kaina. Pagal mūsų skaičiavimą variklio galia apie 100 W, todėl užtenka automobilio 12 V lizdo.</a:t>
             </a:r>
           </a:p>
         </p:txBody>
@@ -1000,7 +1001,7 @@
           <a:lstStyle/>
           <a:p>
             <a:r>
-              <a:t>Apibendrinant: žirklinį domkratą siūlome elektrifikuoti ir sustiprinti. TA2 etape atliksime skaičiavimus, patentų analizę ir įvertinsime atitiktį standartams. Ačiū, laukiame klausimų.</a:t>
+              <a:t>Apibendrinant: domkratai vystėsi nuo jėgos laimėjimo iki saugos ir patogumo. Žirklinį domkratą siūlome elektrifikuoti ir sustiprinti. Ačiū, laukiame klausimų.</a:t>
             </a:r>
           </a:p>
         </p:txBody>
@@ -4207,7 +4208,7 @@
 </p:sld>
 </file>
 
-<file path=ppt/slides/slide2.xml><?xml version="1.0" encoding="utf-8"?>
+<file path=ppt/slides/slide10.xml><?xml version="1.0" encoding="utf-8"?>
 <p:sld xmlns:a="http://schemas.openxmlformats.org/drawingml/2006/main" xmlns:p="http://schemas.openxmlformats.org/presentationml/2006/main" xmlns:r="http://schemas.openxmlformats.org/officeDocument/2006/relationships">
   <p:cSld>
     <p:spTree>
@@ -4251,7 +4252,7 @@
                 </a:solidFill>
                 <a:latin typeface="Calibri"/>
               </a:rPr>
-              <a:t>Kodėl pasirinkome domkratą?</a:t>
+              <a:t>Šaltiniai (2/2)</a:t>
             </a:r>
           </a:p>
         </p:txBody>
@@ -4276,6 +4277,7 @@
           <a:ln>
             <a:noFill/>
           </a:ln>
+          <a:effectLst/>
         </p:spPr>
         <p:style>
           <a:lnRef idx="1">
@@ -4333,7 +4335,7 @@
                 </a:solidFill>
                 <a:latin typeface="Calibri"/>
               </a:rPr>
-              <a:t>2 / 9</a:t>
+              <a:t>10 / 10</a:t>
             </a:r>
           </a:p>
         </p:txBody>
@@ -4372,7 +4374,7 @@
                 </a:solidFill>
                 <a:latin typeface="Calibri"/>
               </a:rPr>
-              <a:t>PBL TA1 · Domkratas</a:t>
+              <a:t>PBL · Domkratas</a:t>
             </a:r>
           </a:p>
         </p:txBody>
@@ -4385,8 +4387,8 @@
         </p:nvSpPr>
         <p:spPr>
           <a:xfrm>
-            <a:off x="640080" y="1554480"/>
-            <a:ext cx="10972800" cy="4389120"/>
+            <a:off x="640080" y="1463040"/>
+            <a:ext cx="10881360" cy="4754880"/>
           </a:xfrm>
           <a:prstGeom prst="rect">
             <a:avLst/>
@@ -4401,11 +4403,553 @@
           <a:p>
             <a:pPr algn="l">
               <a:spcAft>
+                <a:spcPts val="700"/>
+              </a:spcAft>
+            </a:pPr>
+            <a:r>
+              <a:rPr sz="1400" b="0">
+                <a:solidFill>
+                  <a:srgbClr val="222222"/>
+                </a:solidFill>
+                <a:latin typeface="Calibri"/>
+              </a:rPr>
+              <a:t>Pro-Lift-Montagetechnik. (n.d.). </a:t>
+            </a:r>
+            <a:r>
+              <a:rPr sz="1400" b="0" i="1">
+                <a:solidFill>
+                  <a:srgbClr val="222222"/>
+                </a:solidFill>
+                <a:latin typeface="Calibri"/>
+              </a:rPr>
+              <a:t>12V electric scissor jack, car jack, 123 mm – 345 mm</a:t>
+            </a:r>
+            <a:r>
+              <a:rPr sz="1400" b="0" i="0">
+                <a:solidFill>
+                  <a:srgbClr val="222222"/>
+                </a:solidFill>
+                <a:latin typeface="Calibri"/>
+              </a:rPr>
+              <a:t>. https://www.pro-lift-montagetechnik.com/12-volt-electric-scissor-jack-car-jack-123mm-345mm-002</a:t>
+            </a:r>
+          </a:p>
+          <a:p>
+            <a:pPr>
+              <a:spcAft>
+                <a:spcPts val="700"/>
+              </a:spcAft>
+            </a:pPr>
+            <a:r>
+              <a:rPr sz="1400" b="0">
+                <a:solidFill>
+                  <a:srgbClr val="222222"/>
+                </a:solidFill>
+                <a:latin typeface="Calibri"/>
+              </a:rPr>
+              <a:t>Redline Stands. (n.d.). </a:t>
+            </a:r>
+            <a:r>
+              <a:rPr sz="1400" b="0" i="1">
+                <a:solidFill>
+                  <a:srgbClr val="222222"/>
+                </a:solidFill>
+                <a:latin typeface="Calibri"/>
+              </a:rPr>
+              <a:t>Bottle jack vs. floor jack: Differences, pros, and cons</a:t>
+            </a:r>
+            <a:r>
+              <a:rPr sz="1400" b="0" i="0">
+                <a:solidFill>
+                  <a:srgbClr val="222222"/>
+                </a:solidFill>
+                <a:latin typeface="Calibri"/>
+              </a:rPr>
+              <a:t>. https://www.redlinestands.com/blog/bottle-jack-vs-floor-jack/</a:t>
+            </a:r>
+          </a:p>
+          <a:p>
+            <a:pPr>
+              <a:spcAft>
+                <a:spcPts val="700"/>
+              </a:spcAft>
+            </a:pPr>
+            <a:r>
+              <a:rPr sz="1400" b="0">
+                <a:solidFill>
+                  <a:srgbClr val="222222"/>
+                </a:solidFill>
+                <a:latin typeface="Calibri"/>
+              </a:rPr>
+              <a:t>Rorres, C. (n.d.). </a:t>
+            </a:r>
+            <a:r>
+              <a:rPr sz="1400" b="0" i="1">
+                <a:solidFill>
+                  <a:srgbClr val="222222"/>
+                </a:solidFill>
+                <a:latin typeface="Calibri"/>
+              </a:rPr>
+              <a:t>Quotations about Archimedes' lever</a:t>
+            </a:r>
+            <a:r>
+              <a:rPr sz="1400" b="0" i="0">
+                <a:solidFill>
+                  <a:srgbClr val="222222"/>
+                </a:solidFill>
+                <a:latin typeface="Calibri"/>
+              </a:rPr>
+              <a:t>. New York University. https://math.nyu.edu/Archimedes/Lever/LeverQuotes.html</a:t>
+            </a:r>
+          </a:p>
+          <a:p>
+            <a:pPr>
+              <a:spcAft>
+                <a:spcPts val="700"/>
+              </a:spcAft>
+            </a:pPr>
+            <a:r>
+              <a:rPr sz="1400" b="0">
+                <a:solidFill>
+                  <a:srgbClr val="222222"/>
+                </a:solidFill>
+                <a:latin typeface="Calibri"/>
+              </a:rPr>
+              <a:t>Roton Products. (n.d.). </a:t>
+            </a:r>
+            <a:r>
+              <a:rPr sz="1400" b="0" i="1">
+                <a:solidFill>
+                  <a:srgbClr val="222222"/>
+                </a:solidFill>
+                <a:latin typeface="Calibri"/>
+              </a:rPr>
+              <a:t>Trapezoidal lead screws: General information</a:t>
+            </a:r>
+            <a:r>
+              <a:rPr sz="1400" b="0" i="0">
+                <a:solidFill>
+                  <a:srgbClr val="222222"/>
+                </a:solidFill>
+                <a:latin typeface="Calibri"/>
+              </a:rPr>
+              <a:t>. https://www.roton.com/products/trapezoidal-lead-screws-nuts/general-information/</a:t>
+            </a:r>
+          </a:p>
+          <a:p>
+            <a:pPr>
+              <a:spcAft>
+                <a:spcPts val="700"/>
+              </a:spcAft>
+            </a:pPr>
+            <a:r>
+              <a:rPr sz="1400" b="0">
+                <a:solidFill>
+                  <a:srgbClr val="222222"/>
+                </a:solidFill>
+                <a:latin typeface="Calibri"/>
+              </a:rPr>
+              <a:t>Sider Ticino. (n.d.). </a:t>
+            </a:r>
+            <a:r>
+              <a:rPr sz="1400" b="0" i="1">
+                <a:solidFill>
+                  <a:srgbClr val="222222"/>
+                </a:solidFill>
+                <a:latin typeface="Calibri"/>
+              </a:rPr>
+              <a:t>42CrMo4 technical specifications</a:t>
+            </a:r>
+            <a:r>
+              <a:rPr sz="1400" b="0" i="0">
+                <a:solidFill>
+                  <a:srgbClr val="222222"/>
+                </a:solidFill>
+                <a:latin typeface="Calibri"/>
+              </a:rPr>
+              <a:t>. https://siderticino.it/en/steel-datasheets/42crmo4/</a:t>
+            </a:r>
+          </a:p>
+          <a:p>
+            <a:pPr>
+              <a:spcAft>
+                <a:spcPts val="700"/>
+              </a:spcAft>
+            </a:pPr>
+            <a:r>
+              <a:rPr sz="1400" b="0">
+                <a:solidFill>
+                  <a:srgbClr val="222222"/>
+                </a:solidFill>
+                <a:latin typeface="Calibri"/>
+              </a:rPr>
+              <a:t>The World Material. (n.d.). </a:t>
+            </a:r>
+            <a:r>
+              <a:rPr sz="1400" b="0" i="1">
+                <a:solidFill>
+                  <a:srgbClr val="222222"/>
+                </a:solidFill>
+                <a:latin typeface="Calibri"/>
+              </a:rPr>
+              <a:t>EN 10025-2 S235 steel properties</a:t>
+            </a:r>
+            <a:r>
+              <a:rPr sz="1400" b="0" i="0">
+                <a:solidFill>
+                  <a:srgbClr val="222222"/>
+                </a:solidFill>
+                <a:latin typeface="Calibri"/>
+              </a:rPr>
+              <a:t>. https://www.theworldmaterial.com/en-10025-2-material-s235-steel/</a:t>
+            </a:r>
+          </a:p>
+          <a:p>
+            <a:pPr>
+              <a:spcAft>
+                <a:spcPts val="700"/>
+              </a:spcAft>
+            </a:pPr>
+            <a:r>
+              <a:rPr sz="1400" b="0">
+                <a:solidFill>
+                  <a:srgbClr val="222222"/>
+                </a:solidFill>
+                <a:latin typeface="Calibri"/>
+              </a:rPr>
+              <a:t>Wikipedia. (n.d.-a). </a:t>
+            </a:r>
+            <a:r>
+              <a:rPr sz="1400" b="0" i="1">
+                <a:solidFill>
+                  <a:srgbClr val="222222"/>
+                </a:solidFill>
+                <a:latin typeface="Calibri"/>
+              </a:rPr>
+              <a:t>Joseph Bramah</a:t>
+            </a:r>
+            <a:r>
+              <a:rPr sz="1400" b="0" i="0">
+                <a:solidFill>
+                  <a:srgbClr val="222222"/>
+                </a:solidFill>
+                <a:latin typeface="Calibri"/>
+              </a:rPr>
+              <a:t>. https://en.wikipedia.org/wiki/Joseph_Bramah</a:t>
+            </a:r>
+          </a:p>
+          <a:p>
+            <a:pPr>
+              <a:spcAft>
+                <a:spcPts val="700"/>
+              </a:spcAft>
+            </a:pPr>
+            <a:r>
+              <a:rPr sz="1400" b="0">
+                <a:solidFill>
+                  <a:srgbClr val="222222"/>
+                </a:solidFill>
+                <a:latin typeface="Calibri"/>
+              </a:rPr>
+              <a:t>Wikipedia. (n.d.-b). </a:t>
+            </a:r>
+            <a:r>
+              <a:rPr sz="1400" b="0" i="1">
+                <a:solidFill>
+                  <a:srgbClr val="222222"/>
+                </a:solidFill>
+                <a:latin typeface="Calibri"/>
+              </a:rPr>
+              <a:t>Richard Dudgeon</a:t>
+            </a:r>
+            <a:r>
+              <a:rPr sz="1400" b="0" i="0">
+                <a:solidFill>
+                  <a:srgbClr val="222222"/>
+                </a:solidFill>
+                <a:latin typeface="Calibri"/>
+              </a:rPr>
+              <a:t>. https://en.wikipedia.org/wiki/Richard_Dudgeon</a:t>
+            </a:r>
+          </a:p>
+          <a:p>
+            <a:pPr>
+              <a:spcAft>
+                <a:spcPts val="700"/>
+              </a:spcAft>
+            </a:pPr>
+            <a:r>
+              <a:rPr sz="1400" b="0">
+                <a:solidFill>
+                  <a:srgbClr val="222222"/>
+                </a:solidFill>
+                <a:latin typeface="Calibri"/>
+              </a:rPr>
+              <a:t>Wikipedia. (n.d.-c). </a:t>
+            </a:r>
+            <a:r>
+              <a:rPr sz="1400" b="0" i="1">
+                <a:solidFill>
+                  <a:srgbClr val="222222"/>
+                </a:solidFill>
+                <a:latin typeface="Calibri"/>
+              </a:rPr>
+              <a:t>Jack (device)</a:t>
+            </a:r>
+            <a:r>
+              <a:rPr sz="1400" b="0" i="0">
+                <a:solidFill>
+                  <a:srgbClr val="222222"/>
+                </a:solidFill>
+                <a:latin typeface="Calibri"/>
+              </a:rPr>
+              <a:t>. https://en.wikipedia.org/wiki/Jack_(device)</a:t>
+            </a:r>
+          </a:p>
+          <a:p>
+            <a:pPr>
+              <a:spcAft>
+                <a:spcPts val="700"/>
+              </a:spcAft>
+            </a:pPr>
+            <a:r>
+              <a:rPr sz="1400" b="0">
+                <a:solidFill>
+                  <a:srgbClr val="222222"/>
+                </a:solidFill>
+                <a:latin typeface="Calibri"/>
+              </a:rPr>
+              <a:t>Wikipedia. (n.d.-d). </a:t>
+            </a:r>
+            <a:r>
+              <a:rPr sz="1400" b="0" i="1">
+                <a:solidFill>
+                  <a:srgbClr val="222222"/>
+                </a:solidFill>
+                <a:latin typeface="Calibri"/>
+              </a:rPr>
+              <a:t>Jackscrew</a:t>
+            </a:r>
+            <a:r>
+              <a:rPr sz="1400" b="0" i="0">
+                <a:solidFill>
+                  <a:srgbClr val="222222"/>
+                </a:solidFill>
+                <a:latin typeface="Calibri"/>
+              </a:rPr>
+              <a:t>. https://en.wikipedia.org/wiki/Jackscrew</a:t>
+            </a:r>
+          </a:p>
+        </p:txBody>
+      </p:sp>
+    </p:spTree>
+  </p:cSld>
+  <p:clrMapOvr>
+    <a:masterClrMapping/>
+  </p:clrMapOvr>
+</p:sld>
+</file>
+
+<file path=ppt/slides/slide2.xml><?xml version="1.0" encoding="utf-8"?>
+<p:sld xmlns:a="http://schemas.openxmlformats.org/drawingml/2006/main" xmlns:p="http://schemas.openxmlformats.org/presentationml/2006/main" xmlns:r="http://schemas.openxmlformats.org/officeDocument/2006/relationships">
+  <p:cSld>
+    <p:spTree>
+      <p:nvGrpSpPr>
+        <p:cNvPr id="1" name=""/>
+        <p:cNvGrpSpPr/>
+        <p:nvPr/>
+      </p:nvGrpSpPr>
+      <p:grpSpPr/>
+      <p:sp>
+        <p:nvSpPr>
+          <p:cNvPr id="2" name="TextBox 1"/>
+          <p:cNvSpPr txBox="1"/>
+          <p:nvPr/>
+        </p:nvSpPr>
+        <p:spPr>
+          <a:xfrm>
+            <a:off x="548640" y="320040"/>
+            <a:ext cx="11064240" cy="822960"/>
+          </a:xfrm>
+          <a:prstGeom prst="rect">
+            <a:avLst/>
+          </a:prstGeom>
+          <a:noFill/>
+        </p:spPr>
+        <p:txBody>
+          <a:bodyPr wrap="square" anchor="b" lIns="45720" rIns="45720">
+            <a:spAutoFit/>
+          </a:bodyPr>
+          <a:lstStyle/>
+          <a:p>
+            <a:pPr algn="l">
+              <a:spcAft>
+                <a:spcPts val="600"/>
+              </a:spcAft>
+            </a:pPr>
+            <a:r>
+              <a:rPr sz="3200" b="1">
+                <a:solidFill>
+                  <a:srgbClr val="1F4E79"/>
+                </a:solidFill>
+                <a:latin typeface="Calibri"/>
+              </a:rPr>
+              <a:t>Kodėl pasirinkome domkratą?</a:t>
+            </a:r>
+          </a:p>
+        </p:txBody>
+      </p:sp>
+      <p:sp>
+        <p:nvSpPr>
+          <p:cNvPr id="3" name="Rectangle 2"/>
+          <p:cNvSpPr/>
+          <p:nvPr/>
+        </p:nvSpPr>
+        <p:spPr>
+          <a:xfrm>
+            <a:off x="594360" y="1207008"/>
+            <a:ext cx="10972800" cy="27432"/>
+          </a:xfrm>
+          <a:prstGeom prst="rect">
+            <a:avLst/>
+          </a:prstGeom>
+          <a:solidFill>
+            <a:srgbClr val="1F4E79"/>
+          </a:solidFill>
+          <a:ln>
+            <a:noFill/>
+          </a:ln>
+          <a:effectLst/>
+        </p:spPr>
+        <p:style>
+          <a:lnRef idx="1">
+            <a:schemeClr val="accent1"/>
+          </a:lnRef>
+          <a:fillRef idx="3">
+            <a:schemeClr val="accent1"/>
+          </a:fillRef>
+          <a:effectRef idx="2">
+            <a:schemeClr val="accent1"/>
+          </a:effectRef>
+          <a:fontRef idx="minor">
+            <a:schemeClr val="lt1"/>
+          </a:fontRef>
+        </p:style>
+        <p:txBody>
+          <a:bodyPr rtlCol="0" anchor="ctr"/>
+          <a:lstStyle/>
+          <a:p>
+            <a:pPr algn="ctr"/>
+          </a:p>
+        </p:txBody>
+      </p:sp>
+      <p:sp>
+        <p:nvSpPr>
+          <p:cNvPr id="4" name="TextBox 3"/>
+          <p:cNvSpPr txBox="1"/>
+          <p:nvPr/>
+        </p:nvSpPr>
+        <p:spPr>
+          <a:xfrm>
+            <a:off x="10698480" y="6355080"/>
+            <a:ext cx="1005840" cy="365760"/>
+          </a:xfrm>
+          <a:prstGeom prst="rect">
+            <a:avLst/>
+          </a:prstGeom>
+          <a:noFill/>
+        </p:spPr>
+        <p:txBody>
+          <a:bodyPr wrap="square" anchor="t" lIns="45720" rIns="45720">
+            <a:spAutoFit/>
+          </a:bodyPr>
+          <a:lstStyle/>
+          <a:p>
+            <a:pPr algn="r">
+              <a:spcAft>
+                <a:spcPts val="600"/>
+              </a:spcAft>
+            </a:pPr>
+            <a:r>
+              <a:rPr sz="1200" b="0">
+                <a:solidFill>
+                  <a:srgbClr val="595959"/>
+                </a:solidFill>
+                <a:latin typeface="Calibri"/>
+              </a:rPr>
+              <a:t>2 / 10</a:t>
+            </a:r>
+          </a:p>
+        </p:txBody>
+      </p:sp>
+      <p:sp>
+        <p:nvSpPr>
+          <p:cNvPr id="5" name="TextBox 4"/>
+          <p:cNvSpPr txBox="1"/>
+          <p:nvPr/>
+        </p:nvSpPr>
+        <p:spPr>
+          <a:xfrm>
+            <a:off x="548640" y="6355080"/>
+            <a:ext cx="7315200" cy="365760"/>
+          </a:xfrm>
+          <a:prstGeom prst="rect">
+            <a:avLst/>
+          </a:prstGeom>
+          <a:noFill/>
+        </p:spPr>
+        <p:txBody>
+          <a:bodyPr wrap="square" anchor="t" lIns="45720" rIns="45720">
+            <a:spAutoFit/>
+          </a:bodyPr>
+          <a:lstStyle/>
+          <a:p>
+            <a:pPr algn="l">
+              <a:spcAft>
+                <a:spcPts val="600"/>
+              </a:spcAft>
+            </a:pPr>
+            <a:r>
+              <a:rPr sz="1200" b="0">
+                <a:solidFill>
+                  <a:srgbClr val="595959"/>
+                </a:solidFill>
+                <a:latin typeface="Calibri"/>
+              </a:rPr>
+              <a:t>PBL · Domkratas</a:t>
+            </a:r>
+          </a:p>
+        </p:txBody>
+      </p:sp>
+      <p:sp>
+        <p:nvSpPr>
+          <p:cNvPr id="6" name="TextBox 5"/>
+          <p:cNvSpPr txBox="1"/>
+          <p:nvPr/>
+        </p:nvSpPr>
+        <p:spPr>
+          <a:xfrm>
+            <a:off x="640080" y="1554480"/>
+            <a:ext cx="10972800" cy="4206240"/>
+          </a:xfrm>
+          <a:prstGeom prst="rect">
+            <a:avLst/>
+          </a:prstGeom>
+          <a:noFill/>
+        </p:spPr>
+        <p:txBody>
+          <a:bodyPr wrap="square" anchor="t" lIns="45720" rIns="45720">
+            <a:spAutoFit/>
+          </a:bodyPr>
+          <a:lstStyle/>
+          <a:p>
+            <a:pPr algn="l">
+              <a:spcAft>
                 <a:spcPts val="1600"/>
               </a:spcAft>
             </a:pPr>
             <a:r>
-              <a:rPr sz="2200" b="1">
+              <a:rPr sz="2100" b="1">
                 <a:solidFill>
                   <a:srgbClr val="222222"/>
                 </a:solidFill>
@@ -4414,13 +4958,22 @@
               <a:t>• Kasdienis įrenginys</a:t>
             </a:r>
             <a:r>
-              <a:rPr sz="2200">
+              <a:rPr sz="2100" b="0" i="0">
                 <a:solidFill>
                   <a:srgbClr val="222222"/>
                 </a:solidFill>
                 <a:latin typeface="Calibri"/>
               </a:rPr>
-              <a:t> – domkratą turi beveik kiekvienas automobilis (ratų keitimas).</a:t>
+              <a:t> – žirklinį domkratą gamintojai dažnai deda į naujus automobilius.</a:t>
+            </a:r>
+            <a:r>
+              <a:rPr sz="1700" b="0" i="0">
+                <a:solidFill>
+                  <a:srgbClr val="595959"/>
+                </a:solidFill>
+                <a:latin typeface="Calibri"/>
+              </a:rPr>
+              <a:t> (CJ Pony Parts, n.d.)</a:t>
             </a:r>
           </a:p>
           <a:p>
@@ -4430,7 +4983,7 @@
               </a:spcAft>
             </a:pPr>
             <a:r>
-              <a:rPr sz="2200" b="1">
+              <a:rPr sz="2100" b="1">
                 <a:solidFill>
                   <a:srgbClr val="222222"/>
                 </a:solidFill>
@@ -4439,13 +4992,22 @@
               <a:t>• Platus taikymas</a:t>
             </a:r>
             <a:r>
-              <a:rPr sz="2200">
+              <a:rPr sz="2100" b="0" i="0">
                 <a:solidFill>
                   <a:srgbClr val="222222"/>
                 </a:solidFill>
                 <a:latin typeface="Calibri"/>
               </a:rPr>
-              <a:t> – autoservisai, statyba, geležinkelis, gelbėjimo tarnybos.</a:t>
+              <a:t> – automobilių remontas, ūkiai, statyba, geležinkelis.</a:t>
+            </a:r>
+            <a:r>
+              <a:rPr sz="1700" b="0" i="0">
+                <a:solidFill>
+                  <a:srgbClr val="595959"/>
+                </a:solidFill>
+                <a:latin typeface="Calibri"/>
+              </a:rPr>
+              <a:t> (Hi-Lift Jack Company, n.d.-a; Wikipedia, n.d.-b)</a:t>
             </a:r>
           </a:p>
           <a:p>
@@ -4455,7 +5017,7 @@
               </a:spcAft>
             </a:pPr>
             <a:r>
-              <a:rPr sz="2200" b="1">
+              <a:rPr sz="2100" b="1">
                 <a:solidFill>
                   <a:srgbClr val="222222"/>
                 </a:solidFill>
@@ -4464,7 +5026,7 @@
               <a:t>• Daug mechanikos vienoje vietoje</a:t>
             </a:r>
             <a:r>
-              <a:rPr sz="2200">
+              <a:rPr sz="2100" b="0" i="0">
                 <a:solidFill>
                   <a:srgbClr val="222222"/>
                 </a:solidFill>
@@ -4480,22 +5042,31 @@
               </a:spcAft>
             </a:pPr>
             <a:r>
-              <a:rPr sz="2200" b="1">
+              <a:rPr sz="2100" b="1">
                 <a:solidFill>
                   <a:srgbClr val="222222"/>
                 </a:solidFill>
                 <a:latin typeface="Calibri"/>
               </a:rPr>
-              <a:t>• Svarbi sauga</a:t>
-            </a:r>
-            <a:r>
-              <a:rPr sz="2200">
+              <a:t>• Mechaninis principas</a:t>
+            </a:r>
+            <a:r>
+              <a:rPr sz="2100" b="0" i="0">
                 <a:solidFill>
                   <a:srgbClr val="222222"/>
                 </a:solidFill>
                 <a:latin typeface="Calibri"/>
               </a:rPr>
-              <a:t> – domkratas laiko šimtus kilogramų šalia žmogaus; vienam automobilio kampui tenka apie 0,4–0,5 t.</a:t>
+              <a:t> – svertas ir sraigtas: maža jėga ilgu keliu pakelia didelį krovinį.</a:t>
+            </a:r>
+            <a:r>
+              <a:rPr sz="1700" b="0" i="0">
+                <a:solidFill>
+                  <a:srgbClr val="595959"/>
+                </a:solidFill>
+                <a:latin typeface="Calibri"/>
+              </a:rPr>
+              <a:t> (Rorres, n.d.)</a:t>
             </a:r>
           </a:p>
           <a:p>
@@ -4505,22 +5076,31 @@
               </a:spcAft>
             </a:pPr>
             <a:r>
-              <a:rPr sz="2200" b="1">
+              <a:rPr sz="2100" b="1">
                 <a:solidFill>
                   <a:srgbClr val="222222"/>
                 </a:solidFill>
                 <a:latin typeface="Calibri"/>
               </a:rPr>
-              <a:t>• Veikimo principas</a:t>
-            </a:r>
-            <a:r>
-              <a:rPr sz="2200">
+              <a:t>• Hidraulinis principas</a:t>
+            </a:r>
+            <a:r>
+              <a:rPr sz="2100" b="0" i="0">
                 <a:solidFill>
                   <a:srgbClr val="222222"/>
                 </a:solidFill>
                 <a:latin typeface="Calibri"/>
               </a:rPr>
-              <a:t> – nedidele jėga pakeliamas didelis krovinys: sraigtu (svertu) arba hidraulika (Paskalio dėsnis).</a:t>
+              <a:t> – Paskalio dėsnis: F₁ / A₁ = F₂ / A₂, todėl didesnis stūmoklis duoda didesnę jėgą.</a:t>
+            </a:r>
+            <a:r>
+              <a:rPr sz="1700" b="0" i="0">
+                <a:solidFill>
+                  <a:srgbClr val="595959"/>
+                </a:solidFill>
+                <a:latin typeface="Calibri"/>
+              </a:rPr>
+              <a:t> (LibreTexts, n.d.)</a:t>
             </a:r>
           </a:p>
         </p:txBody>
@@ -4602,6 +5182,7 @@
           <a:ln>
             <a:noFill/>
           </a:ln>
+          <a:effectLst/>
         </p:spPr>
         <p:style>
           <a:lnRef idx="1">
@@ -4659,7 +5240,7 @@
                 </a:solidFill>
                 <a:latin typeface="Calibri"/>
               </a:rPr>
-              <a:t>3 / 9</a:t>
+              <a:t>3 / 10</a:t>
             </a:r>
           </a:p>
         </p:txBody>
@@ -4698,7 +5279,7 @@
                 </a:solidFill>
                 <a:latin typeface="Calibri"/>
               </a:rPr>
-              <a:t>PBL TA1 · Domkratas</a:t>
+              <a:t>PBL · Domkratas</a:t>
             </a:r>
           </a:p>
         </p:txBody>
@@ -4712,8 +5293,8 @@
           <p:nvPr/>
         </p:nvGraphicFramePr>
         <p:xfrm>
-          <a:off x="640080" y="1554480"/>
-          <a:ext cx="10881360" cy="3968496"/>
+          <a:off x="640080" y="1463040"/>
+          <a:ext cx="10881360" cy="4279392"/>
         </p:xfrm>
         <a:graphic>
           <a:graphicData uri="http://schemas.openxmlformats.org/drawingml/2006/table">
@@ -4722,17 +5303,17 @@
                 <a:tableStyleId>{5C22544A-7EE6-4342-B048-85BDC9FD1C3A}</a:tableStyleId>
               </a:tblPr>
               <a:tblGrid>
-                <a:gridCol w="2377440"/>
-                <a:gridCol w="8503920"/>
+                <a:gridCol w="2011680"/>
+                <a:gridCol w="8869680"/>
               </a:tblGrid>
-              <a:tr h="566928">
+              <a:tr h="475488">
                 <a:tc>
                   <a:txBody>
                     <a:bodyPr/>
                     <a:lstStyle/>
                     <a:p>
                       <a:r>
-                        <a:rPr sz="1700" b="1">
+                        <a:rPr sz="1600" b="1" i="0">
                           <a:solidFill>
                             <a:srgbClr val="FFFFFF"/>
                           </a:solidFill>
@@ -4754,7 +5335,7 @@
                     <a:lstStyle/>
                     <a:p>
                       <a:r>
-                        <a:rPr sz="1700" b="1">
+                        <a:rPr sz="1600" b="1" i="0">
                           <a:solidFill>
                             <a:srgbClr val="FFFFFF"/>
                           </a:solidFill>
@@ -4771,14 +5352,14 @@
                   </a:tcPr>
                 </a:tc>
               </a:tr>
-              <a:tr h="566928">
+              <a:tr h="475488">
                 <a:tc>
                   <a:txBody>
                     <a:bodyPr/>
                     <a:lstStyle/>
                     <a:p>
                       <a:r>
-                        <a:rPr sz="1700" b="1">
+                        <a:rPr sz="1600" b="1" i="0">
                           <a:solidFill>
                             <a:srgbClr val="222222"/>
                           </a:solidFill>
@@ -4800,13 +5381,13 @@
                     <a:lstStyle/>
                     <a:p>
                       <a:r>
-                        <a:rPr sz="1700" b="0">
+                        <a:rPr sz="1600" b="0" i="0">
                           <a:solidFill>
                             <a:srgbClr val="222222"/>
                           </a:solidFill>
                           <a:latin typeface="Calibri"/>
                         </a:rPr>
-                        <a:t>Archimedas aprašo sverto principą – jėgos laimėjimo pagrindą</a:t>
+                        <a:t>Archimedas aiškina sverto principą („Duokite man atramos tašką…“)</a:t>
                       </a:r>
                     </a:p>
                   </a:txBody>
@@ -4817,20 +5398,20 @@
                   </a:tcPr>
                 </a:tc>
               </a:tr>
-              <a:tr h="566928">
+              <a:tr h="475488">
                 <a:tc>
                   <a:txBody>
                     <a:bodyPr/>
                     <a:lstStyle/>
                     <a:p>
                       <a:r>
-                        <a:rPr sz="1700" b="1">
+                        <a:rPr sz="1600" b="1" i="0">
                           <a:solidFill>
                             <a:srgbClr val="222222"/>
                           </a:solidFill>
                           <a:latin typeface="Calibri"/>
                         </a:rPr>
-                        <a:t>XV–XVI a.</a:t>
+                        <a:t>I a.</a:t>
                       </a:r>
                     </a:p>
                   </a:txBody>
@@ -4846,13 +5427,13 @@
                     <a:lstStyle/>
                     <a:p>
                       <a:r>
-                        <a:rPr sz="1700" b="0">
+                        <a:rPr sz="1600" b="0" i="0">
                           <a:solidFill>
                             <a:srgbClr val="222222"/>
                           </a:solidFill>
                           <a:latin typeface="Calibri"/>
                         </a:rPr>
-                        <a:t>Sraigtiniai kėlikliai (sraigtas su veržle), Leonardo da Vinci eskizai</a:t>
+                        <a:t>Graikai ir romėnai naudoja sraigtinius presus alyvuogėms ir vynuogėms spausti</a:t>
                       </a:r>
                     </a:p>
                   </a:txBody>
@@ -4863,14 +5444,14 @@
                   </a:tcPr>
                 </a:tc>
               </a:tr>
-              <a:tr h="566928">
+              <a:tr h="475488">
                 <a:tc>
                   <a:txBody>
                     <a:bodyPr/>
                     <a:lstStyle/>
                     <a:p>
                       <a:r>
-                        <a:rPr sz="1700" b="1">
+                        <a:rPr sz="1600" b="1" i="0">
                           <a:solidFill>
                             <a:srgbClr val="222222"/>
                           </a:solidFill>
@@ -4892,13 +5473,13 @@
                     <a:lstStyle/>
                     <a:p>
                       <a:r>
-                        <a:rPr sz="1700" b="0">
+                        <a:rPr sz="1600" b="0" i="0">
                           <a:solidFill>
                             <a:srgbClr val="222222"/>
                           </a:solidFill>
                           <a:latin typeface="Calibri"/>
                         </a:rPr>
-                        <a:t>J. Bramah patentuoja hidraulinį presą (Paskalio dėsnis)</a:t>
+                        <a:t>J. Bramah patentuoja hidraulinį presą, veikiantį pagal Paskalio dėsnį</a:t>
                       </a:r>
                     </a:p>
                   </a:txBody>
@@ -4909,14 +5490,14 @@
                   </a:tcPr>
                 </a:tc>
               </a:tr>
-              <a:tr h="566928">
+              <a:tr h="475488">
                 <a:tc>
                   <a:txBody>
                     <a:bodyPr/>
                     <a:lstStyle/>
                     <a:p>
                       <a:r>
-                        <a:rPr sz="1700" b="1">
+                        <a:rPr sz="1600" b="1" i="0">
                           <a:solidFill>
                             <a:srgbClr val="222222"/>
                           </a:solidFill>
@@ -4938,13 +5519,13 @@
                     <a:lstStyle/>
                     <a:p>
                       <a:r>
-                        <a:rPr sz="1700" b="0">
+                        <a:rPr sz="1600" b="0" i="0">
                           <a:solidFill>
                             <a:srgbClr val="222222"/>
                           </a:solidFill>
                           <a:latin typeface="Calibri"/>
                         </a:rPr>
-                        <a:t>R. Dudgeon – nešiojamas hidraulinis domkratas</a:t>
+                        <a:t>R. Dudgeon patentuoja nešiojamą hidraulinį domkratą</a:t>
                       </a:r>
                     </a:p>
                   </a:txBody>
@@ -4955,20 +5536,20 @@
                   </a:tcPr>
                 </a:tc>
               </a:tr>
-              <a:tr h="566928">
+              <a:tr h="475488">
                 <a:tc>
                   <a:txBody>
                     <a:bodyPr/>
                     <a:lstStyle/>
                     <a:p>
                       <a:r>
-                        <a:rPr sz="1700" b="1">
+                        <a:rPr sz="1600" b="1" i="0">
                           <a:solidFill>
                             <a:srgbClr val="222222"/>
                           </a:solidFill>
                           <a:latin typeface="Calibri"/>
                         </a:rPr>
-                        <a:t>XX a.</a:t>
+                        <a:t>1905 m.</a:t>
                       </a:r>
                     </a:p>
                   </a:txBody>
@@ -4984,13 +5565,13 @@
                     <a:lstStyle/>
                     <a:p>
                       <a:r>
-                        <a:rPr sz="1700" b="0">
+                        <a:rPr sz="1600" b="0" i="0">
                           <a:solidFill>
                             <a:srgbClr val="222222"/>
                           </a:solidFill>
                           <a:latin typeface="Calibri"/>
                         </a:rPr>
-                        <a:t>„Hi-Lift“ krumpliastiebinis (1905 m.), žirklinis – automobilio komplekte, vežimėliniai – servisuose</a:t>
+                        <a:t>P. J. Harrah patentuoja krumpliastiebinį „Hi-Lift“ domkratą</a:t>
                       </a:r>
                     </a:p>
                   </a:txBody>
@@ -5001,20 +5582,20 @@
                   </a:tcPr>
                 </a:tc>
               </a:tr>
-              <a:tr h="566928">
+              <a:tr h="475488">
                 <a:tc>
                   <a:txBody>
                     <a:bodyPr/>
                     <a:lstStyle/>
                     <a:p>
                       <a:r>
-                        <a:rPr sz="1700" b="1">
+                        <a:rPr sz="1600" b="1" i="0">
                           <a:solidFill>
                             <a:srgbClr val="222222"/>
                           </a:solidFill>
                           <a:latin typeface="Calibri"/>
                         </a:rPr>
-                        <a:t>XXI a.</a:t>
+                        <a:t>1920 m.</a:t>
                       </a:r>
                     </a:p>
                   </a:txBody>
@@ -5030,13 +5611,105 @@
                     <a:lstStyle/>
                     <a:p>
                       <a:r>
-                        <a:rPr sz="1700" b="0">
+                        <a:rPr sz="1600" b="0" i="0">
                           <a:solidFill>
                             <a:srgbClr val="222222"/>
                           </a:solidFill>
                           <a:latin typeface="Calibri"/>
                         </a:rPr>
-                        <a:t>12 V elektriniai, elektrohidrauliniai domkratai, pneumatinės pagalvės</a:t>
+                        <a:t>J. LaFrance pateikia rombo formos (žirklinio) domkrato patento paraišką</a:t>
+                      </a:r>
+                    </a:p>
+                  </a:txBody>
+                  <a:tcPr marL="73152" marR="73152" anchor="ctr">
+                    <a:solidFill>
+                      <a:srgbClr val="FFFFFF"/>
+                    </a:solidFill>
+                  </a:tcPr>
+                </a:tc>
+              </a:tr>
+              <a:tr h="475488">
+                <a:tc>
+                  <a:txBody>
+                    <a:bodyPr/>
+                    <a:lstStyle/>
+                    <a:p>
+                      <a:r>
+                        <a:rPr sz="1600" b="1" i="0">
+                          <a:solidFill>
+                            <a:srgbClr val="222222"/>
+                          </a:solidFill>
+                          <a:latin typeface="Calibri"/>
+                        </a:rPr>
+                        <a:t>1949 m.</a:t>
+                      </a:r>
+                    </a:p>
+                  </a:txBody>
+                  <a:tcPr marL="73152" marR="73152" anchor="ctr">
+                    <a:solidFill>
+                      <a:srgbClr val="FFFFFF"/>
+                    </a:solidFill>
+                  </a:tcPr>
+                </a:tc>
+                <a:tc>
+                  <a:txBody>
+                    <a:bodyPr/>
+                    <a:lstStyle/>
+                    <a:p>
+                      <a:r>
+                        <a:rPr sz="1600" b="0" i="0">
+                          <a:solidFill>
+                            <a:srgbClr val="222222"/>
+                          </a:solidFill>
+                          <a:latin typeface="Calibri"/>
+                        </a:rPr>
+                        <a:t>W. Watson patobulina žirklinį domkratą – jis tampa sudedamas ir kompaktiškas</a:t>
+                      </a:r>
+                    </a:p>
+                  </a:txBody>
+                  <a:tcPr marL="73152" marR="73152" anchor="ctr">
+                    <a:solidFill>
+                      <a:srgbClr val="FFFFFF"/>
+                    </a:solidFill>
+                  </a:tcPr>
+                </a:tc>
+              </a:tr>
+              <a:tr h="475488">
+                <a:tc>
+                  <a:txBody>
+                    <a:bodyPr/>
+                    <a:lstStyle/>
+                    <a:p>
+                      <a:r>
+                        <a:rPr sz="1600" b="1" i="0">
+                          <a:solidFill>
+                            <a:srgbClr val="222222"/>
+                          </a:solidFill>
+                          <a:latin typeface="Calibri"/>
+                        </a:rPr>
+                        <a:t>Šiandien</a:t>
+                      </a:r>
+                    </a:p>
+                  </a:txBody>
+                  <a:tcPr marL="73152" marR="73152" anchor="ctr">
+                    <a:solidFill>
+                      <a:srgbClr val="FFFFFF"/>
+                    </a:solidFill>
+                  </a:tcPr>
+                </a:tc>
+                <a:tc>
+                  <a:txBody>
+                    <a:bodyPr/>
+                    <a:lstStyle/>
+                    <a:p>
+                      <a:r>
+                        <a:rPr sz="1600" b="0" i="0">
+                          <a:solidFill>
+                            <a:srgbClr val="222222"/>
+                          </a:solidFill>
+                          <a:latin typeface="Calibri"/>
+                        </a:rPr>
+                        <a:t>Gaminami 12 V elektriniai žirkliniai domkratai</a:t>
                       </a:r>
                     </a:p>
                   </a:txBody>
@@ -5059,7 +5732,7 @@
         </p:nvSpPr>
         <p:spPr>
           <a:xfrm>
-            <a:off x="640080" y="5760720"/>
+            <a:off x="640080" y="5897880"/>
             <a:ext cx="10881360" cy="457200"/>
           </a:xfrm>
           <a:prstGeom prst="rect">
@@ -5079,13 +5752,13 @@
               </a:spcAft>
             </a:pPr>
             <a:r>
-              <a:rPr sz="1400" b="0">
+              <a:rPr sz="1300" b="0">
                 <a:solidFill>
                   <a:srgbClr val="595959"/>
                 </a:solidFill>
                 <a:latin typeface="Calibri"/>
               </a:rPr>
-              <a:t>Šaltiniai: Encyclopaedia Britannica (n.d.); Hi-Lift Jack Company (n.d.).</a:t>
+              <a:t>Šaltiniai: Rorres (n.d.); Wikipedia (n.d.-a, n.d.-b, n.d.-c); Hi-Lift Jack Company (n.d.-a); AutoIndustriya (n.d.); Pro-Lift-Montagetechnik (n.d.).</a:t>
             </a:r>
           </a:p>
         </p:txBody>
@@ -5167,6 +5840,7 @@
           <a:ln>
             <a:noFill/>
           </a:ln>
+          <a:effectLst/>
         </p:spPr>
         <p:style>
           <a:lnRef idx="1">
@@ -5224,7 +5898,7 @@
                 </a:solidFill>
                 <a:latin typeface="Calibri"/>
               </a:rPr>
-              <a:t>4 / 9</a:t>
+              <a:t>4 / 10</a:t>
             </a:r>
           </a:p>
         </p:txBody>
@@ -5263,7 +5937,7 @@
                 </a:solidFill>
                 <a:latin typeface="Calibri"/>
               </a:rPr>
-              <a:t>PBL TA1 · Domkratas</a:t>
+              <a:t>PBL · Domkratas</a:t>
             </a:r>
           </a:p>
         </p:txBody>
@@ -5278,7 +5952,7 @@
         </p:nvGraphicFramePr>
         <p:xfrm>
           <a:off x="640080" y="1463040"/>
-          <a:ext cx="10881360" cy="4279392"/>
+          <a:ext cx="10881360" cy="4059936"/>
         </p:xfrm>
         <a:graphic>
           <a:graphicData uri="http://schemas.openxmlformats.org/drawingml/2006/table">
@@ -5292,14 +5966,14 @@
                 <a:gridCol w="2834640"/>
                 <a:gridCol w="2926080"/>
               </a:tblGrid>
-              <a:tr h="713232">
+              <a:tr h="676656">
                 <a:tc>
                   <a:txBody>
                     <a:bodyPr/>
                     <a:lstStyle/>
                     <a:p>
                       <a:r>
-                        <a:rPr sz="1600" b="1">
+                        <a:rPr sz="1500" b="1" i="0">
                           <a:solidFill>
                             <a:srgbClr val="FFFFFF"/>
                           </a:solidFill>
@@ -5321,7 +5995,7 @@
                     <a:lstStyle/>
                     <a:p>
                       <a:r>
-                        <a:rPr sz="1600" b="1">
+                        <a:rPr sz="1500" b="1" i="0">
                           <a:solidFill>
                             <a:srgbClr val="FFFFFF"/>
                           </a:solidFill>
@@ -5343,7 +6017,7 @@
                     <a:lstStyle/>
                     <a:p>
                       <a:r>
-                        <a:rPr sz="1600" b="1">
+                        <a:rPr sz="1500" b="1" i="0">
                           <a:solidFill>
                             <a:srgbClr val="FFFFFF"/>
                           </a:solidFill>
@@ -5365,7 +6039,7 @@
                     <a:lstStyle/>
                     <a:p>
                       <a:r>
-                        <a:rPr sz="1600" b="1">
+                        <a:rPr sz="1500" b="1" i="0">
                           <a:solidFill>
                             <a:srgbClr val="FFFFFF"/>
                           </a:solidFill>
@@ -5382,14 +6056,14 @@
                   </a:tcPr>
                 </a:tc>
               </a:tr>
-              <a:tr h="713232">
+              <a:tr h="676656">
                 <a:tc>
                   <a:txBody>
                     <a:bodyPr/>
                     <a:lstStyle/>
                     <a:p>
                       <a:r>
-                        <a:rPr sz="1600" b="1">
+                        <a:rPr sz="1500" b="1" i="0">
                           <a:solidFill>
                             <a:srgbClr val="222222"/>
                           </a:solidFill>
@@ -5411,7 +6085,7 @@
                     <a:lstStyle/>
                     <a:p>
                       <a:r>
-                        <a:rPr sz="1600" b="0">
+                        <a:rPr sz="1500" b="0" i="0">
                           <a:solidFill>
                             <a:srgbClr val="222222"/>
                           </a:solidFill>
@@ -5433,13 +6107,13 @@
                     <a:lstStyle/>
                     <a:p>
                       <a:r>
-                        <a:rPr sz="1600" b="0">
+                        <a:rPr sz="1500" b="0" i="0">
                           <a:solidFill>
                             <a:srgbClr val="222222"/>
                           </a:solidFill>
                           <a:latin typeface="Calibri"/>
                         </a:rPr>
-                        <a:t>Savistabdis, patikimas</a:t>
+                        <a:t>Savistabdis – krovinys nenusileidžia savaime</a:t>
                       </a:r>
                     </a:p>
                   </a:txBody>
@@ -5455,13 +6129,13 @@
                     <a:lstStyle/>
                     <a:p>
                       <a:r>
-                        <a:rPr sz="1600" b="0">
+                        <a:rPr sz="1500" b="0" i="0">
                           <a:solidFill>
                             <a:srgbClr val="222222"/>
                           </a:solidFill>
                           <a:latin typeface="Calibri"/>
                         </a:rPr>
-                        <a:t>Lėtas, mažas kėlimo aukštis</a:t>
+                        <a:t>Mažas naudingumo koeficientas (30–40 %), lėtas</a:t>
                       </a:r>
                     </a:p>
                   </a:txBody>
@@ -5472,14 +6146,14 @@
                   </a:tcPr>
                 </a:tc>
               </a:tr>
-              <a:tr h="713232">
+              <a:tr h="676656">
                 <a:tc>
                   <a:txBody>
                     <a:bodyPr/>
                     <a:lstStyle/>
                     <a:p>
                       <a:r>
-                        <a:rPr sz="1600" b="1">
+                        <a:rPr sz="1500" b="1" i="0">
                           <a:solidFill>
                             <a:srgbClr val="222222"/>
                           </a:solidFill>
@@ -5501,13 +6175,13 @@
                     <a:lstStyle/>
                     <a:p>
                       <a:r>
-                        <a:rPr sz="1600" b="0">
+                        <a:rPr sz="1500" b="0" i="0">
                           <a:solidFill>
                             <a:srgbClr val="222222"/>
                           </a:solidFill>
                           <a:latin typeface="Calibri"/>
                         </a:rPr>
-                        <a:t>Svirtis su skląsčiu kopia krumpliastiebiu</a:t>
+                        <a:t>Svirtis su skląsčiu kyla krumpliastiebiu</a:t>
                       </a:r>
                     </a:p>
                   </a:txBody>
@@ -5523,13 +6197,13 @@
                     <a:lstStyle/>
                     <a:p>
                       <a:r>
-                        <a:rPr sz="1600" b="0">
+                        <a:rPr sz="1500" b="0" i="0">
                           <a:solidFill>
                             <a:srgbClr val="222222"/>
                           </a:solidFill>
                           <a:latin typeface="Calibri"/>
                         </a:rPr>
-                        <a:t>Labai didelis kėlimo aukštis</a:t>
+                        <a:t>Didelis kėlimo aukštis (iki ~1,5 m)</a:t>
                       </a:r>
                     </a:p>
                   </a:txBody>
@@ -5545,13 +6219,13 @@
                     <a:lstStyle/>
                     <a:p>
                       <a:r>
-                        <a:rPr sz="1600" b="0">
+                        <a:rPr sz="1500" b="0" i="0">
                           <a:solidFill>
                             <a:srgbClr val="222222"/>
                           </a:solidFill>
                           <a:latin typeface="Calibri"/>
                         </a:rPr>
-                        <a:t>Nestabilus, pavojinga rankenos atatranka</a:t>
+                        <a:t>Pavojinga rankenos atatranka</a:t>
                       </a:r>
                     </a:p>
                   </a:txBody>
@@ -5562,14 +6236,14 @@
                   </a:tcPr>
                 </a:tc>
               </a:tr>
-              <a:tr h="713232">
+              <a:tr h="676656">
                 <a:tc>
                   <a:txBody>
                     <a:bodyPr/>
                     <a:lstStyle/>
                     <a:p>
                       <a:r>
-                        <a:rPr sz="1600" b="1">
+                        <a:rPr sz="1500" b="1" i="0">
                           <a:solidFill>
                             <a:srgbClr val="222222"/>
                           </a:solidFill>
@@ -5591,7 +6265,7 @@
                     <a:lstStyle/>
                     <a:p>
                       <a:r>
-                        <a:rPr sz="1600" b="0">
+                        <a:rPr sz="1500" b="0" i="0">
                           <a:solidFill>
                             <a:srgbClr val="222222"/>
                           </a:solidFill>
@@ -5613,13 +6287,13 @@
                     <a:lstStyle/>
                     <a:p>
                       <a:r>
-                        <a:rPr sz="1600" b="0">
+                        <a:rPr sz="1500" b="0" i="0">
                           <a:solidFill>
                             <a:srgbClr val="222222"/>
                           </a:solidFill>
                           <a:latin typeface="Calibri"/>
                         </a:rPr>
-                        <a:t>Kompaktiškas, lengvas, pigus</a:t>
+                        <a:t>Lengvas, pigus, telpa automobilyje</a:t>
                       </a:r>
                     </a:p>
                   </a:txBody>
@@ -5635,13 +6309,13 @@
                     <a:lstStyle/>
                     <a:p>
                       <a:r>
-                        <a:rPr sz="1600" b="0">
+                        <a:rPr sz="1500" b="0" i="0">
                           <a:solidFill>
                             <a:srgbClr val="222222"/>
                           </a:solidFill>
                           <a:latin typeface="Calibri"/>
                         </a:rPr>
-                        <a:t>Lėtas, sunku sukti, siauras pagrindas</a:t>
+                        <a:t>Lėtas, siauras pagrindas, nestabilus</a:t>
                       </a:r>
                     </a:p>
                   </a:txBody>
@@ -5652,14 +6326,14 @@
                   </a:tcPr>
                 </a:tc>
               </a:tr>
-              <a:tr h="713232">
+              <a:tr h="676656">
                 <a:tc>
                   <a:txBody>
                     <a:bodyPr/>
                     <a:lstStyle/>
                     <a:p>
                       <a:r>
-                        <a:rPr sz="1600" b="1">
+                        <a:rPr sz="1500" b="1" i="0">
                           <a:solidFill>
                             <a:srgbClr val="222222"/>
                           </a:solidFill>
@@ -5681,7 +6355,7 @@
                     <a:lstStyle/>
                     <a:p>
                       <a:r>
-                        <a:rPr sz="1600" b="0">
+                        <a:rPr sz="1500" b="0" i="0">
                           <a:solidFill>
                             <a:srgbClr val="222222"/>
                           </a:solidFill>
@@ -5703,13 +6377,13 @@
                     <a:lstStyle/>
                     <a:p>
                       <a:r>
-                        <a:rPr sz="1600" b="0">
+                        <a:rPr sz="1500" b="0" i="0">
                           <a:solidFill>
                             <a:srgbClr val="222222"/>
                           </a:solidFill>
                           <a:latin typeface="Calibri"/>
                         </a:rPr>
-                        <a:t>Didelė jėga mažame tūryje</a:t>
+                        <a:t>Didelė keliamoji galia (3–50 t)</a:t>
                       </a:r>
                     </a:p>
                   </a:txBody>
@@ -5725,13 +6399,13 @@
                     <a:lstStyle/>
                     <a:p>
                       <a:r>
-                        <a:rPr sz="1600" b="0">
+                        <a:rPr sz="1500" b="0" i="0">
                           <a:solidFill>
                             <a:srgbClr val="222222"/>
                           </a:solidFill>
                           <a:latin typeface="Calibri"/>
                         </a:rPr>
-                        <a:t>Didelis pradinis aukštis, nutekėjimai</a:t>
+                        <a:t>Mažas pagrindas, didelis pradinis aukštis</a:t>
                       </a:r>
                     </a:p>
                   </a:txBody>
@@ -5742,14 +6416,14 @@
                   </a:tcPr>
                 </a:tc>
               </a:tr>
-              <a:tr h="713232">
+              <a:tr h="676656">
                 <a:tc>
                   <a:txBody>
                     <a:bodyPr/>
                     <a:lstStyle/>
                     <a:p>
                       <a:r>
-                        <a:rPr sz="1600" b="1">
+                        <a:rPr sz="1500" b="1" i="0">
                           <a:solidFill>
                             <a:srgbClr val="222222"/>
                           </a:solidFill>
@@ -5771,7 +6445,7 @@
                     <a:lstStyle/>
                     <a:p>
                       <a:r>
-                        <a:rPr sz="1600" b="0">
+                        <a:rPr sz="1500" b="0" i="0">
                           <a:solidFill>
                             <a:srgbClr val="222222"/>
                           </a:solidFill>
@@ -5793,13 +6467,13 @@
                     <a:lstStyle/>
                     <a:p>
                       <a:r>
-                        <a:rPr sz="1600" b="0">
+                        <a:rPr sz="1500" b="0" i="0">
                           <a:solidFill>
                             <a:srgbClr val="222222"/>
                           </a:solidFill>
                           <a:latin typeface="Calibri"/>
                         </a:rPr>
-                        <a:t>Greitas, stabilus</a:t>
+                        <a:t>Greitas ir stabilus (2–4 t)</a:t>
                       </a:r>
                     </a:p>
                   </a:txBody>
@@ -5815,13 +6489,13 @@
                     <a:lstStyle/>
                     <a:p>
                       <a:r>
-                        <a:rPr sz="1600" b="0">
+                        <a:rPr sz="1500" b="0" i="0">
                           <a:solidFill>
                             <a:srgbClr val="222222"/>
                           </a:solidFill>
                           <a:latin typeface="Calibri"/>
                         </a:rPr>
-                        <a:t>Sunkus, nenešiojamas, brangus</a:t>
+                        <a:t>Didelis, sunku perkelti</a:t>
                       </a:r>
                     </a:p>
                   </a:txBody>
@@ -5836,6 +6510,45 @@
           </a:graphicData>
         </a:graphic>
       </p:graphicFrame>
+      <p:sp>
+        <p:nvSpPr>
+          <p:cNvPr id="7" name="TextBox 6"/>
+          <p:cNvSpPr txBox="1"/>
+          <p:nvPr/>
+        </p:nvSpPr>
+        <p:spPr>
+          <a:xfrm>
+            <a:off x="640080" y="5897880"/>
+            <a:ext cx="10881360" cy="457200"/>
+          </a:xfrm>
+          <a:prstGeom prst="rect">
+            <a:avLst/>
+          </a:prstGeom>
+          <a:noFill/>
+        </p:spPr>
+        <p:txBody>
+          <a:bodyPr wrap="square" anchor="t" lIns="45720" rIns="45720">
+            <a:spAutoFit/>
+          </a:bodyPr>
+          <a:lstStyle/>
+          <a:p>
+            <a:pPr algn="l">
+              <a:spcAft>
+                <a:spcPts val="600"/>
+              </a:spcAft>
+            </a:pPr>
+            <a:r>
+              <a:rPr sz="1300" b="0">
+                <a:solidFill>
+                  <a:srgbClr val="595959"/>
+                </a:solidFill>
+                <a:latin typeface="Calibri"/>
+              </a:rPr>
+              <a:t>Šaltiniai: Wikipedia (n.d.-d); Joyce/Dayton (n.d.); CJ Pony Parts (n.d.); Hi-Lift Jack Company (n.d.-b); CN Trailer Parts (n.d.); Redline Stands (n.d.).</a:t>
+            </a:r>
+          </a:p>
+        </p:txBody>
+      </p:sp>
     </p:spTree>
   </p:cSld>
   <p:clrMapOvr>
@@ -5913,6 +6626,7 @@
           <a:ln>
             <a:noFill/>
           </a:ln>
+          <a:effectLst/>
         </p:spPr>
         <p:style>
           <a:lnRef idx="1">
@@ -5970,7 +6684,7 @@
                 </a:solidFill>
                 <a:latin typeface="Calibri"/>
               </a:rPr>
-              <a:t>5 / 9</a:t>
+              <a:t>5 / 10</a:t>
             </a:r>
           </a:p>
         </p:txBody>
@@ -6009,7 +6723,7 @@
                 </a:solidFill>
                 <a:latin typeface="Calibri"/>
               </a:rPr>
-              <a:t>PBL TA1 · Domkratas</a:t>
+              <a:t>PBL · Domkratas</a:t>
             </a:r>
           </a:p>
         </p:txBody>
@@ -6062,7 +6776,7 @@
         <p:spPr>
           <a:xfrm>
             <a:off x="640080" y="2011680"/>
-            <a:ext cx="5486400" cy="3931920"/>
+            <a:ext cx="5577840" cy="3749039"/>
           </a:xfrm>
           <a:prstGeom prst="rect">
             <a:avLst/>
@@ -6090,13 +6804,13 @@
               <a:t>• Lėtas</a:t>
             </a:r>
             <a:r>
-              <a:rPr sz="1900">
+              <a:rPr sz="1900" b="0" i="0">
                 <a:solidFill>
                   <a:srgbClr val="222222"/>
                 </a:solidFill>
                 <a:latin typeface="Calibri"/>
               </a:rPr>
-              <a:t> – reikia apie 60–100 rankenos apsisukimų (2–4 min).</a:t>
+              <a:t> – reikia daug rankenos apsisukimų (mūsų įvertinimu, 60–100).</a:t>
             </a:r>
           </a:p>
           <a:p>
@@ -6115,13 +6829,13 @@
               <a:t>• Sunku sukti</a:t>
             </a:r>
             <a:r>
-              <a:rPr sz="1900">
+              <a:rPr sz="1900" b="0" i="0">
                 <a:solidFill>
                   <a:srgbClr val="222222"/>
                 </a:solidFill>
                 <a:latin typeface="Calibri"/>
               </a:rPr>
-              <a:t> – žemoje padėtyje jėga sraigte kelis kartus didesnė už krovinį.</a:t>
+              <a:t> – žemoje padėtyje jėga sraigte kelis kartus didesnė už krovinį (F = Q / tg θ).</a:t>
             </a:r>
           </a:p>
           <a:p>
@@ -6140,13 +6854,13 @@
               <a:t>• Nestabilus</a:t>
             </a:r>
             <a:r>
-              <a:rPr sz="1900">
+              <a:rPr sz="1900" b="0" i="0">
                 <a:solidFill>
                   <a:srgbClr val="222222"/>
                 </a:solidFill>
                 <a:latin typeface="Calibri"/>
               </a:rPr>
-              <a:t> – mažas pagrindas slysta ar smenga į minkštą gruntą.</a:t>
+              <a:t> – siauras pagrindas, ypač ant nelygaus ar minkšto paviršiaus.</a:t>
             </a:r>
           </a:p>
           <a:p>
@@ -6165,13 +6879,13 @@
               <a:t>• Nepatogus</a:t>
             </a:r>
             <a:r>
-              <a:rPr sz="1900">
+              <a:rPr sz="1900" b="0" i="0">
                 <a:solidFill>
                   <a:srgbClr val="222222"/>
                 </a:solidFill>
                 <a:latin typeface="Calibri"/>
               </a:rPr>
-              <a:t> – žmogus dirba pasilenkęs, ilgai būna prie kelio.</a:t>
+              <a:t> – sukti tenka nepatogioje padėtyje.</a:t>
             </a:r>
           </a:p>
         </p:txBody>
@@ -6185,7 +6899,7 @@
         <p:spPr>
           <a:xfrm>
             <a:off x="6492240" y="1508760"/>
-            <a:ext cx="5029200" cy="4297680"/>
+            <a:ext cx="5029200" cy="4206240"/>
           </a:xfrm>
           <a:prstGeom prst="rect">
             <a:avLst/>
@@ -6229,7 +6943,7 @@
         <p:spPr>
           <a:xfrm>
             <a:off x="6720840" y="1691640"/>
-            <a:ext cx="4572000" cy="4023360"/>
+            <a:ext cx="4572000" cy="3931920"/>
           </a:xfrm>
           <a:prstGeom prst="rect">
             <a:avLst/>
@@ -6379,8 +7093,8 @@
         </p:nvSpPr>
         <p:spPr>
           <a:xfrm>
-            <a:off x="640080" y="5852160"/>
-            <a:ext cx="5486400" cy="457200"/>
+            <a:off x="640080" y="5897880"/>
+            <a:ext cx="10881360" cy="457200"/>
           </a:xfrm>
           <a:prstGeom prst="rect">
             <a:avLst/>
@@ -6399,13 +7113,13 @@
               </a:spcAft>
             </a:pPr>
             <a:r>
-              <a:rPr sz="1400" b="0">
+              <a:rPr sz="1300" b="0">
                 <a:solidFill>
                   <a:srgbClr val="595959"/>
                 </a:solidFill>
                 <a:latin typeface="Calibri"/>
               </a:rPr>
-              <a:t>Apsisukimų skaičius – mūsų įvertinimas.</a:t>
+              <a:t>Šaltiniai: CN Trailer Parts (n.d.). Skaičiai ir tikslai – mūsų įvertinimai.</a:t>
             </a:r>
           </a:p>
         </p:txBody>
@@ -6487,6 +7201,7 @@
           <a:ln>
             <a:noFill/>
           </a:ln>
+          <a:effectLst/>
         </p:spPr>
         <p:style>
           <a:lnRef idx="1">
@@ -6544,7 +7259,7 @@
                 </a:solidFill>
                 <a:latin typeface="Calibri"/>
               </a:rPr>
-              <a:t>6 / 9</a:t>
+              <a:t>6 / 10</a:t>
             </a:r>
           </a:p>
         </p:txBody>
@@ -6583,7 +7298,7 @@
                 </a:solidFill>
                 <a:latin typeface="Calibri"/>
               </a:rPr>
-              <a:t>PBL TA1 · Domkratas</a:t>
+              <a:t>PBL · Domkratas</a:t>
             </a:r>
           </a:p>
         </p:txBody>
@@ -6598,7 +7313,7 @@
         </p:nvGraphicFramePr>
         <p:xfrm>
           <a:off x="640080" y="1463040"/>
-          <a:ext cx="10881360" cy="4352544"/>
+          <a:ext cx="10881360" cy="4096512"/>
         </p:xfrm>
         <a:graphic>
           <a:graphicData uri="http://schemas.openxmlformats.org/drawingml/2006/table">
@@ -6608,18 +7323,18 @@
               </a:tblPr>
               <a:tblGrid>
                 <a:gridCol w="1737360"/>
-                <a:gridCol w="2651760"/>
+                <a:gridCol w="2560320"/>
                 <a:gridCol w="3291840"/>
-                <a:gridCol w="3200400"/>
+                <a:gridCol w="3291840"/>
               </a:tblGrid>
-              <a:tr h="621792">
+              <a:tr h="585216">
                 <a:tc>
                   <a:txBody>
                     <a:bodyPr/>
                     <a:lstStyle/>
                     <a:p>
                       <a:r>
-                        <a:rPr sz="1600" b="1">
+                        <a:rPr sz="1500" b="1" i="0">
                           <a:solidFill>
                             <a:srgbClr val="FFFFFF"/>
                           </a:solidFill>
@@ -6641,7 +7356,7 @@
                     <a:lstStyle/>
                     <a:p>
                       <a:r>
-                        <a:rPr sz="1600" b="1">
+                        <a:rPr sz="1500" b="1" i="0">
                           <a:solidFill>
                             <a:srgbClr val="FFFFFF"/>
                           </a:solidFill>
@@ -6663,7 +7378,7 @@
                     <a:lstStyle/>
                     <a:p>
                       <a:r>
-                        <a:rPr sz="1600" b="1">
+                        <a:rPr sz="1500" b="1" i="0">
                           <a:solidFill>
                             <a:srgbClr val="FFFFFF"/>
                           </a:solidFill>
@@ -6685,7 +7400,7 @@
                     <a:lstStyle/>
                     <a:p>
                       <a:r>
-                        <a:rPr sz="1600" b="1">
+                        <a:rPr sz="1500" b="1" i="0">
                           <a:solidFill>
                             <a:srgbClr val="FFFFFF"/>
                           </a:solidFill>
@@ -6702,14 +7417,14 @@
                   </a:tcPr>
                 </a:tc>
               </a:tr>
-              <a:tr h="621792">
+              <a:tr h="585216">
                 <a:tc>
                   <a:txBody>
                     <a:bodyPr/>
                     <a:lstStyle/>
                     <a:p>
                       <a:r>
-                        <a:rPr sz="1600" b="1">
+                        <a:rPr sz="1500" b="1" i="0">
                           <a:solidFill>
                             <a:srgbClr val="222222"/>
                           </a:solidFill>
@@ -6731,7 +7446,7 @@
                     <a:lstStyle/>
                     <a:p>
                       <a:r>
-                        <a:rPr sz="1600" b="0">
+                        <a:rPr sz="1500" b="0" i="0">
                           <a:solidFill>
                             <a:srgbClr val="222222"/>
                           </a:solidFill>
@@ -6753,13 +7468,13 @@
                     <a:lstStyle/>
                     <a:p>
                       <a:r>
-                        <a:rPr sz="1600" b="0">
+                        <a:rPr sz="1500" b="0" i="0">
                           <a:solidFill>
                             <a:srgbClr val="222222"/>
                           </a:solidFill>
                           <a:latin typeface="Calibri"/>
                         </a:rPr>
-                        <a:t>12 V variklis (~100 W) + reduktorius</a:t>
+                        <a:t>12 V variklis (~100 W) su reduktoriumi</a:t>
                       </a:r>
                     </a:p>
                   </a:txBody>
@@ -6775,13 +7490,13 @@
                     <a:lstStyle/>
                     <a:p>
                       <a:r>
-                        <a:rPr sz="1600" b="0">
+                        <a:rPr sz="1500" b="0" i="0">
                           <a:solidFill>
                             <a:srgbClr val="222222"/>
                           </a:solidFill>
                           <a:latin typeface="Calibri"/>
                         </a:rPr>
-                        <a:t>Greitai, be fizinių pastangų</a:t>
+                        <a:t>Greitai ir be fizinių pastangų</a:t>
                       </a:r>
                     </a:p>
                   </a:txBody>
@@ -6792,14 +7507,14 @@
                   </a:tcPr>
                 </a:tc>
               </a:tr>
-              <a:tr h="621792">
+              <a:tr h="585216">
                 <a:tc>
                   <a:txBody>
                     <a:bodyPr/>
                     <a:lstStyle/>
                     <a:p>
                       <a:r>
-                        <a:rPr sz="1600" b="1">
+                        <a:rPr sz="1500" b="1" i="0">
                           <a:solidFill>
                             <a:srgbClr val="222222"/>
                           </a:solidFill>
@@ -6821,13 +7536,13 @@
                     <a:lstStyle/>
                     <a:p>
                       <a:r>
-                        <a:rPr sz="1600" b="0">
+                        <a:rPr sz="1500" b="0" i="0">
                           <a:solidFill>
                             <a:srgbClr val="222222"/>
                           </a:solidFill>
                           <a:latin typeface="Calibri"/>
                         </a:rPr>
-                        <a:t>Paprastas plienas, metrinis sriegis</a:t>
+                        <a:t>Paprastas plienas</a:t>
                       </a:r>
                     </a:p>
                   </a:txBody>
@@ -6843,13 +7558,13 @@
                     <a:lstStyle/>
                     <a:p>
                       <a:r>
-                        <a:rPr sz="1600" b="0">
+                        <a:rPr sz="1500" b="0" i="0">
                           <a:solidFill>
                             <a:srgbClr val="222222"/>
                           </a:solidFill>
                           <a:latin typeface="Calibri"/>
                         </a:rPr>
-                        <a:t>Trapecinis Tr18×4, plienas 42CrMo4</a:t>
+                        <a:t>Trapecinis sraigtas, plienas 42CrMo4</a:t>
                       </a:r>
                     </a:p>
                   </a:txBody>
@@ -6865,13 +7580,13 @@
                     <a:lstStyle/>
                     <a:p>
                       <a:r>
-                        <a:rPr sz="1600" b="0">
+                        <a:rPr sz="1500" b="0" i="0">
                           <a:solidFill>
                             <a:srgbClr val="222222"/>
                           </a:solidFill>
                           <a:latin typeface="Calibri"/>
                         </a:rPr>
-                        <a:t>Savistabdis, atsparus dilimui</a:t>
+                        <a:t>Savistabdis; plienas stiprus ir atsparus nuovargiui</a:t>
                       </a:r>
                     </a:p>
                   </a:txBody>
@@ -6882,14 +7597,14 @@
                   </a:tcPr>
                 </a:tc>
               </a:tr>
-              <a:tr h="621792">
+              <a:tr h="585216">
                 <a:tc>
                   <a:txBody>
                     <a:bodyPr/>
                     <a:lstStyle/>
                     <a:p>
                       <a:r>
-                        <a:rPr sz="1600" b="1">
+                        <a:rPr sz="1500" b="1" i="0">
                           <a:solidFill>
                             <a:srgbClr val="222222"/>
                           </a:solidFill>
@@ -6911,7 +7626,7 @@
                     <a:lstStyle/>
                     <a:p>
                       <a:r>
-                        <a:rPr sz="1600" b="0">
+                        <a:rPr sz="1500" b="0" i="0">
                           <a:solidFill>
                             <a:srgbClr val="222222"/>
                           </a:solidFill>
@@ -6933,7 +7648,7 @@
                     <a:lstStyle/>
                     <a:p>
                       <a:r>
-                        <a:rPr sz="1600" b="0">
+                        <a:rPr sz="1500" b="0" i="0">
                           <a:solidFill>
                             <a:srgbClr val="222222"/>
                           </a:solidFill>
@@ -6955,13 +7670,13 @@
                     <a:lstStyle/>
                     <a:p>
                       <a:r>
-                        <a:rPr sz="1600" b="0">
+                        <a:rPr sz="1500" b="0" i="0">
                           <a:solidFill>
                             <a:srgbClr val="222222"/>
                           </a:solidFill>
                           <a:latin typeface="Calibri"/>
                         </a:rPr>
-                        <a:t>Mažesnė trintis, mažiau dyla</a:t>
+                        <a:t>Maža trintis, atspari dilimui</a:t>
                       </a:r>
                     </a:p>
                   </a:txBody>
@@ -6972,14 +7687,14 @@
                   </a:tcPr>
                 </a:tc>
               </a:tr>
-              <a:tr h="621792">
+              <a:tr h="585216">
                 <a:tc>
                   <a:txBody>
                     <a:bodyPr/>
                     <a:lstStyle/>
                     <a:p>
                       <a:r>
-                        <a:rPr sz="1600" b="1">
+                        <a:rPr sz="1500" b="1" i="0">
                           <a:solidFill>
                             <a:srgbClr val="222222"/>
                           </a:solidFill>
@@ -7001,13 +7716,13 @@
                     <a:lstStyle/>
                     <a:p>
                       <a:r>
-                        <a:rPr sz="1600" b="0">
+                        <a:rPr sz="1500" b="0" i="0">
                           <a:solidFill>
                             <a:srgbClr val="222222"/>
                           </a:solidFill>
                           <a:latin typeface="Calibri"/>
                         </a:rPr>
-                        <a:t>Plienas S235</a:t>
+                        <a:t>Plienas S235 (235 MPa)</a:t>
                       </a:r>
                     </a:p>
                   </a:txBody>
@@ -7023,13 +7738,13 @@
                     <a:lstStyle/>
                     <a:p>
                       <a:r>
-                        <a:rPr sz="1600" b="0">
+                        <a:rPr sz="1500" b="0" i="0">
                           <a:solidFill>
                             <a:srgbClr val="222222"/>
                           </a:solidFill>
                           <a:latin typeface="Calibri"/>
                         </a:rPr>
-                        <a:t>Plienas S420MC</a:t>
+                        <a:t>Plienas S420MC (420 MPa)</a:t>
                       </a:r>
                     </a:p>
                   </a:txBody>
@@ -7045,13 +7760,13 @@
                     <a:lstStyle/>
                     <a:p>
                       <a:r>
-                        <a:rPr sz="1600" b="0">
+                        <a:rPr sz="1500" b="0" i="0">
                           <a:solidFill>
                             <a:srgbClr val="222222"/>
                           </a:solidFill>
                           <a:latin typeface="Calibri"/>
                         </a:rPr>
-                        <a:t>~1,8 karto stipresnės, ta pati masė</a:t>
+                        <a:t>Takumo riba ~1,8 karto didesnė</a:t>
                       </a:r>
                     </a:p>
                   </a:txBody>
@@ -7062,14 +7777,14 @@
                   </a:tcPr>
                 </a:tc>
               </a:tr>
-              <a:tr h="621792">
+              <a:tr h="585216">
                 <a:tc>
                   <a:txBody>
                     <a:bodyPr/>
                     <a:lstStyle/>
                     <a:p>
                       <a:r>
-                        <a:rPr sz="1600" b="1">
+                        <a:rPr sz="1500" b="1" i="0">
                           <a:solidFill>
                             <a:srgbClr val="222222"/>
                           </a:solidFill>
@@ -7091,13 +7806,13 @@
                     <a:lstStyle/>
                     <a:p>
                       <a:r>
-                        <a:rPr sz="1600" b="0">
+                        <a:rPr sz="1500" b="0" i="0">
                           <a:solidFill>
                             <a:srgbClr val="222222"/>
                           </a:solidFill>
                           <a:latin typeface="Calibri"/>
                         </a:rPr>
-                        <a:t>~130×80 mm</a:t>
+                        <a:t>Siauras</a:t>
                       </a:r>
                     </a:p>
                   </a:txBody>
@@ -7113,13 +7828,13 @@
                     <a:lstStyle/>
                     <a:p>
                       <a:r>
-                        <a:rPr sz="1600" b="0">
+                        <a:rPr sz="1500" b="0" i="0">
                           <a:solidFill>
                             <a:srgbClr val="222222"/>
                           </a:solidFill>
                           <a:latin typeface="Calibri"/>
                         </a:rPr>
-                        <a:t>~200×120 mm su guminiu padu</a:t>
+                        <a:t>Platesnis, su guminiu padu</a:t>
                       </a:r>
                     </a:p>
                   </a:txBody>
@@ -7135,7 +7850,7 @@
                     <a:lstStyle/>
                     <a:p>
                       <a:r>
-                        <a:rPr sz="1600" b="0">
+                        <a:rPr sz="1500" b="0" i="0">
                           <a:solidFill>
                             <a:srgbClr val="222222"/>
                           </a:solidFill>
@@ -7152,14 +7867,14 @@
                   </a:tcPr>
                 </a:tc>
               </a:tr>
-              <a:tr h="621792">
+              <a:tr h="585216">
                 <a:tc>
                   <a:txBody>
                     <a:bodyPr/>
                     <a:lstStyle/>
                     <a:p>
                       <a:r>
-                        <a:rPr sz="1600" b="1">
+                        <a:rPr sz="1500" b="1" i="0">
                           <a:solidFill>
                             <a:srgbClr val="222222"/>
                           </a:solidFill>
@@ -7181,7 +7896,7 @@
                     <a:lstStyle/>
                     <a:p>
                       <a:r>
-                        <a:rPr sz="1600" b="0">
+                        <a:rPr sz="1500" b="0" i="0">
                           <a:solidFill>
                             <a:srgbClr val="222222"/>
                           </a:solidFill>
@@ -7203,13 +7918,13 @@
                     <a:lstStyle/>
                     <a:p>
                       <a:r>
-                        <a:rPr sz="1600" b="0">
+                        <a:rPr sz="1500" b="0" i="0">
                           <a:solidFill>
                             <a:srgbClr val="222222"/>
                           </a:solidFill>
                           <a:latin typeface="Calibri"/>
                         </a:rPr>
-                        <a:t>Galiniai jungikliai, perkrovos apsauga, avarinis rankinis sukimas</a:t>
+                        <a:t>Galiniai jungikliai, avarinis rankinis sukimas</a:t>
                       </a:r>
                     </a:p>
                   </a:txBody>
@@ -7225,13 +7940,13 @@
                     <a:lstStyle/>
                     <a:p>
                       <a:r>
-                        <a:rPr sz="1600" b="0">
+                        <a:rPr sz="1500" b="0" i="0">
                           <a:solidFill>
                             <a:srgbClr val="222222"/>
                           </a:solidFill>
                           <a:latin typeface="Calibri"/>
                         </a:rPr>
-                        <a:t>Veikia ir dingus elektrai</a:t>
+                        <a:t>Variklis sustoja kraštinėse padėtyse</a:t>
                       </a:r>
                     </a:p>
                   </a:txBody>
@@ -7246,6 +7961,45 @@
           </a:graphicData>
         </a:graphic>
       </p:graphicFrame>
+      <p:sp>
+        <p:nvSpPr>
+          <p:cNvPr id="7" name="TextBox 6"/>
+          <p:cNvSpPr txBox="1"/>
+          <p:nvPr/>
+        </p:nvSpPr>
+        <p:spPr>
+          <a:xfrm>
+            <a:off x="640080" y="5760720"/>
+            <a:ext cx="10881360" cy="457200"/>
+          </a:xfrm>
+          <a:prstGeom prst="rect">
+            <a:avLst/>
+          </a:prstGeom>
+          <a:noFill/>
+        </p:spPr>
+        <p:txBody>
+          <a:bodyPr wrap="square" anchor="t" lIns="45720" rIns="45720">
+            <a:spAutoFit/>
+          </a:bodyPr>
+          <a:lstStyle/>
+          <a:p>
+            <a:pPr algn="l">
+              <a:spcAft>
+                <a:spcPts val="600"/>
+              </a:spcAft>
+            </a:pPr>
+            <a:r>
+              <a:rPr sz="1300" b="0">
+                <a:solidFill>
+                  <a:srgbClr val="595959"/>
+                </a:solidFill>
+                <a:latin typeface="Calibri"/>
+              </a:rPr>
+              <a:t>Šaltiniai: Roton Products (n.d.); Sider Ticino (n.d.); Hengli Automation (n.d.); The World Material (n.d.); Gnee Steel (n.d.); Mickael (2004). Variklio galia – mūsų skaičiavimas.</a:t>
+            </a:r>
+          </a:p>
+        </p:txBody>
+      </p:sp>
     </p:spTree>
   </p:cSld>
   <p:clrMapOvr>
@@ -7323,6 +8077,7 @@
           <a:ln>
             <a:noFill/>
           </a:ln>
+          <a:effectLst/>
         </p:spPr>
         <p:style>
           <a:lnRef idx="1">
@@ -7380,7 +8135,7 @@
                 </a:solidFill>
                 <a:latin typeface="Calibri"/>
               </a:rPr>
-              <a:t>7 / 9</a:t>
+              <a:t>7 / 10</a:t>
             </a:r>
           </a:p>
         </p:txBody>
@@ -7419,7 +8174,7 @@
                 </a:solidFill>
                 <a:latin typeface="Calibri"/>
               </a:rPr>
-              <a:t>PBL TA1 · Domkratas</a:t>
+              <a:t>PBL · Domkratas</a:t>
             </a:r>
           </a:p>
         </p:txBody>
@@ -7454,7 +8209,7 @@
                     <a:lstStyle/>
                     <a:p>
                       <a:r>
-                        <a:rPr sz="1700" b="1">
+                        <a:rPr sz="1700" b="1" i="0">
                           <a:solidFill>
                             <a:srgbClr val="FFFFFF"/>
                           </a:solidFill>
@@ -7476,7 +8231,7 @@
                     <a:lstStyle/>
                     <a:p>
                       <a:r>
-                        <a:rPr sz="1700" b="1">
+                        <a:rPr sz="1700" b="1" i="0">
                           <a:solidFill>
                             <a:srgbClr val="FFFFFF"/>
                           </a:solidFill>
@@ -7498,7 +8253,7 @@
                     <a:lstStyle/>
                     <a:p>
                       <a:r>
-                        <a:rPr sz="1700" b="1">
+                        <a:rPr sz="1700" b="1" i="0">
                           <a:solidFill>
                             <a:srgbClr val="FFFFFF"/>
                           </a:solidFill>
@@ -7522,7 +8277,7 @@
                     <a:lstStyle/>
                     <a:p>
                       <a:r>
-                        <a:rPr sz="1700" b="1">
+                        <a:rPr sz="1700" b="1" i="0">
                           <a:solidFill>
                             <a:srgbClr val="222222"/>
                           </a:solidFill>
@@ -7544,7 +8299,7 @@
                     <a:lstStyle/>
                     <a:p>
                       <a:r>
-                        <a:rPr sz="1700" b="0">
+                        <a:rPr sz="1700" b="0" i="0">
                           <a:solidFill>
                             <a:srgbClr val="222222"/>
                           </a:solidFill>
@@ -7566,7 +8321,7 @@
                     <a:lstStyle/>
                     <a:p>
                       <a:r>
-                        <a:rPr sz="1700" b="0">
+                        <a:rPr sz="1700" b="0" i="0">
                           <a:solidFill>
                             <a:srgbClr val="222222"/>
                           </a:solidFill>
@@ -7590,7 +8345,7 @@
                     <a:lstStyle/>
                     <a:p>
                       <a:r>
-                        <a:rPr sz="1700" b="1">
+                        <a:rPr sz="1700" b="1" i="0">
                           <a:solidFill>
                             <a:srgbClr val="222222"/>
                           </a:solidFill>
@@ -7612,7 +8367,7 @@
                     <a:lstStyle/>
                     <a:p>
                       <a:r>
-                        <a:rPr sz="1700" b="0">
+                        <a:rPr sz="1700" b="0" i="0">
                           <a:solidFill>
                             <a:srgbClr val="222222"/>
                           </a:solidFill>
@@ -7634,7 +8389,7 @@
                     <a:lstStyle/>
                     <a:p>
                       <a:r>
-                        <a:rPr sz="1700" b="0">
+                        <a:rPr sz="1700" b="0" i="0">
                           <a:solidFill>
                             <a:srgbClr val="222222"/>
                           </a:solidFill>
@@ -7658,7 +8413,7 @@
                     <a:lstStyle/>
                     <a:p>
                       <a:r>
-                        <a:rPr sz="1700" b="1">
+                        <a:rPr sz="1700" b="1" i="0">
                           <a:solidFill>
                             <a:srgbClr val="222222"/>
                           </a:solidFill>
@@ -7680,7 +8435,7 @@
                     <a:lstStyle/>
                     <a:p>
                       <a:r>
-                        <a:rPr sz="1700" b="0">
+                        <a:rPr sz="1700" b="0" i="0">
                           <a:solidFill>
                             <a:srgbClr val="222222"/>
                           </a:solidFill>
@@ -7702,7 +8457,7 @@
                     <a:lstStyle/>
                     <a:p>
                       <a:r>
-                        <a:rPr sz="1700" b="0">
+                        <a:rPr sz="1700" b="0" i="0">
                           <a:solidFill>
                             <a:srgbClr val="222222"/>
                           </a:solidFill>
@@ -7726,7 +8481,7 @@
                     <a:lstStyle/>
                     <a:p>
                       <a:r>
-                        <a:rPr sz="1700" b="1">
+                        <a:rPr sz="1700" b="1" i="0">
                           <a:solidFill>
                             <a:srgbClr val="222222"/>
                           </a:solidFill>
@@ -7748,7 +8503,7 @@
                     <a:lstStyle/>
                     <a:p>
                       <a:r>
-                        <a:rPr sz="1700" b="0">
+                        <a:rPr sz="1700" b="0" i="0">
                           <a:solidFill>
                             <a:srgbClr val="222222"/>
                           </a:solidFill>
@@ -7770,7 +8525,7 @@
                     <a:lstStyle/>
                     <a:p>
                       <a:r>
-                        <a:rPr sz="1700" b="0">
+                        <a:rPr sz="1700" b="0" i="0">
                           <a:solidFill>
                             <a:srgbClr val="222222"/>
                           </a:solidFill>
@@ -7794,7 +8549,7 @@
                     <a:lstStyle/>
                     <a:p>
                       <a:r>
-                        <a:rPr sz="1700" b="1">
+                        <a:rPr sz="1700" b="1" i="0">
                           <a:solidFill>
                             <a:srgbClr val="222222"/>
                           </a:solidFill>
@@ -7816,7 +8571,7 @@
                     <a:lstStyle/>
                     <a:p>
                       <a:r>
-                        <a:rPr sz="1700" b="0">
+                        <a:rPr sz="1700" b="0" i="0">
                           <a:solidFill>
                             <a:srgbClr val="222222"/>
                           </a:solidFill>
@@ -7838,7 +8593,7 @@
                     <a:lstStyle/>
                     <a:p>
                       <a:r>
-                        <a:rPr sz="1700" b="0">
+                        <a:rPr sz="1700" b="0" i="0">
                           <a:solidFill>
                             <a:srgbClr val="222222"/>
                           </a:solidFill>
@@ -7957,7 +8712,7 @@
                 </a:solidFill>
                 <a:latin typeface="Calibri"/>
               </a:rPr>
-              <a:t>≈ 8 A (saugiklis 15 A)</a:t>
+              <a:t>I = P / U ≈ 93 / 12 ≈ 8 A</a:t>
             </a:r>
           </a:p>
           <a:p>
@@ -7973,7 +8728,7 @@
                 </a:solidFill>
                 <a:latin typeface="Calibri"/>
               </a:rPr>
-              <a:t>Savistabdumas:</a:t>
+              <a:t>Savistabdumo sąlyga:</a:t>
             </a:r>
           </a:p>
           <a:p>
@@ -7989,7 +8744,7 @@
                 </a:solidFill>
                 <a:latin typeface="Calibri"/>
               </a:rPr>
-              <a:t>kėlimo kampas ψ = 4,5° &lt; trinties kampas φ′ ≈ 5,9° – krovinys nenusileidžia savaime.</a:t>
+              <a:t>sriegio pakilimo kampas turi būti mažesnis už trinties kampą – tada krovinys nenusileidžia savaime.</a:t>
             </a:r>
           </a:p>
         </p:txBody>
@@ -8002,7 +8757,7 @@
         </p:nvSpPr>
         <p:spPr>
           <a:xfrm>
-            <a:off x="640080" y="5760720"/>
+            <a:off x="640080" y="5897880"/>
             <a:ext cx="10881360" cy="457200"/>
           </a:xfrm>
           <a:prstGeom prst="rect">
@@ -8022,13 +8777,13 @@
               </a:spcAft>
             </a:pPr>
             <a:r>
-              <a:rPr sz="1400" b="0">
+              <a:rPr sz="1300" b="0">
                 <a:solidFill>
                   <a:srgbClr val="595959"/>
                 </a:solidFill>
                 <a:latin typeface="Calibri"/>
               </a:rPr>
-              <a:t>Visos vertės apytikslės; tikslūs skaičiavimai bus TA2 etape.</a:t>
+              <a:t>Šaltiniai: Roton Products (n.d.) – savistabdumo sąlyga. Lentelės vertės ir skaičiavimas – mūsų apytiksliai įvertinimai.</a:t>
             </a:r>
           </a:p>
         </p:txBody>
@@ -8085,7 +8840,7 @@
                 </a:solidFill>
                 <a:latin typeface="Calibri"/>
               </a:rPr>
-              <a:t>Išvados ir tolesni darbai</a:t>
+              <a:t>Išvados</a:t>
             </a:r>
           </a:p>
         </p:txBody>
@@ -8110,6 +8865,7 @@
           <a:ln>
             <a:noFill/>
           </a:ln>
+          <a:effectLst/>
         </p:spPr>
         <p:style>
           <a:lnRef idx="1">
@@ -8167,7 +8923,7 @@
                 </a:solidFill>
                 <a:latin typeface="Calibri"/>
               </a:rPr>
-              <a:t>8 / 9</a:t>
+              <a:t>8 / 10</a:t>
             </a:r>
           </a:p>
         </p:txBody>
@@ -8206,7 +8962,7 @@
                 </a:solidFill>
                 <a:latin typeface="Calibri"/>
               </a:rPr>
-              <a:t>PBL TA1 · Domkratas</a:t>
+              <a:t>PBL · Domkratas</a:t>
             </a:r>
           </a:p>
         </p:txBody>
@@ -8220,7 +8976,7 @@
         <p:spPr>
           <a:xfrm>
             <a:off x="640080" y="1554480"/>
-            <a:ext cx="6400800" cy="4206240"/>
+            <a:ext cx="6766560" cy="4206240"/>
           </a:xfrm>
           <a:prstGeom prst="rect">
             <a:avLst/>
@@ -8235,65 +8991,101 @@
           <a:p>
             <a:pPr algn="l">
               <a:spcAft>
-                <a:spcPts val="1600"/>
+                <a:spcPts val="1800"/>
               </a:spcAft>
             </a:pPr>
             <a:r>
-              <a:rPr sz="2000" b="0">
+              <a:rPr sz="2100" b="1">
                 <a:solidFill>
                   <a:srgbClr val="222222"/>
                 </a:solidFill>
                 <a:latin typeface="Calibri"/>
               </a:rPr>
-              <a:t>• Domkratai vystėsi nuo jėgos laimėjimo (svertas, sraigtas) per hidrauliką iki saugos ir patogumo.</a:t>
+              <a:t>• Raida</a:t>
+            </a:r>
+            <a:r>
+              <a:rPr sz="2100" b="0" i="0">
+                <a:solidFill>
+                  <a:srgbClr val="222222"/>
+                </a:solidFill>
+                <a:latin typeface="Calibri"/>
+              </a:rPr>
+              <a:t> – nuo jėgos laimėjimo (svertas, sraigtas) per hidrauliką iki elektrinių domkratų.</a:t>
             </a:r>
           </a:p>
           <a:p>
             <a:pPr>
               <a:spcAft>
-                <a:spcPts val="1600"/>
+                <a:spcPts val="1800"/>
               </a:spcAft>
             </a:pPr>
             <a:r>
-              <a:rPr sz="2000" b="0">
+              <a:rPr sz="2100" b="1">
                 <a:solidFill>
                   <a:srgbClr val="222222"/>
                 </a:solidFill>
                 <a:latin typeface="Calibri"/>
               </a:rPr>
-              <a:t>• Žirklinis domkratas kompaktiškas ir savistabdis, bet lėtas, sunkiai sukamas ir nestabilus.</a:t>
+              <a:t>• Problema</a:t>
+            </a:r>
+            <a:r>
+              <a:rPr sz="2100" b="0" i="0">
+                <a:solidFill>
+                  <a:srgbClr val="222222"/>
+                </a:solidFill>
+                <a:latin typeface="Calibri"/>
+              </a:rPr>
+              <a:t> – žirklinis domkratas kompaktiškas ir savistabdis, bet lėtas, sunkiai sukamas ir nestabilus.</a:t>
             </a:r>
           </a:p>
           <a:p>
             <a:pPr>
               <a:spcAft>
-                <a:spcPts val="1600"/>
+                <a:spcPts val="1800"/>
               </a:spcAft>
             </a:pPr>
             <a:r>
-              <a:rPr sz="2000" b="0">
+              <a:rPr sz="2100" b="1">
                 <a:solidFill>
                   <a:srgbClr val="222222"/>
                 </a:solidFill>
                 <a:latin typeface="Calibri"/>
               </a:rPr>
-              <a:t>• Siūlome 12 V elektrinę pavarą, Tr18×4 sraigtą su bronzine veržle, stipresnes svirtis ir platesnį pagrindą.</a:t>
+              <a:t>• Sprendimas</a:t>
+            </a:r>
+            <a:r>
+              <a:rPr sz="2100" b="0" i="0">
+                <a:solidFill>
+                  <a:srgbClr val="222222"/>
+                </a:solidFill>
+                <a:latin typeface="Calibri"/>
+              </a:rPr>
+              <a:t> – 12 V elektrinė pavara, trapecinis sraigtas su bronzine veržle, stipresnės svirtys, platesnis pagrindas.</a:t>
             </a:r>
           </a:p>
           <a:p>
             <a:pPr>
               <a:spcAft>
-                <a:spcPts val="1600"/>
+                <a:spcPts val="1800"/>
               </a:spcAft>
             </a:pPr>
             <a:r>
-              <a:rPr sz="2000" b="0">
+              <a:rPr sz="2100" b="1">
                 <a:solidFill>
                   <a:srgbClr val="222222"/>
                 </a:solidFill>
                 <a:latin typeface="Calibri"/>
               </a:rPr>
-              <a:t>• Kompromisas – šiek tiek didesnė masė ir kaina.</a:t>
+              <a:t>• Kompromisas</a:t>
+            </a:r>
+            <a:r>
+              <a:rPr sz="2100" b="0" i="0">
+                <a:solidFill>
+                  <a:srgbClr val="222222"/>
+                </a:solidFill>
+                <a:latin typeface="Calibri"/>
+              </a:rPr>
+              <a:t> – šiek tiek didesnė masė ir kaina.</a:t>
             </a:r>
           </a:p>
         </p:txBody>
@@ -8306,8 +9098,8 @@
         </p:nvSpPr>
         <p:spPr>
           <a:xfrm>
-            <a:off x="7406640" y="1600200"/>
-            <a:ext cx="4114800" cy="3108960"/>
+            <a:off x="7772400" y="2377440"/>
+            <a:ext cx="3749039" cy="1828800"/>
           </a:xfrm>
           <a:prstGeom prst="rect">
             <a:avLst/>
@@ -8350,8 +9142,8 @@
         </p:nvSpPr>
         <p:spPr>
           <a:xfrm>
-            <a:off x="7635240" y="1737360"/>
-            <a:ext cx="3657600" cy="2834640"/>
+            <a:off x="7772400" y="2377440"/>
+            <a:ext cx="3749039" cy="1828800"/>
           </a:xfrm>
           <a:prstGeom prst="rect">
             <a:avLst/>
@@ -8359,110 +9151,7 @@
           <a:noFill/>
         </p:spPr>
         <p:txBody>
-          <a:bodyPr wrap="square" anchor="t" lIns="45720" rIns="45720">
-            <a:spAutoFit/>
-          </a:bodyPr>
-          <a:lstStyle/>
-          <a:p>
-            <a:pPr algn="l">
-              <a:spcAft>
-                <a:spcPts val="800"/>
-              </a:spcAft>
-            </a:pPr>
-            <a:r>
-              <a:rPr sz="2100" b="1">
-                <a:solidFill>
-                  <a:srgbClr val="1F4E79"/>
-                </a:solidFill>
-                <a:latin typeface="Calibri"/>
-              </a:rPr>
-              <a:t>TA2 etape</a:t>
-            </a:r>
-          </a:p>
-          <a:p>
-            <a:pPr>
-              <a:spcAft>
-                <a:spcPts val="600"/>
-              </a:spcAft>
-            </a:pPr>
-            <a:r>
-              <a:rPr sz="1800" b="0">
-                <a:solidFill>
-                  <a:srgbClr val="222222"/>
-                </a:solidFill>
-                <a:latin typeface="Calibri"/>
-              </a:rPr>
-              <a:t>• naujausių patentų ir straipsnių analizė</a:t>
-            </a:r>
-          </a:p>
-          <a:p>
-            <a:pPr>
-              <a:spcAft>
-                <a:spcPts val="600"/>
-              </a:spcAft>
-            </a:pPr>
-            <a:r>
-              <a:rPr sz="1800" b="0">
-                <a:solidFill>
-                  <a:srgbClr val="222222"/>
-                </a:solidFill>
-                <a:latin typeface="Calibri"/>
-              </a:rPr>
-              <a:t>• sraigto ir veržlės stiprumo skaičiavimai</a:t>
-            </a:r>
-          </a:p>
-          <a:p>
-            <a:pPr>
-              <a:spcAft>
-                <a:spcPts val="600"/>
-              </a:spcAft>
-            </a:pPr>
-            <a:r>
-              <a:rPr sz="1800" b="0">
-                <a:solidFill>
-                  <a:srgbClr val="222222"/>
-                </a:solidFill>
-                <a:latin typeface="Calibri"/>
-              </a:rPr>
-              <a:t>• variklio ir reduktoriaus parinkimas</a:t>
-            </a:r>
-          </a:p>
-          <a:p>
-            <a:pPr>
-              <a:spcAft>
-                <a:spcPts val="600"/>
-              </a:spcAft>
-            </a:pPr>
-            <a:r>
-              <a:rPr sz="1800" b="0">
-                <a:solidFill>
-                  <a:srgbClr val="222222"/>
-                </a:solidFill>
-                <a:latin typeface="Calibri"/>
-              </a:rPr>
-              <a:t>• atitiktis standartui EN 1494, sauga</a:t>
-            </a:r>
-          </a:p>
-        </p:txBody>
-      </p:sp>
-      <p:sp>
-        <p:nvSpPr>
-          <p:cNvPr id="9" name="TextBox 8"/>
-          <p:cNvSpPr txBox="1"/>
-          <p:nvPr/>
-        </p:nvSpPr>
-        <p:spPr>
-          <a:xfrm>
-            <a:off x="7406640" y="4937760"/>
-            <a:ext cx="4114800" cy="731520"/>
-          </a:xfrm>
-          <a:prstGeom prst="rect">
-            <a:avLst/>
-          </a:prstGeom>
-          <a:noFill/>
-        </p:spPr>
-        <p:txBody>
-          <a:bodyPr wrap="square" anchor="t" lIns="45720" rIns="45720">
+          <a:bodyPr wrap="square" anchor="ctr" lIns="45720" rIns="45720">
             <a:spAutoFit/>
           </a:bodyPr>
           <a:lstStyle/>
@@ -8473,7 +9162,7 @@
               </a:spcAft>
             </a:pPr>
             <a:r>
-              <a:rPr sz="3200" b="1">
+              <a:rPr sz="3600" b="1">
                 <a:solidFill>
                   <a:srgbClr val="1F4E79"/>
                 </a:solidFill>
@@ -8536,7 +9225,7 @@
                 </a:solidFill>
                 <a:latin typeface="Calibri"/>
               </a:rPr>
-              <a:t>Šaltiniai</a:t>
+              <a:t>Šaltiniai (1/2)</a:t>
             </a:r>
           </a:p>
         </p:txBody>
@@ -8561,6 +9250,7 @@
           <a:ln>
             <a:noFill/>
           </a:ln>
+          <a:effectLst/>
         </p:spPr>
         <p:style>
           <a:lnRef idx="1">
@@ -8618,7 +9308,7 @@
                 </a:solidFill>
                 <a:latin typeface="Calibri"/>
               </a:rPr>
-              <a:t>9 / 9</a:t>
+              <a:t>9 / 10</a:t>
             </a:r>
           </a:p>
         </p:txBody>
@@ -8657,7 +9347,7 @@
                 </a:solidFill>
                 <a:latin typeface="Calibri"/>
               </a:rPr>
-              <a:t>PBL TA1 · Domkratas</a:t>
+              <a:t>PBL · Domkratas</a:t>
             </a:r>
           </a:p>
         </p:txBody>
@@ -8670,8 +9360,8 @@
         </p:nvSpPr>
         <p:spPr>
           <a:xfrm>
-            <a:off x="640080" y="1554480"/>
-            <a:ext cx="10881360" cy="4389120"/>
+            <a:off x="640080" y="1463040"/>
+            <a:ext cx="10881360" cy="4754880"/>
           </a:xfrm>
           <a:prstGeom prst="rect">
             <a:avLst/>
@@ -8686,190 +9376,190 @@
           <a:p>
             <a:pPr algn="l">
               <a:spcAft>
-                <a:spcPts val="1400"/>
+                <a:spcPts val="700"/>
               </a:spcAft>
             </a:pPr>
             <a:r>
-              <a:rPr sz="1800" b="0">
+              <a:rPr sz="1400" b="0">
                 <a:solidFill>
                   <a:srgbClr val="222222"/>
                 </a:solidFill>
                 <a:latin typeface="Calibri"/>
               </a:rPr>
-              <a:t>Budynas, R. G., &amp; Nisbett, J. K. (2020). </a:t>
-            </a:r>
-            <a:r>
-              <a:rPr sz="1800" i="1">
+              <a:t>AutoIndustriya. (n.d.). </a:t>
+            </a:r>
+            <a:r>
+              <a:rPr sz="1400" b="0" i="1">
                 <a:solidFill>
                   <a:srgbClr val="222222"/>
                 </a:solidFill>
                 <a:latin typeface="Calibri"/>
               </a:rPr>
-              <a:t>Shigley's mechanical engineering design</a:t>
-            </a:r>
-            <a:r>
-              <a:rPr sz="1800" i="0">
+              <a:t>Auto essentials: The story of the humble car jack</a:t>
+            </a:r>
+            <a:r>
+              <a:rPr sz="1400" b="0" i="0">
                 <a:solidFill>
                   <a:srgbClr val="222222"/>
                 </a:solidFill>
                 <a:latin typeface="Calibri"/>
               </a:rPr>
-              <a:t> (11th ed.). McGraw-Hill Education.</a:t>
+              <a:t>. https://www.autoindustriya.com/features/auto-essentials-the-story-of-the-humble-car-jack.html</a:t>
             </a:r>
           </a:p>
           <a:p>
             <a:pPr>
               <a:spcAft>
-                <a:spcPts val="1400"/>
+                <a:spcPts val="700"/>
               </a:spcAft>
             </a:pPr>
             <a:r>
-              <a:rPr sz="1800" b="0">
+              <a:rPr sz="1400" b="0">
                 <a:solidFill>
                   <a:srgbClr val="222222"/>
                 </a:solidFill>
                 <a:latin typeface="Calibri"/>
               </a:rPr>
-              <a:t>Childs, P. R. N. (2014). </a:t>
-            </a:r>
-            <a:r>
-              <a:rPr sz="1800" i="1">
+              <a:t>CJ Pony Parts. (n.d.). </a:t>
+            </a:r>
+            <a:r>
+              <a:rPr sz="1400" b="0" i="1">
                 <a:solidFill>
                   <a:srgbClr val="222222"/>
                 </a:solidFill>
                 <a:latin typeface="Calibri"/>
               </a:rPr>
-              <a:t>Mechanical design engineering handbook</a:t>
-            </a:r>
-            <a:r>
-              <a:rPr sz="1800" i="0">
+              <a:t>Types of car jacks</a:t>
+            </a:r>
+            <a:r>
+              <a:rPr sz="1400" b="0" i="0">
                 <a:solidFill>
                   <a:srgbClr val="222222"/>
                 </a:solidFill>
                 <a:latin typeface="Calibri"/>
               </a:rPr>
-              <a:t>. Butterworth-Heinemann.</a:t>
+              <a:t>. https://www.cjponyparts.com/resources/types-of-car-jacks</a:t>
             </a:r>
           </a:p>
           <a:p>
             <a:pPr>
               <a:spcAft>
-                <a:spcPts val="1400"/>
+                <a:spcPts val="700"/>
               </a:spcAft>
             </a:pPr>
             <a:r>
-              <a:rPr sz="1800" b="0">
+              <a:rPr sz="1400" b="0">
                 <a:solidFill>
                   <a:srgbClr val="222222"/>
                 </a:solidFill>
                 <a:latin typeface="Calibri"/>
               </a:rPr>
-              <a:t>European Committee for Standardization. (2008). </a:t>
-            </a:r>
-            <a:r>
-              <a:rPr sz="1800" i="1">
+              <a:t>CN Trailer Parts. (n.d.). </a:t>
+            </a:r>
+            <a:r>
+              <a:rPr sz="1400" b="0" i="1">
                 <a:solidFill>
                   <a:srgbClr val="222222"/>
                 </a:solidFill>
                 <a:latin typeface="Calibri"/>
               </a:rPr>
-              <a:t>Mobile or movable jacks and associated lifting equipment</a:t>
-            </a:r>
-            <a:r>
-              <a:rPr sz="1800" i="0">
+              <a:t>What are the disadvantages of a scissor jack?</a:t>
+            </a:r>
+            <a:r>
+              <a:rPr sz="1400" b="0" i="0">
                 <a:solidFill>
                   <a:srgbClr val="222222"/>
                 </a:solidFill>
                 <a:latin typeface="Calibri"/>
               </a:rPr>
-              <a:t> (EN 1494:2000+A1:2008).</a:t>
+              <a:t> https://www.cntrailerparts.com/blog/what-are-the-disadvantages-of-a-scissor-jack-372667.html</a:t>
             </a:r>
           </a:p>
           <a:p>
             <a:pPr>
               <a:spcAft>
-                <a:spcPts val="1400"/>
+                <a:spcPts val="700"/>
               </a:spcAft>
             </a:pPr>
             <a:r>
-              <a:rPr sz="1800" b="0">
+              <a:rPr sz="1400" b="0">
                 <a:solidFill>
                   <a:srgbClr val="222222"/>
                 </a:solidFill>
                 <a:latin typeface="Calibri"/>
               </a:rPr>
-              <a:t>Europos Parlamentas ir Taryba. (2023). </a:t>
-            </a:r>
-            <a:r>
-              <a:rPr sz="1800" i="1">
+              <a:t>Gnee Steel. (n.d.). </a:t>
+            </a:r>
+            <a:r>
+              <a:rPr sz="1400" b="0" i="1">
                 <a:solidFill>
                   <a:srgbClr val="222222"/>
                 </a:solidFill>
                 <a:latin typeface="Calibri"/>
               </a:rPr>
-              <a:t>Reglamentas (ES) 2023/1230 dėl mašinų</a:t>
-            </a:r>
-            <a:r>
-              <a:rPr sz="1800" i="0">
+              <a:t>EN 10149-2 S420MC hot rolled automotive steel</a:t>
+            </a:r>
+            <a:r>
+              <a:rPr sz="1400" b="0" i="0">
                 <a:solidFill>
                   <a:srgbClr val="222222"/>
                 </a:solidFill>
                 <a:latin typeface="Calibri"/>
               </a:rPr>
-              <a:t>. Europos Sąjungos oficialusis leidinys.</a:t>
+              <a:t>. https://www.gneesteel.com/products/automotive-steel/en-10149-2-s420mc-hot-rolled-automotive-steel.html</a:t>
             </a:r>
           </a:p>
           <a:p>
             <a:pPr>
               <a:spcAft>
-                <a:spcPts val="1400"/>
+                <a:spcPts val="700"/>
               </a:spcAft>
             </a:pPr>
             <a:r>
-              <a:rPr sz="1800" b="0">
+              <a:rPr sz="1400" b="0">
                 <a:solidFill>
                   <a:srgbClr val="222222"/>
                 </a:solidFill>
                 <a:latin typeface="Calibri"/>
               </a:rPr>
-              <a:t>Encyclopaedia Britannica. (n.d.). </a:t>
-            </a:r>
-            <a:r>
-              <a:rPr sz="1800" i="1">
+              <a:t>Hengli Automation. (n.d.). </a:t>
+            </a:r>
+            <a:r>
+              <a:rPr sz="1400" b="0" i="1">
                 <a:solidFill>
                   <a:srgbClr val="222222"/>
                 </a:solidFill>
                 <a:latin typeface="Calibri"/>
               </a:rPr>
-              <a:t>Jack</a:t>
-            </a:r>
-            <a:r>
-              <a:rPr sz="1800" i="0">
+              <a:t>What is the material of the nut for a T lead screw?</a:t>
+            </a:r>
+            <a:r>
+              <a:rPr sz="1400" b="0" i="0">
                 <a:solidFill>
                   <a:srgbClr val="222222"/>
                 </a:solidFill>
                 <a:latin typeface="Calibri"/>
               </a:rPr>
-              <a:t>. Retrieved [data], from https://www.britannica.com</a:t>
+              <a:t> https://www.hlt-cnc.com/blog/what-is-the-material-of-the-nut-for-a-t-lead-screw-1318622.html</a:t>
             </a:r>
           </a:p>
           <a:p>
             <a:pPr>
               <a:spcAft>
-                <a:spcPts val="1400"/>
+                <a:spcPts val="700"/>
               </a:spcAft>
             </a:pPr>
             <a:r>
-              <a:rPr sz="1800" b="0">
+              <a:rPr sz="1400" b="0">
                 <a:solidFill>
                   <a:srgbClr val="222222"/>
                 </a:solidFill>
                 <a:latin typeface="Calibri"/>
               </a:rPr>
-              <a:t>Hi-Lift Jack Company. (n.d.). </a:t>
-            </a:r>
-            <a:r>
-              <a:rPr sz="1800" i="1">
+              <a:t>Hi-Lift Jack Company. (n.d.-a). </a:t>
+            </a:r>
+            <a:r>
+              <a:rPr sz="1400" b="0" i="1">
                 <a:solidFill>
                   <a:srgbClr val="222222"/>
                 </a:solidFill>
@@ -8878,13 +9568,149 @@
               <a:t>Our history</a:t>
             </a:r>
             <a:r>
-              <a:rPr sz="1800" i="0">
+              <a:rPr sz="1400" b="0" i="0">
                 <a:solidFill>
                   <a:srgbClr val="222222"/>
                 </a:solidFill>
                 <a:latin typeface="Calibri"/>
               </a:rPr>
-              <a:t>. Retrieved [data], from https://www.hi-lift.com</a:t>
+              <a:t>. https://hi-lift.com/company/our-history/</a:t>
+            </a:r>
+          </a:p>
+          <a:p>
+            <a:pPr>
+              <a:spcAft>
+                <a:spcPts val="700"/>
+              </a:spcAft>
+            </a:pPr>
+            <a:r>
+              <a:rPr sz="1400" b="0">
+                <a:solidFill>
+                  <a:srgbClr val="222222"/>
+                </a:solidFill>
+                <a:latin typeface="Calibri"/>
+              </a:rPr>
+              <a:t>Hi-Lift Jack Company. (n.d.-b). </a:t>
+            </a:r>
+            <a:r>
+              <a:rPr sz="1400" b="0" i="1">
+                <a:solidFill>
+                  <a:srgbClr val="222222"/>
+                </a:solidFill>
+                <a:latin typeface="Calibri"/>
+              </a:rPr>
+              <a:t>Hi-Lift jack instructions</a:t>
+            </a:r>
+            <a:r>
+              <a:rPr sz="1400" b="0" i="0">
+                <a:solidFill>
+                  <a:srgbClr val="222222"/>
+                </a:solidFill>
+                <a:latin typeface="Calibri"/>
+              </a:rPr>
+              <a:t> [PDF]. https://hi-lift.com/wp-content/uploads/2016/07/jack_instructions.pdf</a:t>
+            </a:r>
+          </a:p>
+          <a:p>
+            <a:pPr>
+              <a:spcAft>
+                <a:spcPts val="700"/>
+              </a:spcAft>
+            </a:pPr>
+            <a:r>
+              <a:rPr sz="1400" b="0">
+                <a:solidFill>
+                  <a:srgbClr val="222222"/>
+                </a:solidFill>
+                <a:latin typeface="Calibri"/>
+              </a:rPr>
+              <a:t>Joyce/Dayton. (n.d.). </a:t>
+            </a:r>
+            <a:r>
+              <a:rPr sz="1400" b="0" i="1">
+                <a:solidFill>
+                  <a:srgbClr val="222222"/>
+                </a:solidFill>
+                <a:latin typeface="Calibri"/>
+              </a:rPr>
+              <a:t>Machine screw jacks vs. ball screw jacks</a:t>
+            </a:r>
+            <a:r>
+              <a:rPr sz="1400" b="0" i="0">
+                <a:solidFill>
+                  <a:srgbClr val="222222"/>
+                </a:solidFill>
+                <a:latin typeface="Calibri"/>
+              </a:rPr>
+              <a:t>. https://www.joycedayton.com/blog/machine-screw-jacks-vs-ball-screw-jacks</a:t>
+            </a:r>
+          </a:p>
+          <a:p>
+            <a:pPr>
+              <a:spcAft>
+                <a:spcPts val="700"/>
+              </a:spcAft>
+            </a:pPr>
+            <a:r>
+              <a:rPr sz="1400" b="0">
+                <a:solidFill>
+                  <a:srgbClr val="222222"/>
+                </a:solidFill>
+                <a:latin typeface="Calibri"/>
+              </a:rPr>
+              <a:t>LibreTexts. (n.d.). </a:t>
+            </a:r>
+            <a:r>
+              <a:rPr sz="1400" b="0" i="1">
+                <a:solidFill>
+                  <a:srgbClr val="222222"/>
+                </a:solidFill>
+                <a:latin typeface="Calibri"/>
+              </a:rPr>
+              <a:t>10.2: Force multiplication</a:t>
+            </a:r>
+            <a:r>
+              <a:rPr sz="1400" b="0" i="0">
+                <a:solidFill>
+                  <a:srgbClr val="222222"/>
+                </a:solidFill>
+                <a:latin typeface="Calibri"/>
+              </a:rPr>
+              <a:t>. https://eng.libretexts.org/Courses/Northeast_Wisconsin_Technical_College/Fluids_1:_Fluid_Power_and_Pneumatics_(NWTC)/10:_Pascal's_Law/10.02:_Force_Multiplication</a:t>
+            </a:r>
+          </a:p>
+          <a:p>
+            <a:pPr>
+              <a:spcAft>
+                <a:spcPts val="700"/>
+              </a:spcAft>
+            </a:pPr>
+            <a:r>
+              <a:rPr sz="1400" b="0">
+                <a:solidFill>
+                  <a:srgbClr val="222222"/>
+                </a:solidFill>
+                <a:latin typeface="Calibri"/>
+              </a:rPr>
+              <a:t>Mickael, E. (2004). </a:t>
+            </a:r>
+            <a:r>
+              <a:rPr sz="1400" b="0" i="1">
+                <a:solidFill>
+                  <a:srgbClr val="222222"/>
+                </a:solidFill>
+                <a:latin typeface="Calibri"/>
+              </a:rPr>
+              <a:t>Motor driven scissor jack with limit switches</a:t>
+            </a:r>
+            <a:r>
+              <a:rPr sz="1400" b="0" i="0">
+                <a:solidFill>
+                  <a:srgbClr val="222222"/>
+                </a:solidFill>
+                <a:latin typeface="Calibri"/>
+              </a:rPr>
+              <a:t> (U.S. Patent No. 6,695,289). https://patents.google.com/patent/US6695289B1/en</a:t>
             </a:r>
           </a:p>
         </p:txBody>

</xml_diff>

<commit_message>
Add Heron's Mechanics and Roman treadwheel crane to history slide
Co-Authored-By: Claude Opus 5.5 <noreply@anthropic.com>
Claude-Session: https://claude.ai/code/session_01A3dr5uNJtqowxFZtjwACBv
</commit_message>
<xml_diff>
--- a/domkratas-ta1/domkratas-ta1.pptx
+++ b/domkratas-ta1/domkratas-ta1.pptx
@@ -651,7 +651,7 @@
           <a:lstStyle/>
           <a:p>
             <a:r>
-              <a:t>Raida: nuo Archimedo sverto ir antikinių sraigtinių presų per Bramah ir Dudgeon hidrauliką iki žirklinių ir elektrinių domkratų. Tendencija – nuo jėgos laimėjimo link greičio, saugos ir patogumo.</a:t>
+              <a:t>Raida: nuo Archimedo sverto, antikinių sraigtinių presų, Herono kėlimo mechanizmų ir romėnų kranų per Bramah ir Dudgeon hidrauliką iki žirklinių ir elektrinių domkratų. Tendencija – nuo jėgos laimėjimo link greičio, saugos ir patogumo.</a:t>
             </a:r>
           </a:p>
         </p:txBody>
@@ -4413,7 +4413,7 @@
                 </a:solidFill>
                 <a:latin typeface="Calibri"/>
               </a:rPr>
-              <a:t>Pro-Lift-Montagetechnik. (n.d.). </a:t>
+              <a:t>Redline Stands. (n.d.). </a:t>
             </a:r>
             <a:r>
               <a:rPr sz="1400" b="0" i="1">
@@ -4422,7 +4422,7 @@
                 </a:solidFill>
                 <a:latin typeface="Calibri"/>
               </a:rPr>
-              <a:t>12V electric scissor jack, car jack, 123 mm – 345 mm</a:t>
+              <a:t>Bottle jack vs. floor jack: Differences, pros, and cons</a:t>
             </a:r>
             <a:r>
               <a:rPr sz="1400" b="0" i="0">
@@ -4431,7 +4431,7 @@
                 </a:solidFill>
                 <a:latin typeface="Calibri"/>
               </a:rPr>
-              <a:t>. https://www.pro-lift-montagetechnik.com/12-volt-electric-scissor-jack-car-jack-123mm-345mm-002</a:t>
+              <a:t>. https://www.redlinestands.com/blog/bottle-jack-vs-floor-jack/</a:t>
             </a:r>
           </a:p>
           <a:p>
@@ -4447,7 +4447,7 @@
                 </a:solidFill>
                 <a:latin typeface="Calibri"/>
               </a:rPr>
-              <a:t>Redline Stands. (n.d.). </a:t>
+              <a:t>Rorres, C. (n.d.). </a:t>
             </a:r>
             <a:r>
               <a:rPr sz="1400" b="0" i="1">
@@ -4456,7 +4456,7 @@
                 </a:solidFill>
                 <a:latin typeface="Calibri"/>
               </a:rPr>
-              <a:t>Bottle jack vs. floor jack: Differences, pros, and cons</a:t>
+              <a:t>Quotations about Archimedes' lever</a:t>
             </a:r>
             <a:r>
               <a:rPr sz="1400" b="0" i="0">
@@ -4465,7 +4465,7 @@
                 </a:solidFill>
                 <a:latin typeface="Calibri"/>
               </a:rPr>
-              <a:t>. https://www.redlinestands.com/blog/bottle-jack-vs-floor-jack/</a:t>
+              <a:t>. New York University. https://math.nyu.edu/Archimedes/Lever/LeverQuotes.html</a:t>
             </a:r>
           </a:p>
           <a:p>
@@ -4481,7 +4481,7 @@
                 </a:solidFill>
                 <a:latin typeface="Calibri"/>
               </a:rPr>
-              <a:t>Rorres, C. (n.d.). </a:t>
+              <a:t>Roton Products. (n.d.). </a:t>
             </a:r>
             <a:r>
               <a:rPr sz="1400" b="0" i="1">
@@ -4490,7 +4490,7 @@
                 </a:solidFill>
                 <a:latin typeface="Calibri"/>
               </a:rPr>
-              <a:t>Quotations about Archimedes' lever</a:t>
+              <a:t>Trapezoidal lead screws: General information</a:t>
             </a:r>
             <a:r>
               <a:rPr sz="1400" b="0" i="0">
@@ -4499,7 +4499,7 @@
                 </a:solidFill>
                 <a:latin typeface="Calibri"/>
               </a:rPr>
-              <a:t>. New York University. https://math.nyu.edu/Archimedes/Lever/LeverQuotes.html</a:t>
+              <a:t>. https://www.roton.com/products/trapezoidal-lead-screws-nuts/general-information/</a:t>
             </a:r>
           </a:p>
           <a:p>
@@ -4515,7 +4515,7 @@
                 </a:solidFill>
                 <a:latin typeface="Calibri"/>
               </a:rPr>
-              <a:t>Roton Products. (n.d.). </a:t>
+              <a:t>Sider Ticino. (n.d.). </a:t>
             </a:r>
             <a:r>
               <a:rPr sz="1400" b="0" i="1">
@@ -4524,7 +4524,7 @@
                 </a:solidFill>
                 <a:latin typeface="Calibri"/>
               </a:rPr>
-              <a:t>Trapezoidal lead screws: General information</a:t>
+              <a:t>42CrMo4 technical specifications</a:t>
             </a:r>
             <a:r>
               <a:rPr sz="1400" b="0" i="0">
@@ -4533,7 +4533,7 @@
                 </a:solidFill>
                 <a:latin typeface="Calibri"/>
               </a:rPr>
-              <a:t>. https://www.roton.com/products/trapezoidal-lead-screws-nuts/general-information/</a:t>
+              <a:t>. https://siderticino.it/en/steel-datasheets/42crmo4/</a:t>
             </a:r>
           </a:p>
           <a:p>
@@ -4549,7 +4549,7 @@
                 </a:solidFill>
                 <a:latin typeface="Calibri"/>
               </a:rPr>
-              <a:t>Sider Ticino. (n.d.). </a:t>
+              <a:t>The World Material. (n.d.). </a:t>
             </a:r>
             <a:r>
               <a:rPr sz="1400" b="0" i="1">
@@ -4558,7 +4558,7 @@
                 </a:solidFill>
                 <a:latin typeface="Calibri"/>
               </a:rPr>
-              <a:t>42CrMo4 technical specifications</a:t>
+              <a:t>EN 10025-2 S235 steel properties</a:t>
             </a:r>
             <a:r>
               <a:rPr sz="1400" b="0" i="0">
@@ -4567,7 +4567,7 @@
                 </a:solidFill>
                 <a:latin typeface="Calibri"/>
               </a:rPr>
-              <a:t>. https://siderticino.it/en/steel-datasheets/42crmo4/</a:t>
+              <a:t>. https://www.theworldmaterial.com/en-10025-2-material-s235-steel/</a:t>
             </a:r>
           </a:p>
           <a:p>
@@ -4583,7 +4583,7 @@
                 </a:solidFill>
                 <a:latin typeface="Calibri"/>
               </a:rPr>
-              <a:t>The World Material. (n.d.). </a:t>
+              <a:t>Wikipedia. (n.d.-a). </a:t>
             </a:r>
             <a:r>
               <a:rPr sz="1400" b="0" i="1">
@@ -4592,7 +4592,7 @@
                 </a:solidFill>
                 <a:latin typeface="Calibri"/>
               </a:rPr>
-              <a:t>EN 10025-2 S235 steel properties</a:t>
+              <a:t>Jack (device)</a:t>
             </a:r>
             <a:r>
               <a:rPr sz="1400" b="0" i="0">
@@ -4601,7 +4601,7 @@
                 </a:solidFill>
                 <a:latin typeface="Calibri"/>
               </a:rPr>
-              <a:t>. https://www.theworldmaterial.com/en-10025-2-material-s235-steel/</a:t>
+              <a:t>. https://en.wikipedia.org/wiki/Jack_(device)</a:t>
             </a:r>
           </a:p>
           <a:p>
@@ -4617,7 +4617,7 @@
                 </a:solidFill>
                 <a:latin typeface="Calibri"/>
               </a:rPr>
-              <a:t>Wikipedia. (n.d.-a). </a:t>
+              <a:t>Wikipedia. (n.d.-b). </a:t>
             </a:r>
             <a:r>
               <a:rPr sz="1400" b="0" i="1">
@@ -4626,7 +4626,7 @@
                 </a:solidFill>
                 <a:latin typeface="Calibri"/>
               </a:rPr>
-              <a:t>Joseph Bramah</a:t>
+              <a:t>Jackscrew</a:t>
             </a:r>
             <a:r>
               <a:rPr sz="1400" b="0" i="0">
@@ -4635,7 +4635,7 @@
                 </a:solidFill>
                 <a:latin typeface="Calibri"/>
               </a:rPr>
-              <a:t>. https://en.wikipedia.org/wiki/Joseph_Bramah</a:t>
+              <a:t>. https://en.wikipedia.org/wiki/Jackscrew</a:t>
             </a:r>
           </a:p>
           <a:p>
@@ -4651,7 +4651,7 @@
                 </a:solidFill>
                 <a:latin typeface="Calibri"/>
               </a:rPr>
-              <a:t>Wikipedia. (n.d.-b). </a:t>
+              <a:t>Wikipedia. (n.d.-c). </a:t>
             </a:r>
             <a:r>
               <a:rPr sz="1400" b="0" i="1">
@@ -4660,7 +4660,7 @@
                 </a:solidFill>
                 <a:latin typeface="Calibri"/>
               </a:rPr>
-              <a:t>Richard Dudgeon</a:t>
+              <a:t>Joseph Bramah</a:t>
             </a:r>
             <a:r>
               <a:rPr sz="1400" b="0" i="0">
@@ -4669,7 +4669,7 @@
                 </a:solidFill>
                 <a:latin typeface="Calibri"/>
               </a:rPr>
-              <a:t>. https://en.wikipedia.org/wiki/Richard_Dudgeon</a:t>
+              <a:t>. https://en.wikipedia.org/wiki/Joseph_Bramah</a:t>
             </a:r>
           </a:p>
           <a:p>
@@ -4685,7 +4685,7 @@
                 </a:solidFill>
                 <a:latin typeface="Calibri"/>
               </a:rPr>
-              <a:t>Wikipedia. (n.d.-c). </a:t>
+              <a:t>Wikipedia. (n.d.-d). </a:t>
             </a:r>
             <a:r>
               <a:rPr sz="1400" b="0" i="1">
@@ -4694,7 +4694,7 @@
                 </a:solidFill>
                 <a:latin typeface="Calibri"/>
               </a:rPr>
-              <a:t>Jack (device)</a:t>
+              <a:t>Richard Dudgeon</a:t>
             </a:r>
             <a:r>
               <a:rPr sz="1400" b="0" i="0">
@@ -4703,7 +4703,7 @@
                 </a:solidFill>
                 <a:latin typeface="Calibri"/>
               </a:rPr>
-              <a:t>. https://en.wikipedia.org/wiki/Jack_(device)</a:t>
+              <a:t>. https://en.wikipedia.org/wiki/Richard_Dudgeon</a:t>
             </a:r>
           </a:p>
           <a:p>
@@ -4719,7 +4719,7 @@
                 </a:solidFill>
                 <a:latin typeface="Calibri"/>
               </a:rPr>
-              <a:t>Wikipedia. (n.d.-d). </a:t>
+              <a:t>Wikipedia. (n.d.-e). </a:t>
             </a:r>
             <a:r>
               <a:rPr sz="1400" b="0" i="1">
@@ -4728,7 +4728,7 @@
                 </a:solidFill>
                 <a:latin typeface="Calibri"/>
               </a:rPr>
-              <a:t>Jackscrew</a:t>
+              <a:t>Simple machine</a:t>
             </a:r>
             <a:r>
               <a:rPr sz="1400" b="0" i="0">
@@ -4737,7 +4737,41 @@
                 </a:solidFill>
                 <a:latin typeface="Calibri"/>
               </a:rPr>
-              <a:t>. https://en.wikipedia.org/wiki/Jackscrew</a:t>
+              <a:t>. https://en.wikipedia.org/wiki/Simple_machine</a:t>
+            </a:r>
+          </a:p>
+          <a:p>
+            <a:pPr>
+              <a:spcAft>
+                <a:spcPts val="700"/>
+              </a:spcAft>
+            </a:pPr>
+            <a:r>
+              <a:rPr sz="1400" b="0">
+                <a:solidFill>
+                  <a:srgbClr val="222222"/>
+                </a:solidFill>
+                <a:latin typeface="Calibri"/>
+              </a:rPr>
+              <a:t>Wikipedia. (n.d.-f). </a:t>
+            </a:r>
+            <a:r>
+              <a:rPr sz="1400" b="0" i="1">
+                <a:solidFill>
+                  <a:srgbClr val="222222"/>
+                </a:solidFill>
+                <a:latin typeface="Calibri"/>
+              </a:rPr>
+              <a:t>Treadwheel crane</a:t>
+            </a:r>
+            <a:r>
+              <a:rPr sz="1400" b="0" i="0">
+                <a:solidFill>
+                  <a:srgbClr val="222222"/>
+                </a:solidFill>
+                <a:latin typeface="Calibri"/>
+              </a:rPr>
+              <a:t>. https://en.wikipedia.org/wiki/Treadwheel_crane</a:t>
             </a:r>
           </a:p>
         </p:txBody>
@@ -5007,7 +5041,7 @@
                 </a:solidFill>
                 <a:latin typeface="Calibri"/>
               </a:rPr>
-              <a:t> (Hi-Lift Jack Company, n.d.-a; Wikipedia, n.d.-b)</a:t>
+              <a:t> (Hi-Lift Jack Company, n.d.-a; Wikipedia, n.d.-d)</a:t>
             </a:r>
           </a:p>
           <a:p>
@@ -5294,7 +5328,7 @@
         </p:nvGraphicFramePr>
         <p:xfrm>
           <a:off x="640080" y="1463040"/>
-          <a:ext cx="10881360" cy="4279392"/>
+          <a:ext cx="10881360" cy="4325112"/>
         </p:xfrm>
         <a:graphic>
           <a:graphicData uri="http://schemas.openxmlformats.org/drawingml/2006/table">
@@ -5306,14 +5340,14 @@
                 <a:gridCol w="2011680"/>
                 <a:gridCol w="8869680"/>
               </a:tblGrid>
-              <a:tr h="475488">
+              <a:tr h="393192">
                 <a:tc>
                   <a:txBody>
                     <a:bodyPr/>
                     <a:lstStyle/>
                     <a:p>
                       <a:r>
-                        <a:rPr sz="1600" b="1" i="0">
+                        <a:rPr sz="1500" b="1" i="0">
                           <a:solidFill>
                             <a:srgbClr val="FFFFFF"/>
                           </a:solidFill>
@@ -5335,7 +5369,7 @@
                     <a:lstStyle/>
                     <a:p>
                       <a:r>
-                        <a:rPr sz="1600" b="1" i="0">
+                        <a:rPr sz="1500" b="1" i="0">
                           <a:solidFill>
                             <a:srgbClr val="FFFFFF"/>
                           </a:solidFill>
@@ -5352,14 +5386,14 @@
                   </a:tcPr>
                 </a:tc>
               </a:tr>
-              <a:tr h="475488">
+              <a:tr h="393192">
                 <a:tc>
                   <a:txBody>
                     <a:bodyPr/>
                     <a:lstStyle/>
                     <a:p>
                       <a:r>
-                        <a:rPr sz="1600" b="1" i="0">
+                        <a:rPr sz="1500" b="1" i="0">
                           <a:solidFill>
                             <a:srgbClr val="222222"/>
                           </a:solidFill>
@@ -5381,7 +5415,7 @@
                     <a:lstStyle/>
                     <a:p>
                       <a:r>
-                        <a:rPr sz="1600" b="0" i="0">
+                        <a:rPr sz="1500" b="0" i="0">
                           <a:solidFill>
                             <a:srgbClr val="222222"/>
                           </a:solidFill>
@@ -5398,14 +5432,14 @@
                   </a:tcPr>
                 </a:tc>
               </a:tr>
-              <a:tr h="475488">
+              <a:tr h="393192">
                 <a:tc>
                   <a:txBody>
                     <a:bodyPr/>
                     <a:lstStyle/>
                     <a:p>
                       <a:r>
-                        <a:rPr sz="1600" b="1" i="0">
+                        <a:rPr sz="1500" b="1" i="0">
                           <a:solidFill>
                             <a:srgbClr val="222222"/>
                           </a:solidFill>
@@ -5427,7 +5461,7 @@
                     <a:lstStyle/>
                     <a:p>
                       <a:r>
-                        <a:rPr sz="1600" b="0" i="0">
+                        <a:rPr sz="1500" b="0" i="0">
                           <a:solidFill>
                             <a:srgbClr val="222222"/>
                           </a:solidFill>
@@ -5444,14 +5478,106 @@
                   </a:tcPr>
                 </a:tc>
               </a:tr>
-              <a:tr h="475488">
+              <a:tr h="393192">
                 <a:tc>
                   <a:txBody>
                     <a:bodyPr/>
                     <a:lstStyle/>
                     <a:p>
                       <a:r>
-                        <a:rPr sz="1600" b="1" i="0">
+                        <a:rPr sz="1500" b="1" i="0">
+                          <a:solidFill>
+                            <a:srgbClr val="222222"/>
+                          </a:solidFill>
+                          <a:latin typeface="Calibri"/>
+                        </a:rPr>
+                        <a:t>~10–75 m.</a:t>
+                      </a:r>
+                    </a:p>
+                  </a:txBody>
+                  <a:tcPr marL="73152" marR="73152" anchor="ctr">
+                    <a:solidFill>
+                      <a:srgbClr val="FFFFFF"/>
+                    </a:solidFill>
+                  </a:tcPr>
+                </a:tc>
+                <a:tc>
+                  <a:txBody>
+                    <a:bodyPr/>
+                    <a:lstStyle/>
+                    <a:p>
+                      <a:r>
+                        <a:rPr sz="1500" b="0" i="0">
+                          <a:solidFill>
+                            <a:srgbClr val="222222"/>
+                          </a:solidFill>
+                          <a:latin typeface="Calibri"/>
+                        </a:rPr>
+                        <a:t>Heronas Aleksandrietis „Mechanikoje“ aprašo kėlimo mechanizmus: svertą, suktuvą, skridinį, pleištą ir sraigtą</a:t>
+                      </a:r>
+                    </a:p>
+                  </a:txBody>
+                  <a:tcPr marL="73152" marR="73152" anchor="ctr">
+                    <a:solidFill>
+                      <a:srgbClr val="FFFFFF"/>
+                    </a:solidFill>
+                  </a:tcPr>
+                </a:tc>
+              </a:tr>
+              <a:tr h="393192">
+                <a:tc>
+                  <a:txBody>
+                    <a:bodyPr/>
+                    <a:lstStyle/>
+                    <a:p>
+                      <a:r>
+                        <a:rPr sz="1500" b="1" i="0">
+                          <a:solidFill>
+                            <a:srgbClr val="222222"/>
+                          </a:solidFill>
+                          <a:latin typeface="Calibri"/>
+                        </a:rPr>
+                        <a:t>I a. pab.</a:t>
+                      </a:r>
+                    </a:p>
+                  </a:txBody>
+                  <a:tcPr marL="73152" marR="73152" anchor="ctr">
+                    <a:solidFill>
+                      <a:srgbClr val="FFFFFF"/>
+                    </a:solidFill>
+                  </a:tcPr>
+                </a:tc>
+                <a:tc>
+                  <a:txBody>
+                    <a:bodyPr/>
+                    <a:lstStyle/>
+                    <a:p>
+                      <a:r>
+                        <a:rPr sz="1500" b="0" i="0">
+                          <a:solidFill>
+                            <a:srgbClr val="222222"/>
+                          </a:solidFill>
+                          <a:latin typeface="Calibri"/>
+                        </a:rPr>
+                        <a:t>Romėnų kranas su mindomu ratu („polyspastos“) kelia iki ~6000 kg</a:t>
+                      </a:r>
+                    </a:p>
+                  </a:txBody>
+                  <a:tcPr marL="73152" marR="73152" anchor="ctr">
+                    <a:solidFill>
+                      <a:srgbClr val="FFFFFF"/>
+                    </a:solidFill>
+                  </a:tcPr>
+                </a:tc>
+              </a:tr>
+              <a:tr h="393192">
+                <a:tc>
+                  <a:txBody>
+                    <a:bodyPr/>
+                    <a:lstStyle/>
+                    <a:p>
+                      <a:r>
+                        <a:rPr sz="1500" b="1" i="0">
                           <a:solidFill>
                             <a:srgbClr val="222222"/>
                           </a:solidFill>
@@ -5473,7 +5599,7 @@
                     <a:lstStyle/>
                     <a:p>
                       <a:r>
-                        <a:rPr sz="1600" b="0" i="0">
+                        <a:rPr sz="1500" b="0" i="0">
                           <a:solidFill>
                             <a:srgbClr val="222222"/>
                           </a:solidFill>
@@ -5490,14 +5616,14 @@
                   </a:tcPr>
                 </a:tc>
               </a:tr>
-              <a:tr h="475488">
+              <a:tr h="393192">
                 <a:tc>
                   <a:txBody>
                     <a:bodyPr/>
                     <a:lstStyle/>
                     <a:p>
                       <a:r>
-                        <a:rPr sz="1600" b="1" i="0">
+                        <a:rPr sz="1500" b="1" i="0">
                           <a:solidFill>
                             <a:srgbClr val="222222"/>
                           </a:solidFill>
@@ -5519,7 +5645,7 @@
                     <a:lstStyle/>
                     <a:p>
                       <a:r>
-                        <a:rPr sz="1600" b="0" i="0">
+                        <a:rPr sz="1500" b="0" i="0">
                           <a:solidFill>
                             <a:srgbClr val="222222"/>
                           </a:solidFill>
@@ -5536,14 +5662,14 @@
                   </a:tcPr>
                 </a:tc>
               </a:tr>
-              <a:tr h="475488">
+              <a:tr h="393192">
                 <a:tc>
                   <a:txBody>
                     <a:bodyPr/>
                     <a:lstStyle/>
                     <a:p>
                       <a:r>
-                        <a:rPr sz="1600" b="1" i="0">
+                        <a:rPr sz="1500" b="1" i="0">
                           <a:solidFill>
                             <a:srgbClr val="222222"/>
                           </a:solidFill>
@@ -5565,7 +5691,7 @@
                     <a:lstStyle/>
                     <a:p>
                       <a:r>
-                        <a:rPr sz="1600" b="0" i="0">
+                        <a:rPr sz="1500" b="0" i="0">
                           <a:solidFill>
                             <a:srgbClr val="222222"/>
                           </a:solidFill>
@@ -5582,14 +5708,14 @@
                   </a:tcPr>
                 </a:tc>
               </a:tr>
-              <a:tr h="475488">
+              <a:tr h="393192">
                 <a:tc>
                   <a:txBody>
                     <a:bodyPr/>
                     <a:lstStyle/>
                     <a:p>
                       <a:r>
-                        <a:rPr sz="1600" b="1" i="0">
+                        <a:rPr sz="1500" b="1" i="0">
                           <a:solidFill>
                             <a:srgbClr val="222222"/>
                           </a:solidFill>
@@ -5611,7 +5737,7 @@
                     <a:lstStyle/>
                     <a:p>
                       <a:r>
-                        <a:rPr sz="1600" b="0" i="0">
+                        <a:rPr sz="1500" b="0" i="0">
                           <a:solidFill>
                             <a:srgbClr val="222222"/>
                           </a:solidFill>
@@ -5628,14 +5754,14 @@
                   </a:tcPr>
                 </a:tc>
               </a:tr>
-              <a:tr h="475488">
+              <a:tr h="393192">
                 <a:tc>
                   <a:txBody>
                     <a:bodyPr/>
                     <a:lstStyle/>
                     <a:p>
                       <a:r>
-                        <a:rPr sz="1600" b="1" i="0">
+                        <a:rPr sz="1500" b="1" i="0">
                           <a:solidFill>
                             <a:srgbClr val="222222"/>
                           </a:solidFill>
@@ -5657,7 +5783,7 @@
                     <a:lstStyle/>
                     <a:p>
                       <a:r>
-                        <a:rPr sz="1600" b="0" i="0">
+                        <a:rPr sz="1500" b="0" i="0">
                           <a:solidFill>
                             <a:srgbClr val="222222"/>
                           </a:solidFill>
@@ -5674,14 +5800,14 @@
                   </a:tcPr>
                 </a:tc>
               </a:tr>
-              <a:tr h="475488">
+              <a:tr h="393192">
                 <a:tc>
                   <a:txBody>
                     <a:bodyPr/>
                     <a:lstStyle/>
                     <a:p>
                       <a:r>
-                        <a:rPr sz="1600" b="1" i="0">
+                        <a:rPr sz="1500" b="1" i="0">
                           <a:solidFill>
                             <a:srgbClr val="222222"/>
                           </a:solidFill>
@@ -5703,7 +5829,7 @@
                     <a:lstStyle/>
                     <a:p>
                       <a:r>
-                        <a:rPr sz="1600" b="0" i="0">
+                        <a:rPr sz="1500" b="0" i="0">
                           <a:solidFill>
                             <a:srgbClr val="222222"/>
                           </a:solidFill>
@@ -5758,7 +5884,7 @@
                 </a:solidFill>
                 <a:latin typeface="Calibri"/>
               </a:rPr>
-              <a:t>Šaltiniai: Rorres (n.d.); Wikipedia (n.d.-a, n.d.-b, n.d.-c); Hi-Lift Jack Company (n.d.-a); AutoIndustriya (n.d.); Pro-Lift-Montagetechnik (n.d.).</a:t>
+              <a:t>Šaltiniai: Rorres (n.d.); Wikipedia (n.d.-a, n.d.-c, n.d.-d, n.d.-e, n.d.-f); Hi-Lift Jack Company (n.d.-a); AutoIndustriya (n.d.); Pro-Lift-Montagetechnik (n.d.).</a:t>
             </a:r>
           </a:p>
         </p:txBody>
@@ -6544,7 +6670,7 @@
                 </a:solidFill>
                 <a:latin typeface="Calibri"/>
               </a:rPr>
-              <a:t>Šaltiniai: Wikipedia (n.d.-d); Joyce/Dayton (n.d.); CJ Pony Parts (n.d.); Hi-Lift Jack Company (n.d.-b); CN Trailer Parts (n.d.); Redline Stands (n.d.).</a:t>
+              <a:t>Šaltiniai: Wikipedia (n.d.-b); Joyce/Dayton (n.d.); CJ Pony Parts (n.d.); Hi-Lift Jack Company (n.d.-b); CN Trailer Parts (n.d.); Redline Stands (n.d.).</a:t>
             </a:r>
           </a:p>
         </p:txBody>
@@ -9713,6 +9839,40 @@
               <a:t> (U.S. Patent No. 6,695,289). https://patents.google.com/patent/US6695289B1/en</a:t>
             </a:r>
           </a:p>
+          <a:p>
+            <a:pPr>
+              <a:spcAft>
+                <a:spcPts val="700"/>
+              </a:spcAft>
+            </a:pPr>
+            <a:r>
+              <a:rPr sz="1400" b="0">
+                <a:solidFill>
+                  <a:srgbClr val="222222"/>
+                </a:solidFill>
+                <a:latin typeface="Calibri"/>
+              </a:rPr>
+              <a:t>Pro-Lift-Montagetechnik. (n.d.). </a:t>
+            </a:r>
+            <a:r>
+              <a:rPr sz="1400" b="0" i="1">
+                <a:solidFill>
+                  <a:srgbClr val="222222"/>
+                </a:solidFill>
+                <a:latin typeface="Calibri"/>
+              </a:rPr>
+              <a:t>12V electric scissor jack, car jack, 123 mm – 345 mm</a:t>
+            </a:r>
+            <a:r>
+              <a:rPr sz="1400" b="0" i="0">
+                <a:solidFill>
+                  <a:srgbClr val="222222"/>
+                </a:solidFill>
+                <a:latin typeface="Calibri"/>
+              </a:rPr>
+              <a:t>. https://www.pro-lift-montagetechnik.com/12-volt-electric-scissor-jack-car-jack-123mm-345mm-002</a:t>
+            </a:r>
+          </a:p>
         </p:txBody>
       </p:sp>
     </p:spTree>

</xml_diff>

<commit_message>
Reorder jack deck: function, history, application, companies, drawbacks
Co-Authored-By: Claude Opus 5.5 <noreply@anthropic.com>
Claude-Session: https://claude.ai/code/session_01A3dr5uNJtqowxFZtjwACBv
</commit_message>
<xml_diff>
--- a/domkratas-ta1/domkratas-ta1.pptx
+++ b/domkratas-ta1/domkratas-ta1.pptx
@@ -583,6 +583,76 @@
           <a:lstStyle/>
           <a:p>
             <a:r>
+              <a:t>Šiandien automobilyje dažniausiai rasime žirklinį domkratą. Jo trūkumai – lėtas, siauro pagrindo, nestabilus ant minkšto paviršiaus ir nepatogus sukti. Siūlome platesnį pagrindą su guminiu padu, savistabdį trapecinį sraigtą su bronzine veržle, stipresnes svirtis ir patogesnę rankeną.</a:t>
+            </a:r>
+          </a:p>
+        </p:txBody>
+      </p:sp>
+      <p:sp>
+        <p:nvSpPr>
+          <p:cNvPr id="4" name="Slide Number Placeholder 3"/>
+          <p:cNvSpPr>
+            <a:spLocks noGrp="1"/>
+          </p:cNvSpPr>
+          <p:nvPr>
+            <p:ph type="sldNum" idx="5" sz="quarter"/>
+          </p:nvPr>
+        </p:nvSpPr>
+        <p:spPr/>
+      </p:sp>
+    </p:spTree>
+  </p:cSld>
+  <p:clrMapOvr>
+    <a:masterClrMapping/>
+  </p:clrMapOvr>
+</p:notes>
+</file>
+
+<file path=ppt/notesSlides/notesSlide11.xml><?xml version="1.0" encoding="utf-8"?>
+<p:notes xmlns:a="http://schemas.openxmlformats.org/drawingml/2006/main" xmlns:p="http://schemas.openxmlformats.org/presentationml/2006/main" xmlns:r="http://schemas.openxmlformats.org/officeDocument/2006/relationships">
+  <p:cSld>
+    <p:spTree>
+      <p:nvGrpSpPr>
+        <p:cNvPr id="1" name=""/>
+        <p:cNvGrpSpPr/>
+        <p:nvPr/>
+      </p:nvGrpSpPr>
+      <p:grpSpPr>
+        <a:xfrm>
+          <a:off x="0" y="0"/>
+          <a:ext cx="0" cy="0"/>
+          <a:chOff x="0" y="0"/>
+          <a:chExt cx="0" cy="0"/>
+        </a:xfrm>
+      </p:grpSpPr>
+      <p:sp>
+        <p:nvSpPr>
+          <p:cNvPr id="2" name="Slide Image Placeholder 1"/>
+          <p:cNvSpPr>
+            <a:spLocks noGrp="1"/>
+          </p:cNvSpPr>
+          <p:nvPr>
+            <p:ph type="sldImg" idx="2"/>
+          </p:nvPr>
+        </p:nvSpPr>
+        <p:spPr/>
+      </p:sp>
+      <p:sp>
+        <p:nvSpPr>
+          <p:cNvPr id="3" name="Notes Placeholder 2"/>
+          <p:cNvSpPr>
+            <a:spLocks noGrp="1"/>
+          </p:cNvSpPr>
+          <p:nvPr>
+            <p:ph type="body" idx="3" sz="quarter"/>
+          </p:nvPr>
+        </p:nvSpPr>
+        <p:spPr/>
+        <p:txBody>
+          <a:bodyPr/>
+          <a:lstStyle/>
+          <a:p>
+            <a:r>
               <a:t>Apibendrinant: domkratas keitėsi nuo sraigtinio iki pneumohidraulinio, ir kiekvienas žingsnis sprendė ankstesniojo problemą. Mūsų idėja – stabilesnis ir patvaresnis žirklinis domkratas. Ačiū, laukiame klausimų.</a:t>
             </a:r>
           </a:p>
@@ -653,7 +723,7 @@
           <a:lstStyle/>
           <a:p>
             <a:r>
-              <a:t>Domkratai buvo naudojami dar vežimams. Atsiradus automobiliams, padangos prakiurdavo labai dažnai, nes keliuose buvo daug pasagų vinių. Kad pakeistum ar užklijuotum padangą, reikia pakelti automobilį – todėl gamintojai pradėjo į kiekvieną automobilį dėti nešiojamą domkratą.</a:t>
+              <a:t>Domkrato funkcija – nedidele žmogaus jėga pakelti sunkų krovinį, pavyzdžiui, automobilio kampą. Tai pavyksta dėl sverto ir sraigto arba dėl hidraulikos. Domkratai buvo naudojami dar vežimams, o atsiradus automobiliams, padangos prakiurdavo labai dažnai, todėl domkrato reikėjo kiekviename automobilyje.</a:t>
             </a:r>
           </a:p>
         </p:txBody>
@@ -723,7 +793,7 @@
           <a:lstStyle/>
           <a:p>
             <a:r>
-              <a:t>Čia visi domkratų tipai surikiuoti pagal atsiradimo laiką. Paryškinti keturi, kuriuos pristatysime išsamiai – kiekvienas iš mūsų po vieną. Kiti trumpai aptarti bus pabaigoje.</a:t>
+              <a:t>Čia visi domkratų tipai surikiuoti pagal atsiradimo laiką. Paryškinti keturi, kuriuos pristatysime išsamiai – kiekvienas iš mūsų po vieną. Kitų tipų panaudojimą aptarsime skaidrėje „Pritaikymas“.</a:t>
             </a:r>
           </a:p>
         </p:txBody>
@@ -1073,7 +1143,7 @@
           <a:lstStyle/>
           <a:p>
             <a:r>
-              <a:t>Trumpai apie kitus domkratus, surikiuotus pagal laiką. Krumpliastiebinis kelia labai aukštai, bet pavojingas dėl rankenos atatrankos. Vežimėlinis – servisų domkratas: greitas, bet sunkus. Elektrinis žirklinis nereikalauja sukti rankos, bet reikia elektros.</a:t>
+              <a:t>Kiekvienas domkratų tipas rado savo vietą. Žirklinis – automobilio bagažinėje, vežimėlinis ir pneumohidraulinis – servisuose, butelinis – sunkiai technikai, krumpliastiebinis – visureigiams ir ūkiams, elektrinis – tiems, kam sunku sukti rankena.</a:t>
             </a:r>
           </a:p>
         </p:txBody>
@@ -1143,7 +1213,7 @@
           <a:lstStyle/>
           <a:p>
             <a:r>
-              <a:t>Tobuliname žirklinį domkratą, nes jis yra kiekvieno automobilio komplekte. Jo problemos – siauras pagrindas, dylantis sraigtas ir nepatogus sukimas. Siūlome platesnį pagrindą su guminiu padu, savistabdį trapecinį sraigtą su bronzine veržle, stipresnes svirtis ir patogesnę rankeną.</a:t>
+              <a:t>Kelios kompanijos sukūrė svarbiausius domkratus ir kai kurios veikia iki šiol. Dudgeon įmonė įkurta 1849 m. ir tebeveikia, Hi-Lift domkratai iki šiol gaminami Indianoje, o Blackhawk prekės ženklas dabar priklauso Stanley.</a:t>
             </a:r>
           </a:p>
         </p:txBody>
@@ -4394,7 +4464,7 @@
                 </a:solidFill>
                 <a:latin typeface="Calibri"/>
               </a:rPr>
-              <a:t>Išvados</a:t>
+              <a:t>Trūkumai ir mūsų patobulinimas</a:t>
             </a:r>
           </a:p>
         </p:txBody>
@@ -4523,6 +4593,683 @@
       </p:sp>
       <p:sp>
         <p:nvSpPr>
+          <p:cNvPr id="6" name="Rectangle 5"/>
+          <p:cNvSpPr/>
+          <p:nvPr/>
+        </p:nvSpPr>
+        <p:spPr>
+          <a:xfrm>
+            <a:off x="640080" y="1463040"/>
+            <a:ext cx="10881360" cy="914400"/>
+          </a:xfrm>
+          <a:prstGeom prst="rect">
+            <a:avLst/>
+          </a:prstGeom>
+          <a:solidFill>
+            <a:srgbClr val="DEEAF6"/>
+          </a:solidFill>
+          <a:ln>
+            <a:noFill/>
+          </a:ln>
+          <a:effectLst/>
+        </p:spPr>
+        <p:style>
+          <a:lnRef idx="1">
+            <a:schemeClr val="accent1"/>
+          </a:lnRef>
+          <a:fillRef idx="3">
+            <a:schemeClr val="accent1"/>
+          </a:fillRef>
+          <a:effectRef idx="2">
+            <a:schemeClr val="accent1"/>
+          </a:effectRef>
+          <a:fontRef idx="minor">
+            <a:schemeClr val="lt1"/>
+          </a:fontRef>
+        </p:style>
+        <p:txBody>
+          <a:bodyPr rtlCol="0" anchor="ctr"/>
+          <a:lstStyle/>
+          <a:p>
+            <a:pPr algn="ctr"/>
+          </a:p>
+        </p:txBody>
+      </p:sp>
+      <p:sp>
+        <p:nvSpPr>
+          <p:cNvPr id="7" name="TextBox 6"/>
+          <p:cNvSpPr txBox="1"/>
+          <p:nvPr/>
+        </p:nvSpPr>
+        <p:spPr>
+          <a:xfrm>
+            <a:off x="822960" y="1508760"/>
+            <a:ext cx="10515600" cy="822960"/>
+          </a:xfrm>
+          <a:prstGeom prst="rect">
+            <a:avLst/>
+          </a:prstGeom>
+          <a:noFill/>
+        </p:spPr>
+        <p:txBody>
+          <a:bodyPr wrap="square" anchor="ctr" lIns="45720" rIns="45720">
+            <a:spAutoFit/>
+          </a:bodyPr>
+          <a:lstStyle/>
+          <a:p>
+            <a:pPr algn="l">
+              <a:spcAft>
+                <a:spcPts val="600"/>
+              </a:spcAft>
+            </a:pPr>
+            <a:r>
+              <a:rPr sz="1800" b="1">
+                <a:solidFill>
+                  <a:srgbClr val="1F4E79"/>
+                </a:solidFill>
+                <a:latin typeface="Calibri"/>
+              </a:rPr>
+              <a:t>Žirklinio domkrato trūkumai: </a:t>
+            </a:r>
+            <a:r>
+              <a:rPr sz="1800" b="0" i="0">
+                <a:solidFill>
+                  <a:srgbClr val="222222"/>
+                </a:solidFill>
+                <a:latin typeface="Calibri"/>
+              </a:rPr>
+              <a:t>lėtas (daug apsisukimų), siauras pagrindas – nestabilus ant minkšto ar nelygaus paviršiaus, sukti tenka nepatogioje padėtyje.</a:t>
+            </a:r>
+          </a:p>
+        </p:txBody>
+      </p:sp>
+      <p:graphicFrame>
+        <p:nvGraphicFramePr>
+          <p:cNvPr id="8" name="Table 7"/>
+          <p:cNvGraphicFramePr>
+            <a:graphicFrameLocks noGrp="1"/>
+          </p:cNvGraphicFramePr>
+          <p:nvPr/>
+        </p:nvGraphicFramePr>
+        <p:xfrm>
+          <a:off x="640080" y="2606040"/>
+          <a:ext cx="10881360" cy="2834640"/>
+        </p:xfrm>
+        <a:graphic>
+          <a:graphicData uri="http://schemas.openxmlformats.org/drawingml/2006/table">
+            <a:tbl>
+              <a:tblPr firstRow="1" bandRow="1">
+                <a:tableStyleId>{5C22544A-7EE6-4342-B048-85BDC9FD1C3A}</a:tableStyleId>
+              </a:tblPr>
+              <a:tblGrid>
+                <a:gridCol w="2194560"/>
+                <a:gridCol w="4206240"/>
+                <a:gridCol w="4480560"/>
+              </a:tblGrid>
+              <a:tr h="566928">
+                <a:tc>
+                  <a:txBody>
+                    <a:bodyPr/>
+                    <a:lstStyle/>
+                    <a:p>
+                      <a:r>
+                        <a:rPr sz="1600" b="1" i="0">
+                          <a:solidFill>
+                            <a:srgbClr val="FFFFFF"/>
+                          </a:solidFill>
+                          <a:latin typeface="Calibri"/>
+                        </a:rPr>
+                        <a:t>Elementas</a:t>
+                      </a:r>
+                    </a:p>
+                  </a:txBody>
+                  <a:tcPr marL="73152" marR="73152" anchor="ctr">
+                    <a:solidFill>
+                      <a:srgbClr val="1F4E79"/>
+                    </a:solidFill>
+                  </a:tcPr>
+                </a:tc>
+                <a:tc>
+                  <a:txBody>
+                    <a:bodyPr/>
+                    <a:lstStyle/>
+                    <a:p>
+                      <a:r>
+                        <a:rPr sz="1600" b="1" i="0">
+                          <a:solidFill>
+                            <a:srgbClr val="FFFFFF"/>
+                          </a:solidFill>
+                          <a:latin typeface="Calibri"/>
+                        </a:rPr>
+                        <a:t>Ką keičiame</a:t>
+                      </a:r>
+                    </a:p>
+                  </a:txBody>
+                  <a:tcPr marL="73152" marR="73152" anchor="ctr">
+                    <a:solidFill>
+                      <a:srgbClr val="1F4E79"/>
+                    </a:solidFill>
+                  </a:tcPr>
+                </a:tc>
+                <a:tc>
+                  <a:txBody>
+                    <a:bodyPr/>
+                    <a:lstStyle/>
+                    <a:p>
+                      <a:r>
+                        <a:rPr sz="1600" b="1" i="0">
+                          <a:solidFill>
+                            <a:srgbClr val="FFFFFF"/>
+                          </a:solidFill>
+                          <a:latin typeface="Calibri"/>
+                        </a:rPr>
+                        <a:t>Kodėl</a:t>
+                      </a:r>
+                    </a:p>
+                  </a:txBody>
+                  <a:tcPr marL="73152" marR="73152" anchor="ctr">
+                    <a:solidFill>
+                      <a:srgbClr val="1F4E79"/>
+                    </a:solidFill>
+                  </a:tcPr>
+                </a:tc>
+              </a:tr>
+              <a:tr h="566928">
+                <a:tc>
+                  <a:txBody>
+                    <a:bodyPr/>
+                    <a:lstStyle/>
+                    <a:p>
+                      <a:r>
+                        <a:rPr sz="1600" b="1" i="0">
+                          <a:solidFill>
+                            <a:srgbClr val="222222"/>
+                          </a:solidFill>
+                          <a:latin typeface="Calibri"/>
+                        </a:rPr>
+                        <a:t>Pagrindas</a:t>
+                      </a:r>
+                    </a:p>
+                  </a:txBody>
+                  <a:tcPr marL="73152" marR="73152" anchor="ctr">
+                    <a:solidFill>
+                      <a:srgbClr val="FFFFFF"/>
+                    </a:solidFill>
+                  </a:tcPr>
+                </a:tc>
+                <a:tc>
+                  <a:txBody>
+                    <a:bodyPr/>
+                    <a:lstStyle/>
+                    <a:p>
+                      <a:r>
+                        <a:rPr sz="1600" b="0" i="0">
+                          <a:solidFill>
+                            <a:srgbClr val="222222"/>
+                          </a:solidFill>
+                          <a:latin typeface="Calibri"/>
+                        </a:rPr>
+                        <a:t>Platesnis, su guminiu padu</a:t>
+                      </a:r>
+                    </a:p>
+                  </a:txBody>
+                  <a:tcPr marL="73152" marR="73152" anchor="ctr">
+                    <a:solidFill>
+                      <a:srgbClr val="FFFFFF"/>
+                    </a:solidFill>
+                  </a:tcPr>
+                </a:tc>
+                <a:tc>
+                  <a:txBody>
+                    <a:bodyPr/>
+                    <a:lstStyle/>
+                    <a:p>
+                      <a:r>
+                        <a:rPr sz="1600" b="0" i="0">
+                          <a:solidFill>
+                            <a:srgbClr val="222222"/>
+                          </a:solidFill>
+                          <a:latin typeface="Calibri"/>
+                        </a:rPr>
+                        <a:t>Neslysta ir nesmenga į minkštą paviršių</a:t>
+                      </a:r>
+                    </a:p>
+                  </a:txBody>
+                  <a:tcPr marL="73152" marR="73152" anchor="ctr">
+                    <a:solidFill>
+                      <a:srgbClr val="FFFFFF"/>
+                    </a:solidFill>
+                  </a:tcPr>
+                </a:tc>
+              </a:tr>
+              <a:tr h="566928">
+                <a:tc>
+                  <a:txBody>
+                    <a:bodyPr/>
+                    <a:lstStyle/>
+                    <a:p>
+                      <a:r>
+                        <a:rPr sz="1600" b="1" i="0">
+                          <a:solidFill>
+                            <a:srgbClr val="222222"/>
+                          </a:solidFill>
+                          <a:latin typeface="Calibri"/>
+                        </a:rPr>
+                        <a:t>Sraigtas ir veržlė</a:t>
+                      </a:r>
+                    </a:p>
+                  </a:txBody>
+                  <a:tcPr marL="73152" marR="73152" anchor="ctr">
+                    <a:solidFill>
+                      <a:srgbClr val="FFFFFF"/>
+                    </a:solidFill>
+                  </a:tcPr>
+                </a:tc>
+                <a:tc>
+                  <a:txBody>
+                    <a:bodyPr/>
+                    <a:lstStyle/>
+                    <a:p>
+                      <a:r>
+                        <a:rPr sz="1600" b="0" i="0">
+                          <a:solidFill>
+                            <a:srgbClr val="222222"/>
+                          </a:solidFill>
+                          <a:latin typeface="Calibri"/>
+                        </a:rPr>
+                        <a:t>Trapecinis sraigtas iš plieno 42CrMo4, veržlė iš bronzos CuSn12</a:t>
+                      </a:r>
+                    </a:p>
+                  </a:txBody>
+                  <a:tcPr marL="73152" marR="73152" anchor="ctr">
+                    <a:solidFill>
+                      <a:srgbClr val="FFFFFF"/>
+                    </a:solidFill>
+                  </a:tcPr>
+                </a:tc>
+                <a:tc>
+                  <a:txBody>
+                    <a:bodyPr/>
+                    <a:lstStyle/>
+                    <a:p>
+                      <a:r>
+                        <a:rPr sz="1600" b="0" i="0">
+                          <a:solidFill>
+                            <a:srgbClr val="222222"/>
+                          </a:solidFill>
+                          <a:latin typeface="Calibri"/>
+                        </a:rPr>
+                        <a:t>Savistabdis, mažiau dyla, maža trintis</a:t>
+                      </a:r>
+                    </a:p>
+                  </a:txBody>
+                  <a:tcPr marL="73152" marR="73152" anchor="ctr">
+                    <a:solidFill>
+                      <a:srgbClr val="FFFFFF"/>
+                    </a:solidFill>
+                  </a:tcPr>
+                </a:tc>
+              </a:tr>
+              <a:tr h="566928">
+                <a:tc>
+                  <a:txBody>
+                    <a:bodyPr/>
+                    <a:lstStyle/>
+                    <a:p>
+                      <a:r>
+                        <a:rPr sz="1600" b="1" i="0">
+                          <a:solidFill>
+                            <a:srgbClr val="222222"/>
+                          </a:solidFill>
+                          <a:latin typeface="Calibri"/>
+                        </a:rPr>
+                        <a:t>Svirtys</a:t>
+                      </a:r>
+                    </a:p>
+                  </a:txBody>
+                  <a:tcPr marL="73152" marR="73152" anchor="ctr">
+                    <a:solidFill>
+                      <a:srgbClr val="FFFFFF"/>
+                    </a:solidFill>
+                  </a:tcPr>
+                </a:tc>
+                <a:tc>
+                  <a:txBody>
+                    <a:bodyPr/>
+                    <a:lstStyle/>
+                    <a:p>
+                      <a:r>
+                        <a:rPr sz="1600" b="0" i="0">
+                          <a:solidFill>
+                            <a:srgbClr val="222222"/>
+                          </a:solidFill>
+                          <a:latin typeface="Calibri"/>
+                        </a:rPr>
+                        <a:t>Plienas S420MC vietoj S235</a:t>
+                      </a:r>
+                    </a:p>
+                  </a:txBody>
+                  <a:tcPr marL="73152" marR="73152" anchor="ctr">
+                    <a:solidFill>
+                      <a:srgbClr val="FFFFFF"/>
+                    </a:solidFill>
+                  </a:tcPr>
+                </a:tc>
+                <a:tc>
+                  <a:txBody>
+                    <a:bodyPr/>
+                    <a:lstStyle/>
+                    <a:p>
+                      <a:r>
+                        <a:rPr sz="1600" b="0" i="0">
+                          <a:solidFill>
+                            <a:srgbClr val="222222"/>
+                          </a:solidFill>
+                          <a:latin typeface="Calibri"/>
+                        </a:rPr>
+                        <a:t>Takumo riba 420 vs 235 MPa – apie 1,8 karto stipresnės</a:t>
+                      </a:r>
+                    </a:p>
+                  </a:txBody>
+                  <a:tcPr marL="73152" marR="73152" anchor="ctr">
+                    <a:solidFill>
+                      <a:srgbClr val="FFFFFF"/>
+                    </a:solidFill>
+                  </a:tcPr>
+                </a:tc>
+              </a:tr>
+              <a:tr h="566928">
+                <a:tc>
+                  <a:txBody>
+                    <a:bodyPr/>
+                    <a:lstStyle/>
+                    <a:p>
+                      <a:r>
+                        <a:rPr sz="1600" b="1" i="0">
+                          <a:solidFill>
+                            <a:srgbClr val="222222"/>
+                          </a:solidFill>
+                          <a:latin typeface="Calibri"/>
+                        </a:rPr>
+                        <a:t>Rankena</a:t>
+                      </a:r>
+                    </a:p>
+                  </a:txBody>
+                  <a:tcPr marL="73152" marR="73152" anchor="ctr">
+                    <a:solidFill>
+                      <a:srgbClr val="FFFFFF"/>
+                    </a:solidFill>
+                  </a:tcPr>
+                </a:tc>
+                <a:tc>
+                  <a:txBody>
+                    <a:bodyPr/>
+                    <a:lstStyle/>
+                    <a:p>
+                      <a:r>
+                        <a:rPr sz="1600" b="0" i="0">
+                          <a:solidFill>
+                            <a:srgbClr val="222222"/>
+                          </a:solidFill>
+                          <a:latin typeface="Calibri"/>
+                        </a:rPr>
+                        <a:t>Ilgesnė, sulankstoma rankena</a:t>
+                      </a:r>
+                    </a:p>
+                  </a:txBody>
+                  <a:tcPr marL="73152" marR="73152" anchor="ctr">
+                    <a:solidFill>
+                      <a:srgbClr val="FFFFFF"/>
+                    </a:solidFill>
+                  </a:tcPr>
+                </a:tc>
+                <a:tc>
+                  <a:txBody>
+                    <a:bodyPr/>
+                    <a:lstStyle/>
+                    <a:p>
+                      <a:r>
+                        <a:rPr sz="1600" b="0" i="0">
+                          <a:solidFill>
+                            <a:srgbClr val="222222"/>
+                          </a:solidFill>
+                          <a:latin typeface="Calibri"/>
+                        </a:rPr>
+                        <a:t>Sukti galima nesilenkiant prie pat rato (mūsų idėja)</a:t>
+                      </a:r>
+                    </a:p>
+                  </a:txBody>
+                  <a:tcPr marL="73152" marR="73152" anchor="ctr">
+                    <a:solidFill>
+                      <a:srgbClr val="FFFFFF"/>
+                    </a:solidFill>
+                  </a:tcPr>
+                </a:tc>
+              </a:tr>
+            </a:tbl>
+          </a:graphicData>
+        </a:graphic>
+      </p:graphicFrame>
+      <p:sp>
+        <p:nvSpPr>
+          <p:cNvPr id="9" name="TextBox 8"/>
+          <p:cNvSpPr txBox="1"/>
+          <p:nvPr/>
+        </p:nvSpPr>
+        <p:spPr>
+          <a:xfrm>
+            <a:off x="640080" y="5897880"/>
+            <a:ext cx="10881360" cy="457200"/>
+          </a:xfrm>
+          <a:prstGeom prst="rect">
+            <a:avLst/>
+          </a:prstGeom>
+          <a:noFill/>
+        </p:spPr>
+        <p:txBody>
+          <a:bodyPr wrap="square" anchor="t" lIns="45720" rIns="45720">
+            <a:spAutoFit/>
+          </a:bodyPr>
+          <a:lstStyle/>
+          <a:p>
+            <a:pPr algn="l">
+              <a:spcAft>
+                <a:spcPts val="600"/>
+              </a:spcAft>
+            </a:pPr>
+            <a:r>
+              <a:rPr sz="1300" b="0">
+                <a:solidFill>
+                  <a:srgbClr val="595959"/>
+                </a:solidFill>
+                <a:latin typeface="Calibri"/>
+              </a:rPr>
+              <a:t>Šaltiniai: CN Trailer Parts (n.d.); Roton Products (n.d.); Sider Ticino (n.d.); Hengli Automation (n.d.); Gnee Steel (n.d.); The World Material (n.d.).</a:t>
+            </a:r>
+          </a:p>
+        </p:txBody>
+      </p:sp>
+    </p:spTree>
+  </p:cSld>
+  <p:clrMapOvr>
+    <a:masterClrMapping/>
+  </p:clrMapOvr>
+</p:sld>
+</file>
+
+<file path=ppt/slides/slide11.xml><?xml version="1.0" encoding="utf-8"?>
+<p:sld xmlns:a="http://schemas.openxmlformats.org/drawingml/2006/main" xmlns:p="http://schemas.openxmlformats.org/presentationml/2006/main" xmlns:r="http://schemas.openxmlformats.org/officeDocument/2006/relationships">
+  <p:cSld>
+    <p:spTree>
+      <p:nvGrpSpPr>
+        <p:cNvPr id="1" name=""/>
+        <p:cNvGrpSpPr/>
+        <p:nvPr/>
+      </p:nvGrpSpPr>
+      <p:grpSpPr/>
+      <p:sp>
+        <p:nvSpPr>
+          <p:cNvPr id="2" name="TextBox 1"/>
+          <p:cNvSpPr txBox="1"/>
+          <p:nvPr/>
+        </p:nvSpPr>
+        <p:spPr>
+          <a:xfrm>
+            <a:off x="548640" y="320040"/>
+            <a:ext cx="11064240" cy="822960"/>
+          </a:xfrm>
+          <a:prstGeom prst="rect">
+            <a:avLst/>
+          </a:prstGeom>
+          <a:noFill/>
+        </p:spPr>
+        <p:txBody>
+          <a:bodyPr wrap="square" anchor="b" lIns="45720" rIns="45720">
+            <a:spAutoFit/>
+          </a:bodyPr>
+          <a:lstStyle/>
+          <a:p>
+            <a:pPr algn="l">
+              <a:spcAft>
+                <a:spcPts val="600"/>
+              </a:spcAft>
+            </a:pPr>
+            <a:r>
+              <a:rPr sz="3200" b="1">
+                <a:solidFill>
+                  <a:srgbClr val="1F4E79"/>
+                </a:solidFill>
+                <a:latin typeface="Calibri"/>
+              </a:rPr>
+              <a:t>Išvados</a:t>
+            </a:r>
+          </a:p>
+        </p:txBody>
+      </p:sp>
+      <p:sp>
+        <p:nvSpPr>
+          <p:cNvPr id="3" name="Rectangle 2"/>
+          <p:cNvSpPr/>
+          <p:nvPr/>
+        </p:nvSpPr>
+        <p:spPr>
+          <a:xfrm>
+            <a:off x="594360" y="1207008"/>
+            <a:ext cx="10972800" cy="27432"/>
+          </a:xfrm>
+          <a:prstGeom prst="rect">
+            <a:avLst/>
+          </a:prstGeom>
+          <a:solidFill>
+            <a:srgbClr val="1F4E79"/>
+          </a:solidFill>
+          <a:ln>
+            <a:noFill/>
+          </a:ln>
+          <a:effectLst/>
+        </p:spPr>
+        <p:style>
+          <a:lnRef idx="1">
+            <a:schemeClr val="accent1"/>
+          </a:lnRef>
+          <a:fillRef idx="3">
+            <a:schemeClr val="accent1"/>
+          </a:fillRef>
+          <a:effectRef idx="2">
+            <a:schemeClr val="accent1"/>
+          </a:effectRef>
+          <a:fontRef idx="minor">
+            <a:schemeClr val="lt1"/>
+          </a:fontRef>
+        </p:style>
+        <p:txBody>
+          <a:bodyPr rtlCol="0" anchor="ctr"/>
+          <a:lstStyle/>
+          <a:p>
+            <a:pPr algn="ctr"/>
+          </a:p>
+        </p:txBody>
+      </p:sp>
+      <p:sp>
+        <p:nvSpPr>
+          <p:cNvPr id="4" name="TextBox 3"/>
+          <p:cNvSpPr txBox="1"/>
+          <p:nvPr/>
+        </p:nvSpPr>
+        <p:spPr>
+          <a:xfrm>
+            <a:off x="10698480" y="6355080"/>
+            <a:ext cx="1005840" cy="365760"/>
+          </a:xfrm>
+          <a:prstGeom prst="rect">
+            <a:avLst/>
+          </a:prstGeom>
+          <a:noFill/>
+        </p:spPr>
+        <p:txBody>
+          <a:bodyPr wrap="square" anchor="t" lIns="45720" rIns="45720">
+            <a:spAutoFit/>
+          </a:bodyPr>
+          <a:lstStyle/>
+          <a:p>
+            <a:pPr algn="r">
+              <a:spcAft>
+                <a:spcPts val="600"/>
+              </a:spcAft>
+            </a:pPr>
+            <a:r>
+              <a:rPr sz="1200" b="0">
+                <a:solidFill>
+                  <a:srgbClr val="595959"/>
+                </a:solidFill>
+                <a:latin typeface="Calibri"/>
+              </a:rPr>
+              <a:t>11 / 12</a:t>
+            </a:r>
+          </a:p>
+        </p:txBody>
+      </p:sp>
+      <p:sp>
+        <p:nvSpPr>
+          <p:cNvPr id="5" name="TextBox 4"/>
+          <p:cNvSpPr txBox="1"/>
+          <p:nvPr/>
+        </p:nvSpPr>
+        <p:spPr>
+          <a:xfrm>
+            <a:off x="548640" y="6355080"/>
+            <a:ext cx="7315200" cy="365760"/>
+          </a:xfrm>
+          <a:prstGeom prst="rect">
+            <a:avLst/>
+          </a:prstGeom>
+          <a:noFill/>
+        </p:spPr>
+        <p:txBody>
+          <a:bodyPr wrap="square" anchor="t" lIns="45720" rIns="45720">
+            <a:spAutoFit/>
+          </a:bodyPr>
+          <a:lstStyle/>
+          <a:p>
+            <a:pPr algn="l">
+              <a:spcAft>
+                <a:spcPts val="600"/>
+              </a:spcAft>
+            </a:pPr>
+            <a:r>
+              <a:rPr sz="1200" b="0">
+                <a:solidFill>
+                  <a:srgbClr val="595959"/>
+                </a:solidFill>
+                <a:latin typeface="Calibri"/>
+              </a:rPr>
+              <a:t>PBL · Automobilinis domkratas</a:t>
+            </a:r>
+          </a:p>
+        </p:txBody>
+      </p:sp>
+      <p:sp>
+        <p:nvSpPr>
           <p:cNvPr id="6" name="TextBox 5"/>
           <p:cNvSpPr txBox="1"/>
           <p:nvPr/>
@@ -4615,6 +5362,31 @@
                 <a:latin typeface="Calibri"/>
               </a:rPr>
               <a:t> – kiekvienas naujas domkratas išsprendė ankstesniojo problemą, bet atnešė naujų.</a:t>
+            </a:r>
+          </a:p>
+          <a:p>
+            <a:pPr>
+              <a:spcAft>
+                <a:spcPts val="1800"/>
+              </a:spcAft>
+            </a:pPr>
+            <a:r>
+              <a:rPr sz="2100" b="1">
+                <a:solidFill>
+                  <a:srgbClr val="222222"/>
+                </a:solidFill>
+                <a:latin typeface="Calibri"/>
+              </a:rPr>
+              <a:t>• Pritaikymas</a:t>
+            </a:r>
+            <a:r>
+              <a:rPr sz="2100" b="0" i="0">
+                <a:solidFill>
+                  <a:srgbClr val="222222"/>
+                </a:solidFill>
+                <a:latin typeface="Calibri"/>
+              </a:rPr>
+              <a:t> – kiekvienas tipas rado savo vietą: nuo automobilio bagažinės iki serviso ir statybų.</a:t>
             </a:r>
           </a:p>
           <a:p>
@@ -4735,7 +5507,7 @@
 </p:sld>
 </file>
 
-<file path=ppt/slides/slide11.xml><?xml version="1.0" encoding="utf-8"?>
+<file path=ppt/slides/slide12.xml><?xml version="1.0" encoding="utf-8"?>
 <p:sld xmlns:a="http://schemas.openxmlformats.org/drawingml/2006/main" xmlns:p="http://schemas.openxmlformats.org/presentationml/2006/main" xmlns:r="http://schemas.openxmlformats.org/officeDocument/2006/relationships">
   <p:cSld>
     <p:spTree>
@@ -4779,7 +5551,7 @@
                 </a:solidFill>
                 <a:latin typeface="Calibri"/>
               </a:rPr>
-              <a:t>Šaltiniai (1/2)</a:t>
+              <a:t>Šaltiniai</a:t>
             </a:r>
           </a:p>
         </p:txBody>
@@ -4862,7 +5634,7 @@
                 </a:solidFill>
                 <a:latin typeface="Calibri"/>
               </a:rPr>
-              <a:t>11 / 12</a:t>
+              <a:t>12 / 12</a:t>
             </a:r>
           </a:p>
         </p:txBody>
@@ -4914,8 +5686,8 @@
         </p:nvSpPr>
         <p:spPr>
           <a:xfrm>
-            <a:off x="640080" y="1463040"/>
-            <a:ext cx="10881360" cy="4754880"/>
+            <a:off x="548640" y="1325880"/>
+            <a:ext cx="5440680" cy="4937760"/>
           </a:xfrm>
           <a:prstGeom prst="rect">
             <a:avLst/>
@@ -4930,11 +5702,11 @@
           <a:p>
             <a:pPr algn="l">
               <a:spcAft>
-                <a:spcPts val="600"/>
-              </a:spcAft>
-            </a:pPr>
-            <a:r>
-              <a:rPr sz="1300" b="0">
+                <a:spcPts val="200"/>
+              </a:spcAft>
+            </a:pPr>
+            <a:r>
+              <a:rPr sz="900" b="0">
                 <a:solidFill>
                   <a:srgbClr val="222222"/>
                 </a:solidFill>
@@ -4943,7 +5715,7 @@
               <a:t>Bovey, G. O. (1882). </a:t>
             </a:r>
             <a:r>
-              <a:rPr sz="1300" b="0" i="1">
+              <a:rPr sz="900" b="0" i="1">
                 <a:solidFill>
                   <a:srgbClr val="222222"/>
                 </a:solidFill>
@@ -4952,7 +5724,7 @@
               <a:t>Carriage-jack</a:t>
             </a:r>
             <a:r>
-              <a:rPr sz="1300" b="0" i="0">
+              <a:rPr sz="900" b="0" i="0">
                 <a:solidFill>
                   <a:srgbClr val="222222"/>
                 </a:solidFill>
@@ -4964,11 +5736,11 @@
           <a:p>
             <a:pPr>
               <a:spcAft>
-                <a:spcPts val="600"/>
-              </a:spcAft>
-            </a:pPr>
-            <a:r>
-              <a:rPr sz="1300" b="0">
+                <a:spcPts val="200"/>
+              </a:spcAft>
+            </a:pPr>
+            <a:r>
+              <a:rPr sz="900" b="0">
                 <a:solidFill>
                   <a:srgbClr val="222222"/>
                 </a:solidFill>
@@ -4977,7 +5749,7 @@
               <a:t>Brown, W. P. (1949). </a:t>
             </a:r>
             <a:r>
-              <a:rPr sz="1300" b="0" i="1">
+              <a:rPr sz="900" b="0" i="1">
                 <a:solidFill>
                   <a:srgbClr val="222222"/>
                 </a:solidFill>
@@ -4986,7 +5758,7 @@
               <a:t>Scissors jack</a:t>
             </a:r>
             <a:r>
-              <a:rPr sz="1300" b="0" i="0">
+              <a:rPr sz="900" b="0" i="0">
                 <a:solidFill>
                   <a:srgbClr val="222222"/>
                 </a:solidFill>
@@ -4998,11 +5770,11 @@
           <a:p>
             <a:pPr>
               <a:spcAft>
-                <a:spcPts val="600"/>
-              </a:spcAft>
-            </a:pPr>
-            <a:r>
-              <a:rPr sz="1300" b="0">
+                <a:spcPts val="200"/>
+              </a:spcAft>
+            </a:pPr>
+            <a:r>
+              <a:rPr sz="900" b="0">
                 <a:solidFill>
                   <a:srgbClr val="222222"/>
                 </a:solidFill>
@@ -5011,7 +5783,7 @@
               <a:t>Castle Equipment. (n.d.). </a:t>
             </a:r>
             <a:r>
-              <a:rPr sz="1300" b="0" i="1">
+              <a:rPr sz="900" b="0" i="1">
                 <a:solidFill>
                   <a:srgbClr val="222222"/>
                 </a:solidFill>
@@ -5020,7 +5792,7 @@
               <a:t>Weaver hydraulic &amp; mechanical jacks history</a:t>
             </a:r>
             <a:r>
-              <a:rPr sz="1300" b="0" i="0">
+              <a:rPr sz="900" b="0" i="0">
                 <a:solidFill>
                   <a:srgbClr val="222222"/>
                 </a:solidFill>
@@ -5032,11 +5804,11 @@
           <a:p>
             <a:pPr>
               <a:spcAft>
-                <a:spcPts val="600"/>
-              </a:spcAft>
-            </a:pPr>
-            <a:r>
-              <a:rPr sz="1300" b="0">
+                <a:spcPts val="200"/>
+              </a:spcAft>
+            </a:pPr>
+            <a:r>
+              <a:rPr sz="900" b="0">
                 <a:solidFill>
                   <a:srgbClr val="222222"/>
                 </a:solidFill>
@@ -5045,7 +5817,7 @@
               <a:t>CJ Pony Parts. (n.d.). </a:t>
             </a:r>
             <a:r>
-              <a:rPr sz="1300" b="0" i="1">
+              <a:rPr sz="900" b="0" i="1">
                 <a:solidFill>
                   <a:srgbClr val="222222"/>
                 </a:solidFill>
@@ -5054,7 +5826,7 @@
               <a:t>Types of car jacks</a:t>
             </a:r>
             <a:r>
-              <a:rPr sz="1300" b="0" i="0">
+              <a:rPr sz="900" b="0" i="0">
                 <a:solidFill>
                   <a:srgbClr val="222222"/>
                 </a:solidFill>
@@ -5066,11 +5838,11 @@
           <a:p>
             <a:pPr>
               <a:spcAft>
-                <a:spcPts val="600"/>
-              </a:spcAft>
-            </a:pPr>
-            <a:r>
-              <a:rPr sz="1300" b="0">
+                <a:spcPts val="200"/>
+              </a:spcAft>
+            </a:pPr>
+            <a:r>
+              <a:rPr sz="900" b="0">
                 <a:solidFill>
                   <a:srgbClr val="222222"/>
                 </a:solidFill>
@@ -5079,7 +5851,7 @@
               <a:t>CN Trailer Parts. (n.d.). </a:t>
             </a:r>
             <a:r>
-              <a:rPr sz="1300" b="0" i="1">
+              <a:rPr sz="900" b="0" i="1">
                 <a:solidFill>
                   <a:srgbClr val="222222"/>
                 </a:solidFill>
@@ -5088,7 +5860,7 @@
               <a:t>What are the disadvantages of a scissor jack?</a:t>
             </a:r>
             <a:r>
-              <a:rPr sz="1300" b="0" i="0">
+              <a:rPr sz="900" b="0" i="0">
                 <a:solidFill>
                   <a:srgbClr val="222222"/>
                 </a:solidFill>
@@ -5100,11 +5872,11 @@
           <a:p>
             <a:pPr>
               <a:spcAft>
-                <a:spcPts val="600"/>
-              </a:spcAft>
-            </a:pPr>
-            <a:r>
-              <a:rPr sz="1300" b="0">
+                <a:spcPts val="200"/>
+              </a:spcAft>
+            </a:pPr>
+            <a:r>
+              <a:rPr sz="900" b="0">
                 <a:solidFill>
                   <a:srgbClr val="222222"/>
                 </a:solidFill>
@@ -5113,7 +5885,7 @@
               <a:t>Dudgeon, R. (1851). </a:t>
             </a:r>
             <a:r>
-              <a:rPr sz="1300" b="0" i="1">
+              <a:rPr sz="900" b="0" i="1">
                 <a:solidFill>
                   <a:srgbClr val="222222"/>
                 </a:solidFill>
@@ -5122,7 +5894,7 @@
               <a:t>Portable hydraulic press</a:t>
             </a:r>
             <a:r>
-              <a:rPr sz="1300" b="0" i="0">
+              <a:rPr sz="900" b="0" i="0">
                 <a:solidFill>
                   <a:srgbClr val="222222"/>
                 </a:solidFill>
@@ -5134,11 +5906,11 @@
           <a:p>
             <a:pPr>
               <a:spcAft>
-                <a:spcPts val="600"/>
-              </a:spcAft>
-            </a:pPr>
-            <a:r>
-              <a:rPr sz="1300" b="0">
+                <a:spcPts val="200"/>
+              </a:spcAft>
+            </a:pPr>
+            <a:r>
+              <a:rPr sz="900" b="0">
                 <a:solidFill>
                   <a:srgbClr val="222222"/>
                 </a:solidFill>
@@ -5147,7 +5919,7 @@
               <a:t>Gnee Steel. (n.d.). </a:t>
             </a:r>
             <a:r>
-              <a:rPr sz="1300" b="0" i="1">
+              <a:rPr sz="900" b="0" i="1">
                 <a:solidFill>
                   <a:srgbClr val="222222"/>
                 </a:solidFill>
@@ -5156,7 +5928,7 @@
               <a:t>EN 10149-2 S420MC hot rolled automotive steel</a:t>
             </a:r>
             <a:r>
-              <a:rPr sz="1300" b="0" i="0">
+              <a:rPr sz="900" b="0" i="0">
                 <a:solidFill>
                   <a:srgbClr val="222222"/>
                 </a:solidFill>
@@ -5168,11 +5940,11 @@
           <a:p>
             <a:pPr>
               <a:spcAft>
-                <a:spcPts val="600"/>
-              </a:spcAft>
-            </a:pPr>
-            <a:r>
-              <a:rPr sz="1300" b="0">
+                <a:spcPts val="200"/>
+              </a:spcAft>
+            </a:pPr>
+            <a:r>
+              <a:rPr sz="900" b="0">
                 <a:solidFill>
                   <a:srgbClr val="222222"/>
                 </a:solidFill>
@@ -5181,7 +5953,7 @@
               <a:t>Hengli Automation. (n.d.). </a:t>
             </a:r>
             <a:r>
-              <a:rPr sz="1300" b="0" i="1">
+              <a:rPr sz="900" b="0" i="1">
                 <a:solidFill>
                   <a:srgbClr val="222222"/>
                 </a:solidFill>
@@ -5190,7 +5962,7 @@
               <a:t>What is the material of the nut for a T lead screw?</a:t>
             </a:r>
             <a:r>
-              <a:rPr sz="1300" b="0" i="0">
+              <a:rPr sz="900" b="0" i="0">
                 <a:solidFill>
                   <a:srgbClr val="222222"/>
                 </a:solidFill>
@@ -5202,11 +5974,11 @@
           <a:p>
             <a:pPr>
               <a:spcAft>
-                <a:spcPts val="600"/>
-              </a:spcAft>
-            </a:pPr>
-            <a:r>
-              <a:rPr sz="1300" b="0">
+                <a:spcPts val="200"/>
+              </a:spcAft>
+            </a:pPr>
+            <a:r>
+              <a:rPr sz="900" b="0">
                 <a:solidFill>
                   <a:srgbClr val="222222"/>
                 </a:solidFill>
@@ -5215,7 +5987,7 @@
               <a:t>Hi-Lift Jack Company. (n.d.-a). </a:t>
             </a:r>
             <a:r>
-              <a:rPr sz="1300" b="0" i="1">
+              <a:rPr sz="900" b="0" i="1">
                 <a:solidFill>
                   <a:srgbClr val="222222"/>
                 </a:solidFill>
@@ -5224,7 +5996,7 @@
               <a:t>Our history</a:t>
             </a:r>
             <a:r>
-              <a:rPr sz="1300" b="0" i="0">
+              <a:rPr sz="900" b="0" i="0">
                 <a:solidFill>
                   <a:srgbClr val="222222"/>
                 </a:solidFill>
@@ -5236,11 +6008,11 @@
           <a:p>
             <a:pPr>
               <a:spcAft>
-                <a:spcPts val="600"/>
-              </a:spcAft>
-            </a:pPr>
-            <a:r>
-              <a:rPr sz="1300" b="0">
+                <a:spcPts val="200"/>
+              </a:spcAft>
+            </a:pPr>
+            <a:r>
+              <a:rPr sz="900" b="0">
                 <a:solidFill>
                   <a:srgbClr val="222222"/>
                 </a:solidFill>
@@ -5249,7 +6021,7 @@
               <a:t>Hi-Lift Jack Company. (n.d.-b). </a:t>
             </a:r>
             <a:r>
-              <a:rPr sz="1300" b="0" i="1">
+              <a:rPr sz="900" b="0" i="1">
                 <a:solidFill>
                   <a:srgbClr val="222222"/>
                 </a:solidFill>
@@ -5258,7 +6030,7 @@
               <a:t>Hi-Lift jack instructions</a:t>
             </a:r>
             <a:r>
-              <a:rPr sz="1300" b="0" i="0">
+              <a:rPr sz="900" b="0" i="0">
                 <a:solidFill>
                   <a:srgbClr val="222222"/>
                 </a:solidFill>
@@ -5270,11 +6042,11 @@
           <a:p>
             <a:pPr>
               <a:spcAft>
-                <a:spcPts val="600"/>
-              </a:spcAft>
-            </a:pPr>
-            <a:r>
-              <a:rPr sz="1300" b="0">
+                <a:spcPts val="200"/>
+              </a:spcAft>
+            </a:pPr>
+            <a:r>
+              <a:rPr sz="900" b="0">
                 <a:solidFill>
                   <a:srgbClr val="222222"/>
                 </a:solidFill>
@@ -5283,7 +6055,7 @@
               <a:t>Joyce/Dayton. (n.d.). </a:t>
             </a:r>
             <a:r>
-              <a:rPr sz="1300" b="0" i="1">
+              <a:rPr sz="900" b="0" i="1">
                 <a:solidFill>
                   <a:srgbClr val="222222"/>
                 </a:solidFill>
@@ -5292,7 +6064,7 @@
               <a:t>Machine screw jacks vs. ball screw jacks</a:t>
             </a:r>
             <a:r>
-              <a:rPr sz="1300" b="0" i="0">
+              <a:rPr sz="900" b="0" i="0">
                 <a:solidFill>
                   <a:srgbClr val="222222"/>
                 </a:solidFill>
@@ -5304,11 +6076,11 @@
           <a:p>
             <a:pPr>
               <a:spcAft>
-                <a:spcPts val="600"/>
-              </a:spcAft>
-            </a:pPr>
-            <a:r>
-              <a:rPr sz="1300" b="0">
+                <a:spcPts val="200"/>
+              </a:spcAft>
+            </a:pPr>
+            <a:r>
+              <a:rPr sz="900" b="0">
                 <a:solidFill>
                   <a:srgbClr val="222222"/>
                 </a:solidFill>
@@ -5317,7 +6089,7 @@
               <a:t>Juds, D. H. (1967). </a:t>
             </a:r>
             <a:r>
-              <a:rPr sz="1300" b="0" i="1">
+              <a:rPr sz="900" b="0" i="1">
                 <a:solidFill>
                   <a:srgbClr val="222222"/>
                 </a:solidFill>
@@ -5326,7 +6098,7 @@
               <a:t>Combination hydraulic and pneumatic jacks</a:t>
             </a:r>
             <a:r>
-              <a:rPr sz="1300" b="0" i="0">
+              <a:rPr sz="900" b="0" i="0">
                 <a:solidFill>
                   <a:srgbClr val="222222"/>
                 </a:solidFill>
@@ -5338,11 +6110,11 @@
           <a:p>
             <a:pPr>
               <a:spcAft>
-                <a:spcPts val="600"/>
-              </a:spcAft>
-            </a:pPr>
-            <a:r>
-              <a:rPr sz="1300" b="0">
+                <a:spcPts val="200"/>
+              </a:spcAft>
+            </a:pPr>
+            <a:r>
+              <a:rPr sz="900" b="0">
                 <a:solidFill>
                   <a:srgbClr val="222222"/>
                 </a:solidFill>
@@ -5351,7 +6123,7 @@
               <a:t>Junkyard Mob. (n.d.). </a:t>
             </a:r>
             <a:r>
-              <a:rPr sz="1300" b="0" i="1">
+              <a:rPr sz="900" b="0" i="1">
                 <a:solidFill>
                   <a:srgbClr val="222222"/>
                 </a:solidFill>
@@ -5360,13 +6132,580 @@
               <a:t>Car jack history and how to identify antique models</a:t>
             </a:r>
             <a:r>
-              <a:rPr sz="1300" b="0" i="0">
+              <a:rPr sz="900" b="0" i="0">
                 <a:solidFill>
                   <a:srgbClr val="222222"/>
                 </a:solidFill>
                 <a:latin typeface="Calibri"/>
               </a:rPr>
               <a:t>. https://www.junkyardmob.com/misc/antique-car-jack-identification/</a:t>
+            </a:r>
+          </a:p>
+          <a:p>
+            <a:pPr>
+              <a:spcAft>
+                <a:spcPts val="200"/>
+              </a:spcAft>
+            </a:pPr>
+            <a:r>
+              <a:rPr sz="900" b="0">
+                <a:solidFill>
+                  <a:srgbClr val="222222"/>
+                </a:solidFill>
+                <a:latin typeface="Calibri"/>
+              </a:rPr>
+              <a:t>LaFrance, J. (1920). </a:t>
+            </a:r>
+            <a:r>
+              <a:rPr sz="900" b="0" i="1">
+                <a:solidFill>
+                  <a:srgbClr val="222222"/>
+                </a:solidFill>
+                <a:latin typeface="Calibri"/>
+              </a:rPr>
+              <a:t>Jack</a:t>
+            </a:r>
+            <a:r>
+              <a:rPr sz="900" b="0" i="0">
+                <a:solidFill>
+                  <a:srgbClr val="222222"/>
+                </a:solidFill>
+                <a:latin typeface="Calibri"/>
+              </a:rPr>
+              <a:t> (U.S. Patent No. 1,362,630). https://patents.google.com/patent/US1362630A/en</a:t>
+            </a:r>
+          </a:p>
+          <a:p>
+            <a:pPr>
+              <a:spcAft>
+                <a:spcPts val="200"/>
+              </a:spcAft>
+            </a:pPr>
+            <a:r>
+              <a:rPr sz="900" b="0">
+                <a:solidFill>
+                  <a:srgbClr val="222222"/>
+                </a:solidFill>
+                <a:latin typeface="Calibri"/>
+              </a:rPr>
+              <a:t>LibreTexts. (n.d.). </a:t>
+            </a:r>
+            <a:r>
+              <a:rPr sz="900" b="0" i="1">
+                <a:solidFill>
+                  <a:srgbClr val="222222"/>
+                </a:solidFill>
+                <a:latin typeface="Calibri"/>
+              </a:rPr>
+              <a:t>10.2: Force multiplication</a:t>
+            </a:r>
+            <a:r>
+              <a:rPr sz="900" b="0" i="0">
+                <a:solidFill>
+                  <a:srgbClr val="222222"/>
+                </a:solidFill>
+                <a:latin typeface="Calibri"/>
+              </a:rPr>
+              <a:t>. https://eng.libretexts.org/Courses/Northeast_Wisconsin_Technical_College/Fluids_1:_Fluid_Power_and_Pneumatics_(NWTC)/10:_Pascal's_Law/10.02:_Force_Multiplication</a:t>
+            </a:r>
+          </a:p>
+        </p:txBody>
+      </p:sp>
+      <p:sp>
+        <p:nvSpPr>
+          <p:cNvPr id="7" name="TextBox 6"/>
+          <p:cNvSpPr txBox="1"/>
+          <p:nvPr/>
+        </p:nvSpPr>
+        <p:spPr>
+          <a:xfrm>
+            <a:off x="6126479" y="1325880"/>
+            <a:ext cx="5440680" cy="4937760"/>
+          </a:xfrm>
+          <a:prstGeom prst="rect">
+            <a:avLst/>
+          </a:prstGeom>
+          <a:noFill/>
+        </p:spPr>
+        <p:txBody>
+          <a:bodyPr wrap="square" anchor="t" lIns="45720" rIns="45720">
+            <a:spAutoFit/>
+          </a:bodyPr>
+          <a:lstStyle/>
+          <a:p>
+            <a:pPr algn="l">
+              <a:spcAft>
+                <a:spcPts val="200"/>
+              </a:spcAft>
+            </a:pPr>
+            <a:r>
+              <a:rPr sz="900" b="0">
+                <a:solidFill>
+                  <a:srgbClr val="222222"/>
+                </a:solidFill>
+                <a:latin typeface="Calibri"/>
+              </a:rPr>
+              <a:t>Mickael, E. (2004). </a:t>
+            </a:r>
+            <a:r>
+              <a:rPr sz="900" b="0" i="1">
+                <a:solidFill>
+                  <a:srgbClr val="222222"/>
+                </a:solidFill>
+                <a:latin typeface="Calibri"/>
+              </a:rPr>
+              <a:t>Motor driven scissor jack with limit switches</a:t>
+            </a:r>
+            <a:r>
+              <a:rPr sz="900" b="0" i="0">
+                <a:solidFill>
+                  <a:srgbClr val="222222"/>
+                </a:solidFill>
+                <a:latin typeface="Calibri"/>
+              </a:rPr>
+              <a:t> (U.S. Patent No. 6,695,289). https://patents.google.com/patent/US6695289B1/en</a:t>
+            </a:r>
+          </a:p>
+          <a:p>
+            <a:pPr>
+              <a:spcAft>
+                <a:spcPts val="200"/>
+              </a:spcAft>
+            </a:pPr>
+            <a:r>
+              <a:rPr sz="900" b="0">
+                <a:solidFill>
+                  <a:srgbClr val="222222"/>
+                </a:solidFill>
+                <a:latin typeface="Calibri"/>
+              </a:rPr>
+              <a:t>Pro-Lift-Montagetechnik. (n.d.). </a:t>
+            </a:r>
+            <a:r>
+              <a:rPr sz="900" b="0" i="1">
+                <a:solidFill>
+                  <a:srgbClr val="222222"/>
+                </a:solidFill>
+                <a:latin typeface="Calibri"/>
+              </a:rPr>
+              <a:t>12V electric scissor jack, car jack, 123 mm – 345 mm</a:t>
+            </a:r>
+            <a:r>
+              <a:rPr sz="900" b="0" i="0">
+                <a:solidFill>
+                  <a:srgbClr val="222222"/>
+                </a:solidFill>
+                <a:latin typeface="Calibri"/>
+              </a:rPr>
+              <a:t>. https://www.pro-lift-montagetechnik.com/12-volt-electric-scissor-jack-car-jack-123mm-345mm-002</a:t>
+            </a:r>
+          </a:p>
+          <a:p>
+            <a:pPr>
+              <a:spcAft>
+                <a:spcPts val="200"/>
+              </a:spcAft>
+            </a:pPr>
+            <a:r>
+              <a:rPr sz="900" b="0">
+                <a:solidFill>
+                  <a:srgbClr val="222222"/>
+                </a:solidFill>
+                <a:latin typeface="Calibri"/>
+              </a:rPr>
+              <a:t>Redline Stands. (n.d.). </a:t>
+            </a:r>
+            <a:r>
+              <a:rPr sz="900" b="0" i="1">
+                <a:solidFill>
+                  <a:srgbClr val="222222"/>
+                </a:solidFill>
+                <a:latin typeface="Calibri"/>
+              </a:rPr>
+              <a:t>Bottle jack vs. floor jack: Differences, pros, and cons</a:t>
+            </a:r>
+            <a:r>
+              <a:rPr sz="900" b="0" i="0">
+                <a:solidFill>
+                  <a:srgbClr val="222222"/>
+                </a:solidFill>
+                <a:latin typeface="Calibri"/>
+              </a:rPr>
+              <a:t>. https://www.redlinestands.com/blog/bottle-jack-vs-floor-jack/</a:t>
+            </a:r>
+          </a:p>
+          <a:p>
+            <a:pPr>
+              <a:spcAft>
+                <a:spcPts val="200"/>
+              </a:spcAft>
+            </a:pPr>
+            <a:r>
+              <a:rPr sz="900" b="0">
+                <a:solidFill>
+                  <a:srgbClr val="222222"/>
+                </a:solidFill>
+                <a:latin typeface="Calibri"/>
+              </a:rPr>
+              <a:t>Richard Dudgeon, Inc. (n.d.). </a:t>
+            </a:r>
+            <a:r>
+              <a:rPr sz="900" b="0" i="1">
+                <a:solidFill>
+                  <a:srgbClr val="222222"/>
+                </a:solidFill>
+                <a:latin typeface="Calibri"/>
+              </a:rPr>
+              <a:t>History</a:t>
+            </a:r>
+            <a:r>
+              <a:rPr sz="900" b="0" i="0">
+                <a:solidFill>
+                  <a:srgbClr val="222222"/>
+                </a:solidFill>
+                <a:latin typeface="Calibri"/>
+              </a:rPr>
+              <a:t>. https://www.dudgeonjacks.com/history.html</a:t>
+            </a:r>
+          </a:p>
+          <a:p>
+            <a:pPr>
+              <a:spcAft>
+                <a:spcPts val="200"/>
+              </a:spcAft>
+            </a:pPr>
+            <a:r>
+              <a:rPr sz="900" b="0">
+                <a:solidFill>
+                  <a:srgbClr val="222222"/>
+                </a:solidFill>
+                <a:latin typeface="Calibri"/>
+              </a:rPr>
+              <a:t>Roton Products. (n.d.). </a:t>
+            </a:r>
+            <a:r>
+              <a:rPr sz="900" b="0" i="1">
+                <a:solidFill>
+                  <a:srgbClr val="222222"/>
+                </a:solidFill>
+                <a:latin typeface="Calibri"/>
+              </a:rPr>
+              <a:t>Trapezoidal lead screws: General information</a:t>
+            </a:r>
+            <a:r>
+              <a:rPr sz="900" b="0" i="0">
+                <a:solidFill>
+                  <a:srgbClr val="222222"/>
+                </a:solidFill>
+                <a:latin typeface="Calibri"/>
+              </a:rPr>
+              <a:t>. https://www.roton.com/products/trapezoidal-lead-screws-nuts/general-information/</a:t>
+            </a:r>
+          </a:p>
+          <a:p>
+            <a:pPr>
+              <a:spcAft>
+                <a:spcPts val="200"/>
+              </a:spcAft>
+            </a:pPr>
+            <a:r>
+              <a:rPr sz="900" b="0">
+                <a:solidFill>
+                  <a:srgbClr val="222222"/>
+                </a:solidFill>
+                <a:latin typeface="Calibri"/>
+              </a:rPr>
+              <a:t>Sider Ticino. (n.d.). </a:t>
+            </a:r>
+            <a:r>
+              <a:rPr sz="900" b="0" i="1">
+                <a:solidFill>
+                  <a:srgbClr val="222222"/>
+                </a:solidFill>
+                <a:latin typeface="Calibri"/>
+              </a:rPr>
+              <a:t>42CrMo4 technical specifications</a:t>
+            </a:r>
+            <a:r>
+              <a:rPr sz="900" b="0" i="0">
+                <a:solidFill>
+                  <a:srgbClr val="222222"/>
+                </a:solidFill>
+                <a:latin typeface="Calibri"/>
+              </a:rPr>
+              <a:t>. https://siderticino.it/en/steel-datasheets/42crmo4/</a:t>
+            </a:r>
+          </a:p>
+          <a:p>
+            <a:pPr>
+              <a:spcAft>
+                <a:spcPts val="200"/>
+              </a:spcAft>
+            </a:pPr>
+            <a:r>
+              <a:rPr sz="900" b="0">
+                <a:solidFill>
+                  <a:srgbClr val="222222"/>
+                </a:solidFill>
+                <a:latin typeface="Calibri"/>
+              </a:rPr>
+              <a:t>Stevenson, H. M. (1898). </a:t>
+            </a:r>
+            <a:r>
+              <a:rPr sz="900" b="0" i="1">
+                <a:solidFill>
+                  <a:srgbClr val="222222"/>
+                </a:solidFill>
+                <a:latin typeface="Calibri"/>
+              </a:rPr>
+              <a:t>Lifting-jack</a:t>
+            </a:r>
+            <a:r>
+              <a:rPr sz="900" b="0" i="0">
+                <a:solidFill>
+                  <a:srgbClr val="222222"/>
+                </a:solidFill>
+                <a:latin typeface="Calibri"/>
+              </a:rPr>
+              <a:t> (U.S. Patent No. 601,451). https://patents.google.com/patent/US601451A/en</a:t>
+            </a:r>
+          </a:p>
+          <a:p>
+            <a:pPr>
+              <a:spcAft>
+                <a:spcPts val="200"/>
+              </a:spcAft>
+            </a:pPr>
+            <a:r>
+              <a:rPr sz="900" b="0">
+                <a:solidFill>
+                  <a:srgbClr val="222222"/>
+                </a:solidFill>
+                <a:latin typeface="Calibri"/>
+              </a:rPr>
+              <a:t>The World Material. (n.d.). </a:t>
+            </a:r>
+            <a:r>
+              <a:rPr sz="900" b="0" i="1">
+                <a:solidFill>
+                  <a:srgbClr val="222222"/>
+                </a:solidFill>
+                <a:latin typeface="Calibri"/>
+              </a:rPr>
+              <a:t>EN 10025-2 S235 steel properties</a:t>
+            </a:r>
+            <a:r>
+              <a:rPr sz="900" b="0" i="0">
+                <a:solidFill>
+                  <a:srgbClr val="222222"/>
+                </a:solidFill>
+                <a:latin typeface="Calibri"/>
+              </a:rPr>
+              <a:t>. https://www.theworldmaterial.com/en-10025-2-material-s235-steel/</a:t>
+            </a:r>
+          </a:p>
+          <a:p>
+            <a:pPr>
+              <a:spcAft>
+                <a:spcPts val="200"/>
+              </a:spcAft>
+            </a:pPr>
+            <a:r>
+              <a:rPr sz="900" b="0">
+                <a:solidFill>
+                  <a:srgbClr val="222222"/>
+                </a:solidFill>
+                <a:latin typeface="Calibri"/>
+              </a:rPr>
+              <a:t>TMG Industrial. (n.d.). </a:t>
+            </a:r>
+            <a:r>
+              <a:rPr sz="900" b="0" i="1">
+                <a:solidFill>
+                  <a:srgbClr val="222222"/>
+                </a:solidFill>
+                <a:latin typeface="Calibri"/>
+              </a:rPr>
+              <a:t>Air hydraulic bottle jacks: How they work and safety tips for use</a:t>
+            </a:r>
+            <a:r>
+              <a:rPr sz="900" b="0" i="0">
+                <a:solidFill>
+                  <a:srgbClr val="222222"/>
+                </a:solidFill>
+                <a:latin typeface="Calibri"/>
+              </a:rPr>
+              <a:t>. https://tmgindustrial.ca/blogs/news/air-hydraulic-bottle-jacks-how-they-work-and-safety-tips-for-use</a:t>
+            </a:r>
+          </a:p>
+          <a:p>
+            <a:pPr>
+              <a:spcAft>
+                <a:spcPts val="200"/>
+              </a:spcAft>
+            </a:pPr>
+            <a:r>
+              <a:rPr sz="900" b="0">
+                <a:solidFill>
+                  <a:srgbClr val="222222"/>
+                </a:solidFill>
+                <a:latin typeface="Calibri"/>
+              </a:rPr>
+              <a:t>VEVOR. (n.d.). </a:t>
+            </a:r>
+            <a:r>
+              <a:rPr sz="900" b="0" i="1">
+                <a:solidFill>
+                  <a:srgbClr val="222222"/>
+                </a:solidFill>
+                <a:latin typeface="Calibri"/>
+              </a:rPr>
+              <a:t>Things to know before buying a pneumatic bottle jack</a:t>
+            </a:r>
+            <a:r>
+              <a:rPr sz="900" b="0" i="0">
+                <a:solidFill>
+                  <a:srgbClr val="222222"/>
+                </a:solidFill>
+                <a:latin typeface="Calibri"/>
+              </a:rPr>
+              <a:t>. https://www.vevor.com/diy-ideas/things-to-know-before-buying-a-pneumatic-bottle-jack/</a:t>
+            </a:r>
+          </a:p>
+          <a:p>
+            <a:pPr>
+              <a:spcAft>
+                <a:spcPts val="200"/>
+              </a:spcAft>
+            </a:pPr>
+            <a:r>
+              <a:rPr sz="900" b="0">
+                <a:solidFill>
+                  <a:srgbClr val="222222"/>
+                </a:solidFill>
+                <a:latin typeface="Calibri"/>
+              </a:rPr>
+              <a:t>Wikipedia. (n.d.-a). </a:t>
+            </a:r>
+            <a:r>
+              <a:rPr sz="900" b="0" i="1">
+                <a:solidFill>
+                  <a:srgbClr val="222222"/>
+                </a:solidFill>
+                <a:latin typeface="Calibri"/>
+              </a:rPr>
+              <a:t>Blackhawk (tools)</a:t>
+            </a:r>
+            <a:r>
+              <a:rPr sz="900" b="0" i="0">
+                <a:solidFill>
+                  <a:srgbClr val="222222"/>
+                </a:solidFill>
+                <a:latin typeface="Calibri"/>
+              </a:rPr>
+              <a:t>. https://en.wikipedia.org/wiki/Blackhawk_(tools)</a:t>
+            </a:r>
+          </a:p>
+          <a:p>
+            <a:pPr>
+              <a:spcAft>
+                <a:spcPts val="200"/>
+              </a:spcAft>
+            </a:pPr>
+            <a:r>
+              <a:rPr sz="900" b="0">
+                <a:solidFill>
+                  <a:srgbClr val="222222"/>
+                </a:solidFill>
+                <a:latin typeface="Calibri"/>
+              </a:rPr>
+              <a:t>Wikipedia. (n.d.-b). </a:t>
+            </a:r>
+            <a:r>
+              <a:rPr sz="900" b="0" i="1">
+                <a:solidFill>
+                  <a:srgbClr val="222222"/>
+                </a:solidFill>
+                <a:latin typeface="Calibri"/>
+              </a:rPr>
+              <a:t>Jackscrew</a:t>
+            </a:r>
+            <a:r>
+              <a:rPr sz="900" b="0" i="0">
+                <a:solidFill>
+                  <a:srgbClr val="222222"/>
+                </a:solidFill>
+                <a:latin typeface="Calibri"/>
+              </a:rPr>
+              <a:t>. https://en.wikipedia.org/wiki/Jackscrew</a:t>
+            </a:r>
+          </a:p>
+          <a:p>
+            <a:pPr>
+              <a:spcAft>
+                <a:spcPts val="200"/>
+              </a:spcAft>
+            </a:pPr>
+            <a:r>
+              <a:rPr sz="900" b="0">
+                <a:solidFill>
+                  <a:srgbClr val="222222"/>
+                </a:solidFill>
+                <a:latin typeface="Calibri"/>
+              </a:rPr>
+              <a:t>Wikipedia. (n.d.-c). </a:t>
+            </a:r>
+            <a:r>
+              <a:rPr sz="900" b="0" i="1">
+                <a:solidFill>
+                  <a:srgbClr val="222222"/>
+                </a:solidFill>
+                <a:latin typeface="Calibri"/>
+              </a:rPr>
+              <a:t>Richard Dudgeon</a:t>
+            </a:r>
+            <a:r>
+              <a:rPr sz="900" b="0" i="0">
+                <a:solidFill>
+                  <a:srgbClr val="222222"/>
+                </a:solidFill>
+                <a:latin typeface="Calibri"/>
+              </a:rPr>
+              <a:t>. https://en.wikipedia.org/wiki/Richard_Dudgeon</a:t>
+            </a:r>
+          </a:p>
+          <a:p>
+            <a:pPr>
+              <a:spcAft>
+                <a:spcPts val="200"/>
+              </a:spcAft>
+            </a:pPr>
+            <a:r>
+              <a:rPr sz="900" b="0">
+                <a:solidFill>
+                  <a:srgbClr val="222222"/>
+                </a:solidFill>
+                <a:latin typeface="Calibri"/>
+              </a:rPr>
+              <a:t>Wikipedia. (n.d.-d). </a:t>
+            </a:r>
+            <a:r>
+              <a:rPr sz="900" b="0" i="1">
+                <a:solidFill>
+                  <a:srgbClr val="222222"/>
+                </a:solidFill>
+                <a:latin typeface="Calibri"/>
+              </a:rPr>
+              <a:t>Spare tire</a:t>
+            </a:r>
+            <a:r>
+              <a:rPr sz="900" b="0" i="0">
+                <a:solidFill>
+                  <a:srgbClr val="222222"/>
+                </a:solidFill>
+                <a:latin typeface="Calibri"/>
+              </a:rPr>
+              <a:t>. https://en.wikipedia.org/wiki/Spare_tire</a:t>
             </a:r>
           </a:p>
         </p:txBody>
@@ -5379,7 +6718,7 @@
 </p:sld>
 </file>
 
-<file path=ppt/slides/slide12.xml><?xml version="1.0" encoding="utf-8"?>
+<file path=ppt/slides/slide2.xml><?xml version="1.0" encoding="utf-8"?>
 <p:sld xmlns:a="http://schemas.openxmlformats.org/drawingml/2006/main" xmlns:p="http://schemas.openxmlformats.org/presentationml/2006/main" xmlns:r="http://schemas.openxmlformats.org/officeDocument/2006/relationships">
   <p:cSld>
     <p:spTree>
@@ -5423,7 +6762,7 @@
                 </a:solidFill>
                 <a:latin typeface="Calibri"/>
               </a:rPr>
-              <a:t>Šaltiniai (2/2)</a:t>
+              <a:t>Funkcija: kam reikalingas domkratas?</a:t>
             </a:r>
           </a:p>
         </p:txBody>
@@ -5506,7 +6845,7 @@
                 </a:solidFill>
                 <a:latin typeface="Calibri"/>
               </a:rPr>
-              <a:t>12 / 12</a:t>
+              <a:t>2 / 12</a:t>
             </a:r>
           </a:p>
         </p:txBody>
@@ -5558,650 +6897,6 @@
         </p:nvSpPr>
         <p:spPr>
           <a:xfrm>
-            <a:off x="640080" y="1463040"/>
-            <a:ext cx="10881360" cy="4754880"/>
-          </a:xfrm>
-          <a:prstGeom prst="rect">
-            <a:avLst/>
-          </a:prstGeom>
-          <a:noFill/>
-        </p:spPr>
-        <p:txBody>
-          <a:bodyPr wrap="square" anchor="t" lIns="45720" rIns="45720">
-            <a:spAutoFit/>
-          </a:bodyPr>
-          <a:lstStyle/>
-          <a:p>
-            <a:pPr algn="l">
-              <a:spcAft>
-                <a:spcPts val="600"/>
-              </a:spcAft>
-            </a:pPr>
-            <a:r>
-              <a:rPr sz="1300" b="0">
-                <a:solidFill>
-                  <a:srgbClr val="222222"/>
-                </a:solidFill>
-                <a:latin typeface="Calibri"/>
-              </a:rPr>
-              <a:t>LaFrance, J. (1920). </a:t>
-            </a:r>
-            <a:r>
-              <a:rPr sz="1300" b="0" i="1">
-                <a:solidFill>
-                  <a:srgbClr val="222222"/>
-                </a:solidFill>
-                <a:latin typeface="Calibri"/>
-              </a:rPr>
-              <a:t>Jack</a:t>
-            </a:r>
-            <a:r>
-              <a:rPr sz="1300" b="0" i="0">
-                <a:solidFill>
-                  <a:srgbClr val="222222"/>
-                </a:solidFill>
-                <a:latin typeface="Calibri"/>
-              </a:rPr>
-              <a:t> (U.S. Patent No. 1,362,630). https://patents.google.com/patent/US1362630A/en</a:t>
-            </a:r>
-          </a:p>
-          <a:p>
-            <a:pPr>
-              <a:spcAft>
-                <a:spcPts val="600"/>
-              </a:spcAft>
-            </a:pPr>
-            <a:r>
-              <a:rPr sz="1300" b="0">
-                <a:solidFill>
-                  <a:srgbClr val="222222"/>
-                </a:solidFill>
-                <a:latin typeface="Calibri"/>
-              </a:rPr>
-              <a:t>LibreTexts. (n.d.). </a:t>
-            </a:r>
-            <a:r>
-              <a:rPr sz="1300" b="0" i="1">
-                <a:solidFill>
-                  <a:srgbClr val="222222"/>
-                </a:solidFill>
-                <a:latin typeface="Calibri"/>
-              </a:rPr>
-              <a:t>10.2: Force multiplication</a:t>
-            </a:r>
-            <a:r>
-              <a:rPr sz="1300" b="0" i="0">
-                <a:solidFill>
-                  <a:srgbClr val="222222"/>
-                </a:solidFill>
-                <a:latin typeface="Calibri"/>
-              </a:rPr>
-              <a:t>. https://eng.libretexts.org/Courses/Northeast_Wisconsin_Technical_College/Fluids_1:_Fluid_Power_and_Pneumatics_(NWTC)/10:_Pascal's_Law/10.02:_Force_Multiplication</a:t>
-            </a:r>
-          </a:p>
-          <a:p>
-            <a:pPr>
-              <a:spcAft>
-                <a:spcPts val="600"/>
-              </a:spcAft>
-            </a:pPr>
-            <a:r>
-              <a:rPr sz="1300" b="0">
-                <a:solidFill>
-                  <a:srgbClr val="222222"/>
-                </a:solidFill>
-                <a:latin typeface="Calibri"/>
-              </a:rPr>
-              <a:t>Mickael, E. (2004). </a:t>
-            </a:r>
-            <a:r>
-              <a:rPr sz="1300" b="0" i="1">
-                <a:solidFill>
-                  <a:srgbClr val="222222"/>
-                </a:solidFill>
-                <a:latin typeface="Calibri"/>
-              </a:rPr>
-              <a:t>Motor driven scissor jack with limit switches</a:t>
-            </a:r>
-            <a:r>
-              <a:rPr sz="1300" b="0" i="0">
-                <a:solidFill>
-                  <a:srgbClr val="222222"/>
-                </a:solidFill>
-                <a:latin typeface="Calibri"/>
-              </a:rPr>
-              <a:t> (U.S. Patent No. 6,695,289). https://patents.google.com/patent/US6695289B1/en</a:t>
-            </a:r>
-          </a:p>
-          <a:p>
-            <a:pPr>
-              <a:spcAft>
-                <a:spcPts val="600"/>
-              </a:spcAft>
-            </a:pPr>
-            <a:r>
-              <a:rPr sz="1300" b="0">
-                <a:solidFill>
-                  <a:srgbClr val="222222"/>
-                </a:solidFill>
-                <a:latin typeface="Calibri"/>
-              </a:rPr>
-              <a:t>Pro-Lift-Montagetechnik. (n.d.). </a:t>
-            </a:r>
-            <a:r>
-              <a:rPr sz="1300" b="0" i="1">
-                <a:solidFill>
-                  <a:srgbClr val="222222"/>
-                </a:solidFill>
-                <a:latin typeface="Calibri"/>
-              </a:rPr>
-              <a:t>12V electric scissor jack, car jack, 123 mm – 345 mm</a:t>
-            </a:r>
-            <a:r>
-              <a:rPr sz="1300" b="0" i="0">
-                <a:solidFill>
-                  <a:srgbClr val="222222"/>
-                </a:solidFill>
-                <a:latin typeface="Calibri"/>
-              </a:rPr>
-              <a:t>. https://www.pro-lift-montagetechnik.com/12-volt-electric-scissor-jack-car-jack-123mm-345mm-002</a:t>
-            </a:r>
-          </a:p>
-          <a:p>
-            <a:pPr>
-              <a:spcAft>
-                <a:spcPts val="600"/>
-              </a:spcAft>
-            </a:pPr>
-            <a:r>
-              <a:rPr sz="1300" b="0">
-                <a:solidFill>
-                  <a:srgbClr val="222222"/>
-                </a:solidFill>
-                <a:latin typeface="Calibri"/>
-              </a:rPr>
-              <a:t>Redline Stands. (n.d.). </a:t>
-            </a:r>
-            <a:r>
-              <a:rPr sz="1300" b="0" i="1">
-                <a:solidFill>
-                  <a:srgbClr val="222222"/>
-                </a:solidFill>
-                <a:latin typeface="Calibri"/>
-              </a:rPr>
-              <a:t>Bottle jack vs. floor jack: Differences, pros, and cons</a:t>
-            </a:r>
-            <a:r>
-              <a:rPr sz="1300" b="0" i="0">
-                <a:solidFill>
-                  <a:srgbClr val="222222"/>
-                </a:solidFill>
-                <a:latin typeface="Calibri"/>
-              </a:rPr>
-              <a:t>. https://www.redlinestands.com/blog/bottle-jack-vs-floor-jack/</a:t>
-            </a:r>
-          </a:p>
-          <a:p>
-            <a:pPr>
-              <a:spcAft>
-                <a:spcPts val="600"/>
-              </a:spcAft>
-            </a:pPr>
-            <a:r>
-              <a:rPr sz="1300" b="0">
-                <a:solidFill>
-                  <a:srgbClr val="222222"/>
-                </a:solidFill>
-                <a:latin typeface="Calibri"/>
-              </a:rPr>
-              <a:t>Roton Products. (n.d.). </a:t>
-            </a:r>
-            <a:r>
-              <a:rPr sz="1300" b="0" i="1">
-                <a:solidFill>
-                  <a:srgbClr val="222222"/>
-                </a:solidFill>
-                <a:latin typeface="Calibri"/>
-              </a:rPr>
-              <a:t>Trapezoidal lead screws: General information</a:t>
-            </a:r>
-            <a:r>
-              <a:rPr sz="1300" b="0" i="0">
-                <a:solidFill>
-                  <a:srgbClr val="222222"/>
-                </a:solidFill>
-                <a:latin typeface="Calibri"/>
-              </a:rPr>
-              <a:t>. https://www.roton.com/products/trapezoidal-lead-screws-nuts/general-information/</a:t>
-            </a:r>
-          </a:p>
-          <a:p>
-            <a:pPr>
-              <a:spcAft>
-                <a:spcPts val="600"/>
-              </a:spcAft>
-            </a:pPr>
-            <a:r>
-              <a:rPr sz="1300" b="0">
-                <a:solidFill>
-                  <a:srgbClr val="222222"/>
-                </a:solidFill>
-                <a:latin typeface="Calibri"/>
-              </a:rPr>
-              <a:t>Sider Ticino. (n.d.). </a:t>
-            </a:r>
-            <a:r>
-              <a:rPr sz="1300" b="0" i="1">
-                <a:solidFill>
-                  <a:srgbClr val="222222"/>
-                </a:solidFill>
-                <a:latin typeface="Calibri"/>
-              </a:rPr>
-              <a:t>42CrMo4 technical specifications</a:t>
-            </a:r>
-            <a:r>
-              <a:rPr sz="1300" b="0" i="0">
-                <a:solidFill>
-                  <a:srgbClr val="222222"/>
-                </a:solidFill>
-                <a:latin typeface="Calibri"/>
-              </a:rPr>
-              <a:t>. https://siderticino.it/en/steel-datasheets/42crmo4/</a:t>
-            </a:r>
-          </a:p>
-          <a:p>
-            <a:pPr>
-              <a:spcAft>
-                <a:spcPts val="600"/>
-              </a:spcAft>
-            </a:pPr>
-            <a:r>
-              <a:rPr sz="1300" b="0">
-                <a:solidFill>
-                  <a:srgbClr val="222222"/>
-                </a:solidFill>
-                <a:latin typeface="Calibri"/>
-              </a:rPr>
-              <a:t>Stevenson, H. M. (1898). </a:t>
-            </a:r>
-            <a:r>
-              <a:rPr sz="1300" b="0" i="1">
-                <a:solidFill>
-                  <a:srgbClr val="222222"/>
-                </a:solidFill>
-                <a:latin typeface="Calibri"/>
-              </a:rPr>
-              <a:t>Lifting-jack</a:t>
-            </a:r>
-            <a:r>
-              <a:rPr sz="1300" b="0" i="0">
-                <a:solidFill>
-                  <a:srgbClr val="222222"/>
-                </a:solidFill>
-                <a:latin typeface="Calibri"/>
-              </a:rPr>
-              <a:t> (U.S. Patent No. 601,451). https://patents.google.com/patent/US601451A/en</a:t>
-            </a:r>
-          </a:p>
-          <a:p>
-            <a:pPr>
-              <a:spcAft>
-                <a:spcPts val="600"/>
-              </a:spcAft>
-            </a:pPr>
-            <a:r>
-              <a:rPr sz="1300" b="0">
-                <a:solidFill>
-                  <a:srgbClr val="222222"/>
-                </a:solidFill>
-                <a:latin typeface="Calibri"/>
-              </a:rPr>
-              <a:t>The World Material. (n.d.). </a:t>
-            </a:r>
-            <a:r>
-              <a:rPr sz="1300" b="0" i="1">
-                <a:solidFill>
-                  <a:srgbClr val="222222"/>
-                </a:solidFill>
-                <a:latin typeface="Calibri"/>
-              </a:rPr>
-              <a:t>EN 10025-2 S235 steel properties</a:t>
-            </a:r>
-            <a:r>
-              <a:rPr sz="1300" b="0" i="0">
-                <a:solidFill>
-                  <a:srgbClr val="222222"/>
-                </a:solidFill>
-                <a:latin typeface="Calibri"/>
-              </a:rPr>
-              <a:t>. https://www.theworldmaterial.com/en-10025-2-material-s235-steel/</a:t>
-            </a:r>
-          </a:p>
-          <a:p>
-            <a:pPr>
-              <a:spcAft>
-                <a:spcPts val="600"/>
-              </a:spcAft>
-            </a:pPr>
-            <a:r>
-              <a:rPr sz="1300" b="0">
-                <a:solidFill>
-                  <a:srgbClr val="222222"/>
-                </a:solidFill>
-                <a:latin typeface="Calibri"/>
-              </a:rPr>
-              <a:t>TMG Industrial. (n.d.). </a:t>
-            </a:r>
-            <a:r>
-              <a:rPr sz="1300" b="0" i="1">
-                <a:solidFill>
-                  <a:srgbClr val="222222"/>
-                </a:solidFill>
-                <a:latin typeface="Calibri"/>
-              </a:rPr>
-              <a:t>Air hydraulic bottle jacks: How they work and safety tips for use</a:t>
-            </a:r>
-            <a:r>
-              <a:rPr sz="1300" b="0" i="0">
-                <a:solidFill>
-                  <a:srgbClr val="222222"/>
-                </a:solidFill>
-                <a:latin typeface="Calibri"/>
-              </a:rPr>
-              <a:t>. https://tmgindustrial.ca/blogs/news/air-hydraulic-bottle-jacks-how-they-work-and-safety-tips-for-use</a:t>
-            </a:r>
-          </a:p>
-          <a:p>
-            <a:pPr>
-              <a:spcAft>
-                <a:spcPts val="600"/>
-              </a:spcAft>
-            </a:pPr>
-            <a:r>
-              <a:rPr sz="1300" b="0">
-                <a:solidFill>
-                  <a:srgbClr val="222222"/>
-                </a:solidFill>
-                <a:latin typeface="Calibri"/>
-              </a:rPr>
-              <a:t>VEVOR. (n.d.). </a:t>
-            </a:r>
-            <a:r>
-              <a:rPr sz="1300" b="0" i="1">
-                <a:solidFill>
-                  <a:srgbClr val="222222"/>
-                </a:solidFill>
-                <a:latin typeface="Calibri"/>
-              </a:rPr>
-              <a:t>Things to know before buying a pneumatic bottle jack</a:t>
-            </a:r>
-            <a:r>
-              <a:rPr sz="1300" b="0" i="0">
-                <a:solidFill>
-                  <a:srgbClr val="222222"/>
-                </a:solidFill>
-                <a:latin typeface="Calibri"/>
-              </a:rPr>
-              <a:t>. https://www.vevor.com/diy-ideas/things-to-know-before-buying-a-pneumatic-bottle-jack/</a:t>
-            </a:r>
-          </a:p>
-          <a:p>
-            <a:pPr>
-              <a:spcAft>
-                <a:spcPts val="600"/>
-              </a:spcAft>
-            </a:pPr>
-            <a:r>
-              <a:rPr sz="1300" b="0">
-                <a:solidFill>
-                  <a:srgbClr val="222222"/>
-                </a:solidFill>
-                <a:latin typeface="Calibri"/>
-              </a:rPr>
-              <a:t>Wikipedia. (n.d.-a). </a:t>
-            </a:r>
-            <a:r>
-              <a:rPr sz="1300" b="0" i="1">
-                <a:solidFill>
-                  <a:srgbClr val="222222"/>
-                </a:solidFill>
-                <a:latin typeface="Calibri"/>
-              </a:rPr>
-              <a:t>Jackscrew</a:t>
-            </a:r>
-            <a:r>
-              <a:rPr sz="1300" b="0" i="0">
-                <a:solidFill>
-                  <a:srgbClr val="222222"/>
-                </a:solidFill>
-                <a:latin typeface="Calibri"/>
-              </a:rPr>
-              <a:t>. https://en.wikipedia.org/wiki/Jackscrew</a:t>
-            </a:r>
-          </a:p>
-          <a:p>
-            <a:pPr>
-              <a:spcAft>
-                <a:spcPts val="600"/>
-              </a:spcAft>
-            </a:pPr>
-            <a:r>
-              <a:rPr sz="1300" b="0">
-                <a:solidFill>
-                  <a:srgbClr val="222222"/>
-                </a:solidFill>
-                <a:latin typeface="Calibri"/>
-              </a:rPr>
-              <a:t>Wikipedia. (n.d.-b). </a:t>
-            </a:r>
-            <a:r>
-              <a:rPr sz="1300" b="0" i="1">
-                <a:solidFill>
-                  <a:srgbClr val="222222"/>
-                </a:solidFill>
-                <a:latin typeface="Calibri"/>
-              </a:rPr>
-              <a:t>Spare tire</a:t>
-            </a:r>
-            <a:r>
-              <a:rPr sz="1300" b="0" i="0">
-                <a:solidFill>
-                  <a:srgbClr val="222222"/>
-                </a:solidFill>
-                <a:latin typeface="Calibri"/>
-              </a:rPr>
-              <a:t>. https://en.wikipedia.org/wiki/Spare_tire</a:t>
-            </a:r>
-          </a:p>
-        </p:txBody>
-      </p:sp>
-    </p:spTree>
-  </p:cSld>
-  <p:clrMapOvr>
-    <a:masterClrMapping/>
-  </p:clrMapOvr>
-</p:sld>
-</file>
-
-<file path=ppt/slides/slide2.xml><?xml version="1.0" encoding="utf-8"?>
-<p:sld xmlns:a="http://schemas.openxmlformats.org/drawingml/2006/main" xmlns:p="http://schemas.openxmlformats.org/presentationml/2006/main" xmlns:r="http://schemas.openxmlformats.org/officeDocument/2006/relationships">
-  <p:cSld>
-    <p:spTree>
-      <p:nvGrpSpPr>
-        <p:cNvPr id="1" name=""/>
-        <p:cNvGrpSpPr/>
-        <p:nvPr/>
-      </p:nvGrpSpPr>
-      <p:grpSpPr/>
-      <p:sp>
-        <p:nvSpPr>
-          <p:cNvPr id="2" name="TextBox 1"/>
-          <p:cNvSpPr txBox="1"/>
-          <p:nvPr/>
-        </p:nvSpPr>
-        <p:spPr>
-          <a:xfrm>
-            <a:off x="548640" y="320040"/>
-            <a:ext cx="11064240" cy="822960"/>
-          </a:xfrm>
-          <a:prstGeom prst="rect">
-            <a:avLst/>
-          </a:prstGeom>
-          <a:noFill/>
-        </p:spPr>
-        <p:txBody>
-          <a:bodyPr wrap="square" anchor="b" lIns="45720" rIns="45720">
-            <a:spAutoFit/>
-          </a:bodyPr>
-          <a:lstStyle/>
-          <a:p>
-            <a:pPr algn="l">
-              <a:spcAft>
-                <a:spcPts val="600"/>
-              </a:spcAft>
-            </a:pPr>
-            <a:r>
-              <a:rPr sz="3200" b="1">
-                <a:solidFill>
-                  <a:srgbClr val="1F4E79"/>
-                </a:solidFill>
-                <a:latin typeface="Calibri"/>
-              </a:rPr>
-              <a:t>Kodėl prireikė domkrato?</a:t>
-            </a:r>
-          </a:p>
-        </p:txBody>
-      </p:sp>
-      <p:sp>
-        <p:nvSpPr>
-          <p:cNvPr id="3" name="Rectangle 2"/>
-          <p:cNvSpPr/>
-          <p:nvPr/>
-        </p:nvSpPr>
-        <p:spPr>
-          <a:xfrm>
-            <a:off x="594360" y="1207008"/>
-            <a:ext cx="10972800" cy="27432"/>
-          </a:xfrm>
-          <a:prstGeom prst="rect">
-            <a:avLst/>
-          </a:prstGeom>
-          <a:solidFill>
-            <a:srgbClr val="1F4E79"/>
-          </a:solidFill>
-          <a:ln>
-            <a:noFill/>
-          </a:ln>
-          <a:effectLst/>
-        </p:spPr>
-        <p:style>
-          <a:lnRef idx="1">
-            <a:schemeClr val="accent1"/>
-          </a:lnRef>
-          <a:fillRef idx="3">
-            <a:schemeClr val="accent1"/>
-          </a:fillRef>
-          <a:effectRef idx="2">
-            <a:schemeClr val="accent1"/>
-          </a:effectRef>
-          <a:fontRef idx="minor">
-            <a:schemeClr val="lt1"/>
-          </a:fontRef>
-        </p:style>
-        <p:txBody>
-          <a:bodyPr rtlCol="0" anchor="ctr"/>
-          <a:lstStyle/>
-          <a:p>
-            <a:pPr algn="ctr"/>
-          </a:p>
-        </p:txBody>
-      </p:sp>
-      <p:sp>
-        <p:nvSpPr>
-          <p:cNvPr id="4" name="TextBox 3"/>
-          <p:cNvSpPr txBox="1"/>
-          <p:nvPr/>
-        </p:nvSpPr>
-        <p:spPr>
-          <a:xfrm>
-            <a:off x="10698480" y="6355080"/>
-            <a:ext cx="1005840" cy="365760"/>
-          </a:xfrm>
-          <a:prstGeom prst="rect">
-            <a:avLst/>
-          </a:prstGeom>
-          <a:noFill/>
-        </p:spPr>
-        <p:txBody>
-          <a:bodyPr wrap="square" anchor="t" lIns="45720" rIns="45720">
-            <a:spAutoFit/>
-          </a:bodyPr>
-          <a:lstStyle/>
-          <a:p>
-            <a:pPr algn="r">
-              <a:spcAft>
-                <a:spcPts val="600"/>
-              </a:spcAft>
-            </a:pPr>
-            <a:r>
-              <a:rPr sz="1200" b="0">
-                <a:solidFill>
-                  <a:srgbClr val="595959"/>
-                </a:solidFill>
-                <a:latin typeface="Calibri"/>
-              </a:rPr>
-              <a:t>2 / 12</a:t>
-            </a:r>
-          </a:p>
-        </p:txBody>
-      </p:sp>
-      <p:sp>
-        <p:nvSpPr>
-          <p:cNvPr id="5" name="TextBox 4"/>
-          <p:cNvSpPr txBox="1"/>
-          <p:nvPr/>
-        </p:nvSpPr>
-        <p:spPr>
-          <a:xfrm>
-            <a:off x="548640" y="6355080"/>
-            <a:ext cx="7315200" cy="365760"/>
-          </a:xfrm>
-          <a:prstGeom prst="rect">
-            <a:avLst/>
-          </a:prstGeom>
-          <a:noFill/>
-        </p:spPr>
-        <p:txBody>
-          <a:bodyPr wrap="square" anchor="t" lIns="45720" rIns="45720">
-            <a:spAutoFit/>
-          </a:bodyPr>
-          <a:lstStyle/>
-          <a:p>
-            <a:pPr algn="l">
-              <a:spcAft>
-                <a:spcPts val="600"/>
-              </a:spcAft>
-            </a:pPr>
-            <a:r>
-              <a:rPr sz="1200" b="0">
-                <a:solidFill>
-                  <a:srgbClr val="595959"/>
-                </a:solidFill>
-                <a:latin typeface="Calibri"/>
-              </a:rPr>
-              <a:t>PBL · Automobilinis domkratas</a:t>
-            </a:r>
-          </a:p>
-        </p:txBody>
-      </p:sp>
-      <p:sp>
-        <p:nvSpPr>
-          <p:cNvPr id="6" name="TextBox 5"/>
-          <p:cNvSpPr txBox="1"/>
-          <p:nvPr/>
-        </p:nvSpPr>
-        <p:spPr>
-          <a:xfrm>
             <a:off x="640080" y="1554480"/>
             <a:ext cx="6400800" cy="4206240"/>
           </a:xfrm>
@@ -6218,101 +6913,101 @@
           <a:p>
             <a:pPr algn="l">
               <a:spcAft>
-                <a:spcPts val="1600"/>
-              </a:spcAft>
-            </a:pPr>
-            <a:r>
-              <a:rPr sz="2100" b="1">
+                <a:spcPts val="1400"/>
+              </a:spcAft>
+            </a:pPr>
+            <a:r>
+              <a:rPr sz="2000" b="1">
                 <a:solidFill>
                   <a:srgbClr val="222222"/>
                 </a:solidFill>
                 <a:latin typeface="Calibri"/>
               </a:rPr>
+              <a:t>• Funkcija</a:t>
+            </a:r>
+            <a:r>
+              <a:rPr sz="2000" b="0" i="0">
+                <a:solidFill>
+                  <a:srgbClr val="222222"/>
+                </a:solidFill>
+                <a:latin typeface="Calibri"/>
+              </a:rPr>
+              <a:t> – nedidele žmogaus jėga pakelti sunkų krovinį, pvz., automobilio kampą, kad būtų galima pakeisti ratą.</a:t>
+            </a:r>
+          </a:p>
+          <a:p>
+            <a:pPr>
+              <a:spcAft>
+                <a:spcPts val="1400"/>
+              </a:spcAft>
+            </a:pPr>
+            <a:r>
+              <a:rPr sz="2000" b="1">
+                <a:solidFill>
+                  <a:srgbClr val="222222"/>
+                </a:solidFill>
+                <a:latin typeface="Calibri"/>
+              </a:rPr>
+              <a:t>• Kaip tai pavyksta</a:t>
+            </a:r>
+            <a:r>
+              <a:rPr sz="2000" b="0" i="0">
+                <a:solidFill>
+                  <a:srgbClr val="222222"/>
+                </a:solidFill>
+                <a:latin typeface="Calibri"/>
+              </a:rPr>
+              <a:t> – sraigtas ar svirtis: maža jėga, bet ilgas kelias; hidraulika: pagal Paskalio dėsnį didesnis stūmoklis duoda didesnę jėgą.</a:t>
+            </a:r>
+          </a:p>
+          <a:p>
+            <a:pPr>
+              <a:spcAft>
+                <a:spcPts val="1400"/>
+              </a:spcAft>
+            </a:pPr>
+            <a:r>
+              <a:rPr sz="2000" b="1">
+                <a:solidFill>
+                  <a:srgbClr val="222222"/>
+                </a:solidFill>
+                <a:latin typeface="Calibri"/>
+              </a:rPr>
               <a:t>• Prieš automobilius</a:t>
             </a:r>
             <a:r>
-              <a:rPr sz="2100" b="0" i="0">
+              <a:rPr sz="2000" b="0" i="0">
                 <a:solidFill>
                   <a:srgbClr val="222222"/>
                 </a:solidFill>
                 <a:latin typeface="Calibri"/>
               </a:rPr>
-              <a:t> – vežimams kelti naudoti paprasti svertiniai domkratai (dešinėje – 1882 m. vežimo domkratas).</a:t>
+              <a:t> – vežimams kelti naudoti svertiniai domkratai (dešinėje – 1882 m. vežimo domkratas).</a:t>
             </a:r>
           </a:p>
           <a:p>
             <a:pPr>
               <a:spcAft>
-                <a:spcPts val="1600"/>
-              </a:spcAft>
-            </a:pPr>
-            <a:r>
-              <a:rPr sz="2100" b="1">
+                <a:spcPts val="1400"/>
+              </a:spcAft>
+            </a:pPr>
+            <a:r>
+              <a:rPr sz="2000" b="1">
                 <a:solidFill>
                   <a:srgbClr val="222222"/>
                 </a:solidFill>
                 <a:latin typeface="Calibri"/>
               </a:rPr>
-              <a:t>• Pirmieji automobiliai</a:t>
-            </a:r>
-            <a:r>
-              <a:rPr sz="2100" b="0" i="0">
+              <a:t>• Kodėl prireikė automobiliams</a:t>
+            </a:r>
+            <a:r>
+              <a:rPr sz="2000" b="0" i="0">
                 <a:solidFill>
                   <a:srgbClr val="222222"/>
                 </a:solidFill>
                 <a:latin typeface="Calibri"/>
               </a:rPr>
-              <a:t> – keliuose gulėjo daug pasagų vinių, todėl padangos prakiurdavo labai dažnai, kartais kelis kartus per vieną išvyką.</a:t>
-            </a:r>
-          </a:p>
-          <a:p>
-            <a:pPr>
-              <a:spcAft>
-                <a:spcPts val="1600"/>
-              </a:spcAft>
-            </a:pPr>
-            <a:r>
-              <a:rPr sz="2100" b="1">
-                <a:solidFill>
-                  <a:srgbClr val="222222"/>
-                </a:solidFill>
-                <a:latin typeface="Calibri"/>
-              </a:rPr>
-              <a:t>• Ką tekdavo daryti</a:t>
-            </a:r>
-            <a:r>
-              <a:rPr sz="2100" b="0" i="0">
-                <a:solidFill>
-                  <a:srgbClr val="222222"/>
-                </a:solidFill>
-                <a:latin typeface="Calibri"/>
-              </a:rPr>
-              <a:t> – pakelti automobilį, nuimti ratą, užklijuoti kamerą ir vėl viską surinkti.</a:t>
-            </a:r>
-          </a:p>
-          <a:p>
-            <a:pPr>
-              <a:spcAft>
-                <a:spcPts val="1600"/>
-              </a:spcAft>
-            </a:pPr>
-            <a:r>
-              <a:rPr sz="2100" b="1">
-                <a:solidFill>
-                  <a:srgbClr val="222222"/>
-                </a:solidFill>
-                <a:latin typeface="Calibri"/>
-              </a:rPr>
-              <a:t>• Išvada gamintojams</a:t>
-            </a:r>
-            <a:r>
-              <a:rPr sz="2100" b="0" i="0">
-                <a:solidFill>
-                  <a:srgbClr val="222222"/>
-                </a:solidFill>
-                <a:latin typeface="Calibri"/>
-              </a:rPr>
-              <a:t> – kiekviename automobilyje reikia nešiojamo, paprasto ir pakankamai stipraus domkrato.</a:t>
+              <a:t> – keliuose gulėjo daug pasagų vinių, padangos prakiurdavo labai dažnai, todėl domkrato reikėjo kiekviename automobilyje.</a:t>
             </a:r>
           </a:p>
         </p:txBody>
@@ -6458,7 +7153,7 @@
                 </a:solidFill>
                 <a:latin typeface="Calibri"/>
               </a:rPr>
-              <a:t>Šaltiniai: Bovey (1882); Wikipedia (n.d.-b); Junkyard Mob (n.d.).</a:t>
+              <a:t>Šaltiniai: Joyce/Dayton (n.d.); LibreTexts (n.d.); Bovey (1882); Wikipedia (n.d.-d); Junkyard Mob (n.d.).</a:t>
             </a:r>
           </a:p>
         </p:txBody>
@@ -6515,7 +7210,7 @@
                 </a:solidFill>
                 <a:latin typeface="Calibri"/>
               </a:rPr>
-              <a:t>Domkratų raida laiko juostoje</a:t>
+              <a:t>Istorija: domkratų raida laiko juostoje</a:t>
             </a:r>
           </a:p>
         </p:txBody>
@@ -7939,7 +8634,7 @@
                 </a:solidFill>
                 <a:latin typeface="Calibri"/>
               </a:rPr>
-              <a:t>Šaltiniai: Stevenson (1898); Wikipedia (n.d.-a); Joyce/Dayton (n.d.).</a:t>
+              <a:t>Šaltiniai: Stevenson (1898); Wikipedia (n.d.-b); Joyce/Dayton (n.d.).</a:t>
             </a:r>
           </a:p>
         </p:txBody>
@@ -9541,7 +10236,7 @@
                 </a:solidFill>
                 <a:latin typeface="Calibri"/>
               </a:rPr>
-              <a:t>Kiti domkratų tipai</a:t>
+              <a:t>Pritaikymas: kur naudojami domkratai</a:t>
             </a:r>
           </a:p>
         </p:txBody>
@@ -9677,8 +10372,8 @@
           <p:nvPr/>
         </p:nvGraphicFramePr>
         <p:xfrm>
-          <a:off x="640080" y="1554480"/>
-          <a:ext cx="10881360" cy="3474720"/>
+          <a:off x="640080" y="1463040"/>
+          <a:ext cx="10881360" cy="3968496"/>
         </p:xfrm>
         <a:graphic>
           <a:graphicData uri="http://schemas.openxmlformats.org/drawingml/2006/table">
@@ -9687,25 +10382,24 @@
                 <a:tableStyleId>{5C22544A-7EE6-4342-B048-85BDC9FD1C3A}</a:tableStyleId>
               </a:tblPr>
               <a:tblGrid>
-                <a:gridCol w="2377440"/>
-                <a:gridCol w="1737360"/>
-                <a:gridCol w="3383280"/>
-                <a:gridCol w="3383280"/>
+                <a:gridCol w="2926080"/>
+                <a:gridCol w="3017520"/>
+                <a:gridCol w="4937760"/>
               </a:tblGrid>
-              <a:tr h="868680">
+              <a:tr h="566928">
                 <a:tc>
                   <a:txBody>
                     <a:bodyPr/>
                     <a:lstStyle/>
                     <a:p>
                       <a:r>
-                        <a:rPr sz="1700" b="1" i="0">
+                        <a:rPr sz="1600" b="1" i="0">
                           <a:solidFill>
                             <a:srgbClr val="FFFFFF"/>
                           </a:solidFill>
                           <a:latin typeface="Calibri"/>
                         </a:rPr>
-                        <a:t>Tipas</a:t>
+                        <a:t>Kur naudojama</a:t>
                       </a:r>
                     </a:p>
                   </a:txBody>
@@ -9721,13 +10415,13 @@
                     <a:lstStyle/>
                     <a:p>
                       <a:r>
-                        <a:rPr sz="1700" b="1" i="0">
+                        <a:rPr sz="1600" b="1" i="0">
                           <a:solidFill>
                             <a:srgbClr val="FFFFFF"/>
                           </a:solidFill>
                           <a:latin typeface="Calibri"/>
                         </a:rPr>
-                        <a:t>Atsiradimas</a:t>
+                        <a:t>Domkrato tipas</a:t>
                       </a:r>
                     </a:p>
                   </a:txBody>
@@ -9743,35 +10437,13 @@
                     <a:lstStyle/>
                     <a:p>
                       <a:r>
-                        <a:rPr sz="1700" b="1" i="0">
+                        <a:rPr sz="1600" b="1" i="0">
                           <a:solidFill>
                             <a:srgbClr val="FFFFFF"/>
                           </a:solidFill>
                           <a:latin typeface="Calibri"/>
                         </a:rPr>
-                        <a:t>Privalumai</a:t>
-                      </a:r>
-                    </a:p>
-                  </a:txBody>
-                  <a:tcPr marL="73152" marR="73152" anchor="ctr">
-                    <a:solidFill>
-                      <a:srgbClr val="1F4E79"/>
-                    </a:solidFill>
-                  </a:tcPr>
-                </a:tc>
-                <a:tc>
-                  <a:txBody>
-                    <a:bodyPr/>
-                    <a:lstStyle/>
-                    <a:p>
-                      <a:r>
-                        <a:rPr sz="1700" b="1" i="0">
-                          <a:solidFill>
-                            <a:srgbClr val="FFFFFF"/>
-                          </a:solidFill>
-                          <a:latin typeface="Calibri"/>
-                        </a:rPr>
-                        <a:t>Trūkumai</a:t>
+                        <a:t>Kodėl tinka</a:t>
                       </a:r>
                     </a:p>
                   </a:txBody>
@@ -9782,14 +10454,240 @@
                   </a:tcPr>
                 </a:tc>
               </a:tr>
-              <a:tr h="868680">
+              <a:tr h="566928">
                 <a:tc>
                   <a:txBody>
                     <a:bodyPr/>
                     <a:lstStyle/>
                     <a:p>
                       <a:r>
-                        <a:rPr sz="1700" b="1" i="0">
+                        <a:rPr sz="1600" b="1" i="0">
+                          <a:solidFill>
+                            <a:srgbClr val="222222"/>
+                          </a:solidFill>
+                          <a:latin typeface="Calibri"/>
+                        </a:rPr>
+                        <a:t>Lengvasis automobilis (ratui keisti)</a:t>
+                      </a:r>
+                    </a:p>
+                  </a:txBody>
+                  <a:tcPr marL="73152" marR="73152" anchor="ctr">
+                    <a:solidFill>
+                      <a:srgbClr val="FFFFFF"/>
+                    </a:solidFill>
+                  </a:tcPr>
+                </a:tc>
+                <a:tc>
+                  <a:txBody>
+                    <a:bodyPr/>
+                    <a:lstStyle/>
+                    <a:p>
+                      <a:r>
+                        <a:rPr sz="1600" b="0" i="0">
+                          <a:solidFill>
+                            <a:srgbClr val="222222"/>
+                          </a:solidFill>
+                          <a:latin typeface="Calibri"/>
+                        </a:rPr>
+                        <a:t>Žirklinis</a:t>
+                      </a:r>
+                    </a:p>
+                  </a:txBody>
+                  <a:tcPr marL="73152" marR="73152" anchor="ctr">
+                    <a:solidFill>
+                      <a:srgbClr val="FFFFFF"/>
+                    </a:solidFill>
+                  </a:tcPr>
+                </a:tc>
+                <a:tc>
+                  <a:txBody>
+                    <a:bodyPr/>
+                    <a:lstStyle/>
+                    <a:p>
+                      <a:r>
+                        <a:rPr sz="1600" b="0" i="0">
+                          <a:solidFill>
+                            <a:srgbClr val="222222"/>
+                          </a:solidFill>
+                          <a:latin typeface="Calibri"/>
+                        </a:rPr>
+                        <a:t>Lengvas ir pigus – gamintojai deda į naujus automobilius</a:t>
+                      </a:r>
+                    </a:p>
+                  </a:txBody>
+                  <a:tcPr marL="73152" marR="73152" anchor="ctr">
+                    <a:solidFill>
+                      <a:srgbClr val="FFFFFF"/>
+                    </a:solidFill>
+                  </a:tcPr>
+                </a:tc>
+              </a:tr>
+              <a:tr h="566928">
+                <a:tc>
+                  <a:txBody>
+                    <a:bodyPr/>
+                    <a:lstStyle/>
+                    <a:p>
+                      <a:r>
+                        <a:rPr sz="1600" b="1" i="0">
+                          <a:solidFill>
+                            <a:srgbClr val="222222"/>
+                          </a:solidFill>
+                          <a:latin typeface="Calibri"/>
+                        </a:rPr>
+                        <a:t>Autoservisai ir garažai</a:t>
+                      </a:r>
+                    </a:p>
+                  </a:txBody>
+                  <a:tcPr marL="73152" marR="73152" anchor="ctr">
+                    <a:solidFill>
+                      <a:srgbClr val="FFFFFF"/>
+                    </a:solidFill>
+                  </a:tcPr>
+                </a:tc>
+                <a:tc>
+                  <a:txBody>
+                    <a:bodyPr/>
+                    <a:lstStyle/>
+                    <a:p>
+                      <a:r>
+                        <a:rPr sz="1600" b="0" i="0">
+                          <a:solidFill>
+                            <a:srgbClr val="222222"/>
+                          </a:solidFill>
+                          <a:latin typeface="Calibri"/>
+                        </a:rPr>
+                        <a:t>Vežimėlinis, pneumohidraulinis</a:t>
+                      </a:r>
+                    </a:p>
+                  </a:txBody>
+                  <a:tcPr marL="73152" marR="73152" anchor="ctr">
+                    <a:solidFill>
+                      <a:srgbClr val="FFFFFF"/>
+                    </a:solidFill>
+                  </a:tcPr>
+                </a:tc>
+                <a:tc>
+                  <a:txBody>
+                    <a:bodyPr/>
+                    <a:lstStyle/>
+                    <a:p>
+                      <a:r>
+                        <a:rPr sz="1600" b="0" i="0">
+                          <a:solidFill>
+                            <a:srgbClr val="222222"/>
+                          </a:solidFill>
+                          <a:latin typeface="Calibri"/>
+                        </a:rPr>
+                        <a:t>Greitas ir stabilus; servisuose yra suslėgto oro linija</a:t>
+                      </a:r>
+                    </a:p>
+                  </a:txBody>
+                  <a:tcPr marL="73152" marR="73152" anchor="ctr">
+                    <a:solidFill>
+                      <a:srgbClr val="FFFFFF"/>
+                    </a:solidFill>
+                  </a:tcPr>
+                </a:tc>
+              </a:tr>
+              <a:tr h="566928">
+                <a:tc>
+                  <a:txBody>
+                    <a:bodyPr/>
+                    <a:lstStyle/>
+                    <a:p>
+                      <a:r>
+                        <a:rPr sz="1600" b="1" i="0">
+                          <a:solidFill>
+                            <a:srgbClr val="222222"/>
+                          </a:solidFill>
+                          <a:latin typeface="Calibri"/>
+                        </a:rPr>
+                        <a:t>Sunkvežimiai ir pramonė</a:t>
+                      </a:r>
+                    </a:p>
+                  </a:txBody>
+                  <a:tcPr marL="73152" marR="73152" anchor="ctr">
+                    <a:solidFill>
+                      <a:srgbClr val="FFFFFF"/>
+                    </a:solidFill>
+                  </a:tcPr>
+                </a:tc>
+                <a:tc>
+                  <a:txBody>
+                    <a:bodyPr/>
+                    <a:lstStyle/>
+                    <a:p>
+                      <a:r>
+                        <a:rPr sz="1600" b="0" i="0">
+                          <a:solidFill>
+                            <a:srgbClr val="222222"/>
+                          </a:solidFill>
+                          <a:latin typeface="Calibri"/>
+                        </a:rPr>
+                        <a:t>Hidraulinis butelinis</a:t>
+                      </a:r>
+                    </a:p>
+                  </a:txBody>
+                  <a:tcPr marL="73152" marR="73152" anchor="ctr">
+                    <a:solidFill>
+                      <a:srgbClr val="FFFFFF"/>
+                    </a:solidFill>
+                  </a:tcPr>
+                </a:tc>
+                <a:tc>
+                  <a:txBody>
+                    <a:bodyPr/>
+                    <a:lstStyle/>
+                    <a:p>
+                      <a:r>
+                        <a:rPr sz="1600" b="0" i="0">
+                          <a:solidFill>
+                            <a:srgbClr val="222222"/>
+                          </a:solidFill>
+                          <a:latin typeface="Calibri"/>
+                        </a:rPr>
+                        <a:t>Didelė keliamoji galia – nuo 3 iki 50 t</a:t>
+                      </a:r>
+                    </a:p>
+                  </a:txBody>
+                  <a:tcPr marL="73152" marR="73152" anchor="ctr">
+                    <a:solidFill>
+                      <a:srgbClr val="FFFFFF"/>
+                    </a:solidFill>
+                  </a:tcPr>
+                </a:tc>
+              </a:tr>
+              <a:tr h="566928">
+                <a:tc>
+                  <a:txBody>
+                    <a:bodyPr/>
+                    <a:lstStyle/>
+                    <a:p>
+                      <a:r>
+                        <a:rPr sz="1600" b="1" i="0">
+                          <a:solidFill>
+                            <a:srgbClr val="222222"/>
+                          </a:solidFill>
+                          <a:latin typeface="Calibri"/>
+                        </a:rPr>
+                        <a:t>Visureigiai ir ūkiai</a:t>
+                      </a:r>
+                    </a:p>
+                  </a:txBody>
+                  <a:tcPr marL="73152" marR="73152" anchor="ctr">
+                    <a:solidFill>
+                      <a:srgbClr val="FFFFFF"/>
+                    </a:solidFill>
+                  </a:tcPr>
+                </a:tc>
+                <a:tc>
+                  <a:txBody>
+                    <a:bodyPr/>
+                    <a:lstStyle/>
+                    <a:p>
+                      <a:r>
+                        <a:rPr sz="1600" b="0" i="0">
                           <a:solidFill>
                             <a:srgbClr val="222222"/>
                           </a:solidFill>
@@ -9811,13 +10709,37 @@
                     <a:lstStyle/>
                     <a:p>
                       <a:r>
-                        <a:rPr sz="1700" b="0" i="0">
+                        <a:rPr sz="1600" b="0" i="0">
                           <a:solidFill>
                             <a:srgbClr val="222222"/>
                           </a:solidFill>
                           <a:latin typeface="Calibri"/>
                         </a:rPr>
-                        <a:t>1905 m.</a:t>
+                        <a:t>Kelia labai aukštai, tinka ir traukti, spausti</a:t>
+                      </a:r>
+                    </a:p>
+                  </a:txBody>
+                  <a:tcPr marL="73152" marR="73152" anchor="ctr">
+                    <a:solidFill>
+                      <a:srgbClr val="FFFFFF"/>
+                    </a:solidFill>
+                  </a:tcPr>
+                </a:tc>
+              </a:tr>
+              <a:tr h="566928">
+                <a:tc>
+                  <a:txBody>
+                    <a:bodyPr/>
+                    <a:lstStyle/>
+                    <a:p>
+                      <a:r>
+                        <a:rPr sz="1600" b="1" i="0">
+                          <a:solidFill>
+                            <a:srgbClr val="222222"/>
+                          </a:solidFill>
+                          <a:latin typeface="Calibri"/>
+                        </a:rPr>
+                        <a:t>Statyba ir sunkūs kroviniai</a:t>
                       </a:r>
                     </a:p>
                   </a:txBody>
@@ -9833,13 +10755,13 @@
                     <a:lstStyle/>
                     <a:p>
                       <a:r>
-                        <a:rPr sz="1700" b="0" i="0">
+                        <a:rPr sz="1600" b="0" i="0">
                           <a:solidFill>
                             <a:srgbClr val="222222"/>
                           </a:solidFill>
                           <a:latin typeface="Calibri"/>
                         </a:rPr>
-                        <a:t>Kelia labai aukštai (iki ~1,5 m), tinka ir traukti, spausti</a:t>
+                        <a:t>Hidraulinės kėlimo sistemos</a:t>
                       </a:r>
                     </a:p>
                   </a:txBody>
@@ -9855,13 +10777,13 @@
                     <a:lstStyle/>
                     <a:p>
                       <a:r>
-                        <a:rPr sz="1700" b="0" i="0">
+                        <a:rPr sz="1600" b="0" i="0">
                           <a:solidFill>
                             <a:srgbClr val="222222"/>
                           </a:solidFill>
                           <a:latin typeface="Calibri"/>
                         </a:rPr>
-                        <a:t>Pavojinga rankenos atatranka, mažiau stabilus</a:t>
+                        <a:t>Daug domkratų kartu kelia didelius objektus</a:t>
                       </a:r>
                     </a:p>
                   </a:txBody>
@@ -9872,20 +10794,20 @@
                   </a:tcPr>
                 </a:tc>
               </a:tr>
-              <a:tr h="868680">
+              <a:tr h="566928">
                 <a:tc>
                   <a:txBody>
                     <a:bodyPr/>
                     <a:lstStyle/>
                     <a:p>
                       <a:r>
-                        <a:rPr sz="1700" b="1" i="0">
+                        <a:rPr sz="1600" b="1" i="0">
                           <a:solidFill>
                             <a:srgbClr val="222222"/>
                           </a:solidFill>
                           <a:latin typeface="Calibri"/>
                         </a:rPr>
-                        <a:t>Vežimėlinis (garažinis)</a:t>
+                        <a:t>Kas nenori sukti rankenos</a:t>
                       </a:r>
                     </a:p>
                   </a:txBody>
@@ -9901,75 +10823,7 @@
                     <a:lstStyle/>
                     <a:p>
                       <a:r>
-                        <a:rPr sz="1700" b="0" i="0">
-                          <a:solidFill>
-                            <a:srgbClr val="222222"/>
-                          </a:solidFill>
-                          <a:latin typeface="Calibri"/>
-                        </a:rPr>
-                        <a:t>1910 m. mechaninis, 1928 m. hidraulinis</a:t>
-                      </a:r>
-                    </a:p>
-                  </a:txBody>
-                  <a:tcPr marL="73152" marR="73152" anchor="ctr">
-                    <a:solidFill>
-                      <a:srgbClr val="FFFFFF"/>
-                    </a:solidFill>
-                  </a:tcPr>
-                </a:tc>
-                <a:tc>
-                  <a:txBody>
-                    <a:bodyPr/>
-                    <a:lstStyle/>
-                    <a:p>
-                      <a:r>
-                        <a:rPr sz="1700" b="0" i="0">
-                          <a:solidFill>
-                            <a:srgbClr val="222222"/>
-                          </a:solidFill>
-                          <a:latin typeface="Calibri"/>
-                        </a:rPr>
-                        <a:t>Greitas ir stabilus, platus pagrindas</a:t>
-                      </a:r>
-                    </a:p>
-                  </a:txBody>
-                  <a:tcPr marL="73152" marR="73152" anchor="ctr">
-                    <a:solidFill>
-                      <a:srgbClr val="FFFFFF"/>
-                    </a:solidFill>
-                  </a:tcPr>
-                </a:tc>
-                <a:tc>
-                  <a:txBody>
-                    <a:bodyPr/>
-                    <a:lstStyle/>
-                    <a:p>
-                      <a:r>
-                        <a:rPr sz="1700" b="0" i="0">
-                          <a:solidFill>
-                            <a:srgbClr val="222222"/>
-                          </a:solidFill>
-                          <a:latin typeface="Calibri"/>
-                        </a:rPr>
-                        <a:t>Didelis ir sunkus, sunku pernešti</a:t>
-                      </a:r>
-                    </a:p>
-                  </a:txBody>
-                  <a:tcPr marL="73152" marR="73152" anchor="ctr">
-                    <a:solidFill>
-                      <a:srgbClr val="FFFFFF"/>
-                    </a:solidFill>
-                  </a:tcPr>
-                </a:tc>
-              </a:tr>
-              <a:tr h="868680">
-                <a:tc>
-                  <a:txBody>
-                    <a:bodyPr/>
-                    <a:lstStyle/>
-                    <a:p>
-                      <a:r>
-                        <a:rPr sz="1700" b="1" i="0">
+                        <a:rPr sz="1600" b="0" i="0">
                           <a:solidFill>
                             <a:srgbClr val="222222"/>
                           </a:solidFill>
@@ -9991,29 +10845,7 @@
                     <a:lstStyle/>
                     <a:p>
                       <a:r>
-                        <a:rPr sz="1700" b="0" i="0">
-                          <a:solidFill>
-                            <a:srgbClr val="222222"/>
-                          </a:solidFill>
-                          <a:latin typeface="Calibri"/>
-                        </a:rPr>
-                        <a:t>2004 m. (patentas)</a:t>
-                      </a:r>
-                    </a:p>
-                  </a:txBody>
-                  <a:tcPr marL="73152" marR="73152" anchor="ctr">
-                    <a:solidFill>
-                      <a:srgbClr val="FFFFFF"/>
-                    </a:solidFill>
-                  </a:tcPr>
-                </a:tc>
-                <a:tc>
-                  <a:txBody>
-                    <a:bodyPr/>
-                    <a:lstStyle/>
-                    <a:p>
-                      <a:r>
-                        <a:rPr sz="1700" b="0" i="0">
+                        <a:rPr sz="1600" b="0" i="0">
                           <a:solidFill>
                             <a:srgbClr val="222222"/>
                           </a:solidFill>
@@ -10029,28 +10861,6 @@
                     </a:solidFill>
                   </a:tcPr>
                 </a:tc>
-                <a:tc>
-                  <a:txBody>
-                    <a:bodyPr/>
-                    <a:lstStyle/>
-                    <a:p>
-                      <a:r>
-                        <a:rPr sz="1700" b="0" i="0">
-                          <a:solidFill>
-                            <a:srgbClr val="222222"/>
-                          </a:solidFill>
-                          <a:latin typeface="Calibri"/>
-                        </a:rPr>
-                        <a:t>Reikia elektros, brangesnis ir sunkesnis</a:t>
-                      </a:r>
-                    </a:p>
-                  </a:txBody>
-                  <a:tcPr marL="73152" marR="73152" anchor="ctr">
-                    <a:solidFill>
-                      <a:srgbClr val="FFFFFF"/>
-                    </a:solidFill>
-                  </a:tcPr>
-                </a:tc>
               </a:tr>
             </a:tbl>
           </a:graphicData>
@@ -10064,7 +10874,7 @@
         </p:nvSpPr>
         <p:spPr>
           <a:xfrm>
-            <a:off x="640080" y="5760720"/>
+            <a:off x="640080" y="5897880"/>
             <a:ext cx="10881360" cy="457200"/>
           </a:xfrm>
           <a:prstGeom prst="rect">
@@ -10090,7 +10900,7 @@
                 </a:solidFill>
                 <a:latin typeface="Calibri"/>
               </a:rPr>
-              <a:t>Šaltiniai: Hi-Lift Jack Company (n.d.-a, n.d.-b); CJ Pony Parts (n.d.); Castle Equipment (n.d.); Redline Stands (n.d.); Mickael (2004); Pro-Lift-Montagetechnik (n.d.).</a:t>
+              <a:t>Šaltiniai: CJ Pony Parts (n.d.); Juds (1967); Hi-Lift Jack Company (n.d.-a); Richard Dudgeon, Inc. (n.d.); Pro-Lift-Montagetechnik (n.d.).</a:t>
             </a:r>
           </a:p>
         </p:txBody>
@@ -10147,7 +10957,7 @@
                 </a:solidFill>
                 <a:latin typeface="Calibri"/>
               </a:rPr>
-              <a:t>Ką siūlome patobulinti</a:t>
+              <a:t>Kompanijos, kūrusios domkratus</a:t>
             </a:r>
           </a:p>
         </p:txBody>
@@ -10274,109 +11084,17 @@
           </a:p>
         </p:txBody>
       </p:sp>
-      <p:sp>
-        <p:nvSpPr>
-          <p:cNvPr id="6" name="Rectangle 5"/>
-          <p:cNvSpPr/>
-          <p:nvPr/>
-        </p:nvSpPr>
-        <p:spPr>
-          <a:xfrm>
-            <a:off x="640080" y="1463040"/>
-            <a:ext cx="10881360" cy="914400"/>
-          </a:xfrm>
-          <a:prstGeom prst="rect">
-            <a:avLst/>
-          </a:prstGeom>
-          <a:solidFill>
-            <a:srgbClr val="DEEAF6"/>
-          </a:solidFill>
-          <a:ln>
-            <a:noFill/>
-          </a:ln>
-          <a:effectLst/>
-        </p:spPr>
-        <p:style>
-          <a:lnRef idx="1">
-            <a:schemeClr val="accent1"/>
-          </a:lnRef>
-          <a:fillRef idx="3">
-            <a:schemeClr val="accent1"/>
-          </a:fillRef>
-          <a:effectRef idx="2">
-            <a:schemeClr val="accent1"/>
-          </a:effectRef>
-          <a:fontRef idx="minor">
-            <a:schemeClr val="lt1"/>
-          </a:fontRef>
-        </p:style>
-        <p:txBody>
-          <a:bodyPr rtlCol="0" anchor="ctr"/>
-          <a:lstStyle/>
-          <a:p>
-            <a:pPr algn="ctr"/>
-          </a:p>
-        </p:txBody>
-      </p:sp>
-      <p:sp>
-        <p:nvSpPr>
-          <p:cNvPr id="7" name="TextBox 6"/>
-          <p:cNvSpPr txBox="1"/>
-          <p:nvPr/>
-        </p:nvSpPr>
-        <p:spPr>
-          <a:xfrm>
-            <a:off x="822960" y="1508760"/>
-            <a:ext cx="10515600" cy="822960"/>
-          </a:xfrm>
-          <a:prstGeom prst="rect">
-            <a:avLst/>
-          </a:prstGeom>
-          <a:noFill/>
-        </p:spPr>
-        <p:txBody>
-          <a:bodyPr wrap="square" anchor="ctr" lIns="45720" rIns="45720">
-            <a:spAutoFit/>
-          </a:bodyPr>
-          <a:lstStyle/>
-          <a:p>
-            <a:pPr algn="l">
-              <a:spcAft>
-                <a:spcPts val="600"/>
-              </a:spcAft>
-            </a:pPr>
-            <a:r>
-              <a:rPr sz="1900" b="1">
-                <a:solidFill>
-                  <a:srgbClr val="1F4E79"/>
-                </a:solidFill>
-                <a:latin typeface="Calibri"/>
-              </a:rPr>
-              <a:t>Tikslas: </a:t>
-            </a:r>
-            <a:r>
-              <a:rPr sz="1900" b="0" i="0">
-                <a:solidFill>
-                  <a:srgbClr val="222222"/>
-                </a:solidFill>
-                <a:latin typeface="Calibri"/>
-              </a:rPr>
-              <a:t>žirklinis domkratas, kuris stabiliai stovi ant nelygaus pagrindo, mažiau dyla ir yra patogiau sukamas.</a:t>
-            </a:r>
-          </a:p>
-        </p:txBody>
-      </p:sp>
       <p:graphicFrame>
         <p:nvGraphicFramePr>
-          <p:cNvPr id="8" name="Table 7"/>
+          <p:cNvPr id="6" name="Table 5"/>
           <p:cNvGraphicFramePr>
             <a:graphicFrameLocks noGrp="1"/>
           </p:cNvGraphicFramePr>
           <p:nvPr/>
         </p:nvGraphicFramePr>
         <p:xfrm>
-          <a:off x="640080" y="2606040"/>
-          <a:ext cx="10881360" cy="2834640"/>
+          <a:off x="640080" y="1463040"/>
+          <a:ext cx="10881360" cy="3950208"/>
         </p:xfrm>
         <a:graphic>
           <a:graphicData uri="http://schemas.openxmlformats.org/drawingml/2006/table">
@@ -10385,11 +11103,12 @@
                 <a:tableStyleId>{5C22544A-7EE6-4342-B048-85BDC9FD1C3A}</a:tableStyleId>
               </a:tblPr>
               <a:tblGrid>
-                <a:gridCol w="2194560"/>
-                <a:gridCol w="4206240"/>
-                <a:gridCol w="4480560"/>
+                <a:gridCol w="2743200"/>
+                <a:gridCol w="1554480"/>
+                <a:gridCol w="4023360"/>
+                <a:gridCol w="2560320"/>
               </a:tblGrid>
-              <a:tr h="566928">
+              <a:tr h="658368">
                 <a:tc>
                   <a:txBody>
                     <a:bodyPr/>
@@ -10402,7 +11121,7 @@
                           </a:solidFill>
                           <a:latin typeface="Calibri"/>
                         </a:rPr>
-                        <a:t>Elementas</a:t>
+                        <a:t>Kompanija</a:t>
                       </a:r>
                     </a:p>
                   </a:txBody>
@@ -10424,7 +11143,7 @@
                           </a:solidFill>
                           <a:latin typeface="Calibri"/>
                         </a:rPr>
-                        <a:t>Ką keičiame</a:t>
+                        <a:t>Įkurta</a:t>
                       </a:r>
                     </a:p>
                   </a:txBody>
@@ -10446,7 +11165,29 @@
                           </a:solidFill>
                           <a:latin typeface="Calibri"/>
                         </a:rPr>
-                        <a:t>Kodėl</a:t>
+                        <a:t>Ką sukūrė</a:t>
+                      </a:r>
+                    </a:p>
+                  </a:txBody>
+                  <a:tcPr marL="73152" marR="73152" anchor="ctr">
+                    <a:solidFill>
+                      <a:srgbClr val="1F4E79"/>
+                    </a:solidFill>
+                  </a:tcPr>
+                </a:tc>
+                <a:tc>
+                  <a:txBody>
+                    <a:bodyPr/>
+                    <a:lstStyle/>
+                    <a:p>
+                      <a:r>
+                        <a:rPr sz="1600" b="1" i="0">
+                          <a:solidFill>
+                            <a:srgbClr val="FFFFFF"/>
+                          </a:solidFill>
+                          <a:latin typeface="Calibri"/>
+                        </a:rPr>
+                        <a:t>Šiandien</a:t>
                       </a:r>
                     </a:p>
                   </a:txBody>
@@ -10457,7 +11198,7 @@
                   </a:tcPr>
                 </a:tc>
               </a:tr>
-              <a:tr h="566928">
+              <a:tr h="658368">
                 <a:tc>
                   <a:txBody>
                     <a:bodyPr/>
@@ -10470,7 +11211,7 @@
                           </a:solidFill>
                           <a:latin typeface="Calibri"/>
                         </a:rPr>
-                        <a:t>Pagrindas</a:t>
+                        <a:t>Richard Dudgeon, Inc. (Niujorkas)</a:t>
                       </a:r>
                     </a:p>
                   </a:txBody>
@@ -10492,7 +11233,7 @@
                           </a:solidFill>
                           <a:latin typeface="Calibri"/>
                         </a:rPr>
-                        <a:t>Platesnis, su guminiu padu</a:t>
+                        <a:t>1849 m.</a:t>
                       </a:r>
                     </a:p>
                   </a:txBody>
@@ -10514,31 +11255,7 @@
                           </a:solidFill>
                           <a:latin typeface="Calibri"/>
                         </a:rPr>
-                        <a:t>Neslysta ir nesmenga į minkštą paviršių</a:t>
-                      </a:r>
-                    </a:p>
-                  </a:txBody>
-                  <a:tcPr marL="73152" marR="73152" anchor="ctr">
-                    <a:solidFill>
-                      <a:srgbClr val="FFFFFF"/>
-                    </a:solidFill>
-                  </a:tcPr>
-                </a:tc>
-              </a:tr>
-              <a:tr h="566928">
-                <a:tc>
-                  <a:txBody>
-                    <a:bodyPr/>
-                    <a:lstStyle/>
-                    <a:p>
-                      <a:r>
-                        <a:rPr sz="1600" b="1" i="0">
-                          <a:solidFill>
-                            <a:srgbClr val="222222"/>
-                          </a:solidFill>
-                          <a:latin typeface="Calibri"/>
-                        </a:rPr>
-                        <a:t>Sraigtas ir veržlė</a:t>
+                        <a:t>Pirmasis nešiojamas hidraulinis domkratas (1851 m.)</a:t>
                       </a:r>
                     </a:p>
                   </a:txBody>
@@ -10560,7 +11277,31 @@
                           </a:solidFill>
                           <a:latin typeface="Calibri"/>
                         </a:rPr>
-                        <a:t>Trapecinis sraigtas iš plieno 42CrMo4, veržlė iš bronzos CuSn12</a:t>
+                        <a:t>Tebeveikia (Konektikutas)</a:t>
+                      </a:r>
+                    </a:p>
+                  </a:txBody>
+                  <a:tcPr marL="73152" marR="73152" anchor="ctr">
+                    <a:solidFill>
+                      <a:srgbClr val="FFFFFF"/>
+                    </a:solidFill>
+                  </a:tcPr>
+                </a:tc>
+              </a:tr>
+              <a:tr h="658368">
+                <a:tc>
+                  <a:txBody>
+                    <a:bodyPr/>
+                    <a:lstStyle/>
+                    <a:p>
+                      <a:r>
+                        <a:rPr sz="1600" b="1" i="0">
+                          <a:solidFill>
+                            <a:srgbClr val="222222"/>
+                          </a:solidFill>
+                          <a:latin typeface="Calibri"/>
+                        </a:rPr>
+                        <a:t>Hi-Lift Jack Company (Indiana)</a:t>
                       </a:r>
                     </a:p>
                   </a:txBody>
@@ -10582,31 +11323,7 @@
                           </a:solidFill>
                           <a:latin typeface="Calibri"/>
                         </a:rPr>
-                        <a:t>Savistabdis, mažiau dyla, maža trintis</a:t>
-                      </a:r>
-                    </a:p>
-                  </a:txBody>
-                  <a:tcPr marL="73152" marR="73152" anchor="ctr">
-                    <a:solidFill>
-                      <a:srgbClr val="FFFFFF"/>
-                    </a:solidFill>
-                  </a:tcPr>
-                </a:tc>
-              </a:tr>
-              <a:tr h="566928">
-                <a:tc>
-                  <a:txBody>
-                    <a:bodyPr/>
-                    <a:lstStyle/>
-                    <a:p>
-                      <a:r>
-                        <a:rPr sz="1600" b="1" i="0">
-                          <a:solidFill>
-                            <a:srgbClr val="222222"/>
-                          </a:solidFill>
-                          <a:latin typeface="Calibri"/>
-                        </a:rPr>
-                        <a:t>Svirtys</a:t>
+                        <a:t>1895 m.</a:t>
                       </a:r>
                     </a:p>
                   </a:txBody>
@@ -10628,7 +11345,7 @@
                           </a:solidFill>
                           <a:latin typeface="Calibri"/>
                         </a:rPr>
-                        <a:t>Plienas S420MC vietoj S235</a:t>
+                        <a:t>Krumpliastiebinis „Hi-Lift“ domkratas (1905 m.)</a:t>
                       </a:r>
                     </a:p>
                   </a:txBody>
@@ -10650,7 +11367,7 @@
                           </a:solidFill>
                           <a:latin typeface="Calibri"/>
                         </a:rPr>
-                        <a:t>Takumo riba 420 vs 235 MPa – apie 1,8 karto stipresnės</a:t>
+                        <a:t>Gamina iki šiol</a:t>
                       </a:r>
                     </a:p>
                   </a:txBody>
@@ -10661,7 +11378,7 @@
                   </a:tcPr>
                 </a:tc>
               </a:tr>
-              <a:tr h="566928">
+              <a:tr h="658368">
                 <a:tc>
                   <a:txBody>
                     <a:bodyPr/>
@@ -10674,7 +11391,7 @@
                           </a:solidFill>
                           <a:latin typeface="Calibri"/>
                         </a:rPr>
-                        <a:t>Rankena</a:t>
+                        <a:t>Weaver Manufacturing</a:t>
                       </a:r>
                     </a:p>
                   </a:txBody>
@@ -10696,7 +11413,7 @@
                           </a:solidFill>
                           <a:latin typeface="Calibri"/>
                         </a:rPr>
-                        <a:t>Ilgesnė, sulankstoma rankena</a:t>
+                        <a:t>—</a:t>
                       </a:r>
                     </a:p>
                   </a:txBody>
@@ -10718,7 +11435,209 @@
                           </a:solidFill>
                           <a:latin typeface="Calibri"/>
                         </a:rPr>
-                        <a:t>Sukti galima nesilenkiant prie pat rato (mūsų idėja)</a:t>
+                        <a:t>Vežimėlinis „Auto-Twin“ (1910 m.), pirmasis hidraulinis (1928 m.)</a:t>
+                      </a:r>
+                    </a:p>
+                  </a:txBody>
+                  <a:tcPr marL="73152" marR="73152" anchor="ctr">
+                    <a:solidFill>
+                      <a:srgbClr val="FFFFFF"/>
+                    </a:solidFill>
+                  </a:tcPr>
+                </a:tc>
+                <a:tc>
+                  <a:txBody>
+                    <a:bodyPr/>
+                    <a:lstStyle/>
+                    <a:p>
+                      <a:r>
+                        <a:rPr sz="1600" b="0" i="0">
+                          <a:solidFill>
+                            <a:srgbClr val="222222"/>
+                          </a:solidFill>
+                          <a:latin typeface="Calibri"/>
+                        </a:rPr>
+                        <a:t>—</a:t>
+                      </a:r>
+                    </a:p>
+                  </a:txBody>
+                  <a:tcPr marL="73152" marR="73152" anchor="ctr">
+                    <a:solidFill>
+                      <a:srgbClr val="FFFFFF"/>
+                    </a:solidFill>
+                  </a:tcPr>
+                </a:tc>
+              </a:tr>
+              <a:tr h="658368">
+                <a:tc>
+                  <a:txBody>
+                    <a:bodyPr/>
+                    <a:lstStyle/>
+                    <a:p>
+                      <a:r>
+                        <a:rPr sz="1600" b="1" i="0">
+                          <a:solidFill>
+                            <a:srgbClr val="222222"/>
+                          </a:solidFill>
+                          <a:latin typeface="Calibri"/>
+                        </a:rPr>
+                        <a:t>Blackhawk (Milvokis)</a:t>
+                      </a:r>
+                    </a:p>
+                  </a:txBody>
+                  <a:tcPr marL="73152" marR="73152" anchor="ctr">
+                    <a:solidFill>
+                      <a:srgbClr val="FFFFFF"/>
+                    </a:solidFill>
+                  </a:tcPr>
+                </a:tc>
+                <a:tc>
+                  <a:txBody>
+                    <a:bodyPr/>
+                    <a:lstStyle/>
+                    <a:p>
+                      <a:r>
+                        <a:rPr sz="1600" b="0" i="0">
+                          <a:solidFill>
+                            <a:srgbClr val="222222"/>
+                          </a:solidFill>
+                          <a:latin typeface="Calibri"/>
+                        </a:rPr>
+                        <a:t>1919 m.</a:t>
+                      </a:r>
+                    </a:p>
+                  </a:txBody>
+                  <a:tcPr marL="73152" marR="73152" anchor="ctr">
+                    <a:solidFill>
+                      <a:srgbClr val="FFFFFF"/>
+                    </a:solidFill>
+                  </a:tcPr>
+                </a:tc>
+                <a:tc>
+                  <a:txBody>
+                    <a:bodyPr/>
+                    <a:lstStyle/>
+                    <a:p>
+                      <a:r>
+                        <a:rPr sz="1600" b="0" i="0">
+                          <a:solidFill>
+                            <a:srgbClr val="222222"/>
+                          </a:solidFill>
+                          <a:latin typeface="Calibri"/>
+                        </a:rPr>
+                        <a:t>Įrankiai ir vežimėliniai domkratai</a:t>
+                      </a:r>
+                    </a:p>
+                  </a:txBody>
+                  <a:tcPr marL="73152" marR="73152" anchor="ctr">
+                    <a:solidFill>
+                      <a:srgbClr val="FFFFFF"/>
+                    </a:solidFill>
+                  </a:tcPr>
+                </a:tc>
+                <a:tc>
+                  <a:txBody>
+                    <a:bodyPr/>
+                    <a:lstStyle/>
+                    <a:p>
+                      <a:r>
+                        <a:rPr sz="1600" b="0" i="0">
+                          <a:solidFill>
+                            <a:srgbClr val="222222"/>
+                          </a:solidFill>
+                          <a:latin typeface="Calibri"/>
+                        </a:rPr>
+                        <a:t>Prekės ženklas priklauso Stanley</a:t>
+                      </a:r>
+                    </a:p>
+                  </a:txBody>
+                  <a:tcPr marL="73152" marR="73152" anchor="ctr">
+                    <a:solidFill>
+                      <a:srgbClr val="FFFFFF"/>
+                    </a:solidFill>
+                  </a:tcPr>
+                </a:tc>
+              </a:tr>
+              <a:tr h="658368">
+                <a:tc>
+                  <a:txBody>
+                    <a:bodyPr/>
+                    <a:lstStyle/>
+                    <a:p>
+                      <a:r>
+                        <a:rPr sz="1600" b="1" i="0">
+                          <a:solidFill>
+                            <a:srgbClr val="222222"/>
+                          </a:solidFill>
+                          <a:latin typeface="Calibri"/>
+                        </a:rPr>
+                        <a:t>Milwaukee Hydraulic Products</a:t>
+                      </a:r>
+                    </a:p>
+                  </a:txBody>
+                  <a:tcPr marL="73152" marR="73152" anchor="ctr">
+                    <a:solidFill>
+                      <a:srgbClr val="FFFFFF"/>
+                    </a:solidFill>
+                  </a:tcPr>
+                </a:tc>
+                <a:tc>
+                  <a:txBody>
+                    <a:bodyPr/>
+                    <a:lstStyle/>
+                    <a:p>
+                      <a:r>
+                        <a:rPr sz="1600" b="0" i="0">
+                          <a:solidFill>
+                            <a:srgbClr val="222222"/>
+                          </a:solidFill>
+                          <a:latin typeface="Calibri"/>
+                        </a:rPr>
+                        <a:t>—</a:t>
+                      </a:r>
+                    </a:p>
+                  </a:txBody>
+                  <a:tcPr marL="73152" marR="73152" anchor="ctr">
+                    <a:solidFill>
+                      <a:srgbClr val="FFFFFF"/>
+                    </a:solidFill>
+                  </a:tcPr>
+                </a:tc>
+                <a:tc>
+                  <a:txBody>
+                    <a:bodyPr/>
+                    <a:lstStyle/>
+                    <a:p>
+                      <a:r>
+                        <a:rPr sz="1600" b="0" i="0">
+                          <a:solidFill>
+                            <a:srgbClr val="222222"/>
+                          </a:solidFill>
+                          <a:latin typeface="Calibri"/>
+                        </a:rPr>
+                        <a:t>Kombinuotas pneumohidraulinis domkratas (1967 m. patentas)</a:t>
+                      </a:r>
+                    </a:p>
+                  </a:txBody>
+                  <a:tcPr marL="73152" marR="73152" anchor="ctr">
+                    <a:solidFill>
+                      <a:srgbClr val="FFFFFF"/>
+                    </a:solidFill>
+                  </a:tcPr>
+                </a:tc>
+                <a:tc>
+                  <a:txBody>
+                    <a:bodyPr/>
+                    <a:lstStyle/>
+                    <a:p>
+                      <a:r>
+                        <a:rPr sz="1600" b="0" i="0">
+                          <a:solidFill>
+                            <a:srgbClr val="222222"/>
+                          </a:solidFill>
+                          <a:latin typeface="Calibri"/>
+                        </a:rPr>
+                        <a:t>—</a:t>
                       </a:r>
                     </a:p>
                   </a:txBody>
@@ -10735,7 +11654,7 @@
       </p:graphicFrame>
       <p:sp>
         <p:nvSpPr>
-          <p:cNvPr id="9" name="TextBox 8"/>
+          <p:cNvPr id="7" name="TextBox 6"/>
           <p:cNvSpPr txBox="1"/>
           <p:nvPr/>
         </p:nvSpPr>
@@ -10767,7 +11686,7 @@
                 </a:solidFill>
                 <a:latin typeface="Calibri"/>
               </a:rPr>
-              <a:t>Šaltiniai: Roton Products (n.d.); Sider Ticino (n.d.); Hengli Automation (n.d.); Gnee Steel (n.d.); The World Material (n.d.); CN Trailer Parts (n.d.).</a:t>
+              <a:t>Šaltiniai: Wikipedia (n.d.-c); Richard Dudgeon, Inc. (n.d.); Hi-Lift Jack Company (n.d.-a); Castle Equipment (n.d.); Wikipedia (n.d.-a); Juds (1967).</a:t>
             </a:r>
           </a:p>
         </p:txBody>

</xml_diff>